<commit_message>
Pivot the story to Moment: hypothesis sweep (question.js), research.json with verdicts + pushback, page ends in a live one-minute Moment, deck rebuilt
Co-Authored-By: Claude Fable 5 <noreply@anthropic.com>
</commit_message>
<xml_diff>
--- a/docs/first-breath-how-it-works.pptx
+++ b/docs/first-breath-how-it-works.pptx
@@ -739,7 +739,7 @@
           <a:p>
             <a:r>
               <a:rPr lang="en-US" dirty="0"/>
-              <a:t>I teach meditation the pragmatic way: start a timer, count your breaths. This is the story of how I proved the world wants that — with data, not opinion.</a:t>
+              <a:t>Open with the pain in one breath: you meditate, you feel calm, then you snap at the same message. Then: I built Moment for that — and before pitching it, I tried to prove myself wrong.</a:t>
             </a:r>
             <a:endParaRPr lang="en-US" dirty="0"/>
           </a:p>
@@ -915,7 +915,7 @@
           <a:p>
             <a:r>
               <a:rPr lang="en-US" dirty="0"/>
-              <a:t>Be explicit that this slide is a claim, not data. The next slides are where the data comes in.</a:t>
+              <a:t/>
             </a:r>
             <a:endParaRPr lang="en-US" dirty="0"/>
           </a:p>
@@ -1531,7 +1531,7 @@
           <a:p>
             <a:r>
               <a:rPr lang="en-US" dirty="0"/>
-              <a:t>Switch to the live page here. Scroll the story, then run the ten-breath timer with the room.</a:t>
+              <a:t>Switch to the live page here. Scroll the story, then type an intention and run the one-minute Moment with the room.</a:t>
             </a:r>
             <a:endParaRPr lang="en-US" dirty="0"/>
           </a:p>
@@ -1989,7 +1989,7 @@
                 <a:ea typeface="Cambria" pitchFamily="34" charset="-122"/>
                 <a:cs typeface="Cambria" pitchFamily="34" charset="-120"/>
               </a:rPr>
-              <a:t>First Breath</a:t>
+              <a:t>Moment</a:t>
             </a:r>
             <a:endParaRPr lang="en-US" sz="4800" dirty="0"/>
           </a:p>
@@ -2028,7 +2028,7 @@
                 <a:ea typeface="Cambria" pitchFamily="34" charset="-122"/>
                 <a:cs typeface="Cambria" pitchFamily="34" charset="-120"/>
               </a:rPr>
-              <a:t>A pain. A proof. A fix.</a:t>
+              <a:t>I had a hypothesis. I asked the web to break it.</a:t>
             </a:r>
             <a:endParaRPr lang="en-US" sz="2000" dirty="0"/>
           </a:p>
@@ -2067,7 +2067,7 @@
                 <a:ea typeface="Calibri" pitchFamily="34" charset="-122"/>
                 <a:cs typeface="Calibri" pitchFamily="34" charset="-120"/>
               </a:rPr>
-              <a:t>How I used the web to prove meditation apps have lost the plot — and what I built instead</a:t>
+              <a:t>Meditation inside the day, not beside it — and what Bright Data said about that</a:t>
             </a:r>
             <a:endParaRPr lang="en-US" sz="1300" dirty="0"/>
           </a:p>
@@ -2106,7 +2106,7 @@
                 <a:ea typeface="Courier New" pitchFamily="34" charset="-122"/>
                 <a:cs typeface="Courier New" pitchFamily="34" charset="-120"/>
               </a:rPr>
-              <a:t>BRIGHT DATA GTM EVENT · AUG 22, 2026 · KEW</a:t>
+              <a:t>BRIGHT DATA GTM EVENT · AUG 22, 2026 · KEW · MOMENT.SZLEZINGIER.COM</a:t>
             </a:r>
             <a:endParaRPr lang="en-US" sz="900" dirty="0"/>
           </a:p>
@@ -2204,8 +2204,8 @@
         </p:nvSpPr>
         <p:spPr>
           <a:xfrm>
-            <a:off x="731520" y="2194560"/>
-            <a:ext cx="7680960" cy="1005840"/>
+            <a:off x="731520" y="2103120"/>
+            <a:ext cx="7680960" cy="1097280"/>
           </a:xfrm>
           <a:prstGeom prst="rect">
             <a:avLst/>
@@ -2229,46 +2229,63 @@
                 <a:ea typeface="Cambria" pitchFamily="34" charset="-122"/>
                 <a:cs typeface="Cambria" pitchFamily="34" charset="-120"/>
               </a:rPr>
-              <a:t>Stop guessing. Let the web show you the way.</a:t>
+              <a:t>Stop defending your idea.</a:t>
             </a:r>
             <a:endParaRPr lang="en-US" sz="2800" dirty="0"/>
           </a:p>
-        </p:txBody>
-      </p:sp>
-      <p:sp>
-        <p:nvSpPr>
-          <p:cNvPr id="5" name="Text 3"/>
-          <p:cNvSpPr/>
-          <p:nvPr/>
-        </p:nvSpPr>
-        <p:spPr>
-          <a:xfrm>
-            <a:off x="731520" y="3291840"/>
-            <a:ext cx="7680960" cy="457200"/>
-          </a:xfrm>
-          <a:prstGeom prst="rect">
-            <a:avLst/>
-          </a:prstGeom>
-          <a:noFill/>
-          <a:ln/>
-        </p:spPr>
-        <p:txBody>
-          <a:bodyPr wrap="square" lIns="0" tIns="0" rIns="0" bIns="0" rtlCol="0" anchor="ctr"/>
-          <a:lstStyle/>
           <a:p>
             <a:pPr algn="ctr" indent="0" marL="0">
               <a:buNone/>
             </a:pPr>
             <a:r>
-              <a:rPr lang="en-US" sz="1800" i="1" dirty="0">
-                <a:solidFill>
-                  <a:srgbClr val="D9954A"/>
+              <a:rPr lang="en-US" sz="2800" dirty="0">
+                <a:solidFill>
+                  <a:srgbClr val="EDE4D7"/>
                 </a:solidFill>
                 <a:latin typeface="Cambria" pitchFamily="34" charset="0"/>
                 <a:ea typeface="Cambria" pitchFamily="34" charset="-122"/>
                 <a:cs typeface="Cambria" pitchFamily="34" charset="-120"/>
               </a:rPr>
-              <a:t>Now — ten breaths.</a:t>
+              <a:t>Let the web try to break it.</a:t>
+            </a:r>
+            <a:endParaRPr lang="en-US" sz="2800" dirty="0"/>
+          </a:p>
+        </p:txBody>
+      </p:sp>
+      <p:sp>
+        <p:nvSpPr>
+          <p:cNvPr id="5" name="Text 3"/>
+          <p:cNvSpPr/>
+          <p:nvPr/>
+        </p:nvSpPr>
+        <p:spPr>
+          <a:xfrm>
+            <a:off x="731520" y="3291840"/>
+            <a:ext cx="7680960" cy="457200"/>
+          </a:xfrm>
+          <a:prstGeom prst="rect">
+            <a:avLst/>
+          </a:prstGeom>
+          <a:noFill/>
+          <a:ln/>
+        </p:spPr>
+        <p:txBody>
+          <a:bodyPr wrap="square" lIns="0" tIns="0" rIns="0" bIns="0" rtlCol="0" anchor="ctr"/>
+          <a:lstStyle/>
+          <a:p>
+            <a:pPr algn="ctr" indent="0" marL="0">
+              <a:buNone/>
+            </a:pPr>
+            <a:r>
+              <a:rPr lang="en-US" sz="1800" i="1" dirty="0">
+                <a:solidFill>
+                  <a:srgbClr val="D9954A"/>
+                </a:solidFill>
+                <a:latin typeface="Cambria" pitchFamily="34" charset="0"/>
+                <a:ea typeface="Cambria" pitchFamily="34" charset="-122"/>
+                <a:cs typeface="Cambria" pitchFamily="34" charset="-120"/>
+              </a:rPr>
+              <a:t>Now — one sentence, one minute.</a:t>
             </a:r>
             <a:endParaRPr lang="en-US" sz="1800" dirty="0"/>
           </a:p>
@@ -2307,7 +2324,7 @@
                 <a:ea typeface="Courier New" pitchFamily="34" charset="-122"/>
                 <a:cs typeface="Courier New" pitchFamily="34" charset="-120"/>
               </a:rPr>
-              <a:t>github.com/kewinzaq1/first-breath  ·  built with Bright Data SERP API · Apple's public review feed · Claude</a:t>
+              <a:t>moment.szlezingier.com  ·  github.com/kewinzaq1/first-breath  ·  built with Bright Data SERP API · Apple's public review feed · Claude</a:t>
             </a:r>
             <a:endParaRPr lang="en-US" sz="850" dirty="0"/>
           </a:p>
@@ -2378,7 +2395,7 @@
                 <a:ea typeface="Courier New" pitchFamily="34" charset="-122"/>
                 <a:cs typeface="Courier New" pitchFamily="34" charset="-120"/>
               </a:rPr>
-              <a:t>PAIN</a:t>
+              <a:t>HYPOTHESIS</a:t>
             </a:r>
             <a:endParaRPr lang="en-US" sz="900" dirty="0"/>
           </a:p>
@@ -2456,7 +2473,7 @@
                 <a:ea typeface="Cambria" pitchFamily="34" charset="-122"/>
                 <a:cs typeface="Cambria" pitchFamily="34" charset="-120"/>
               </a:rPr>
-              <a:t>Meditation apps run the social-feed playbook: keep you coming back, give you more, charge you more.</a:t>
+              <a:t>Two things are broken. Meditation apps overwhelm you. And the calm never leaves the session.</a:t>
             </a:r>
             <a:endParaRPr lang="en-US" sz="2400" dirty="0"/>
           </a:p>
@@ -2471,7 +2488,7 @@
         <p:spPr>
           <a:xfrm>
             <a:off x="548640" y="2057400"/>
-            <a:ext cx="2560320" cy="1691640"/>
+            <a:ext cx="2560320" cy="1874520"/>
           </a:xfrm>
           <a:prstGeom prst="rect">
             <a:avLst/>
@@ -2481,7 +2498,7 @@
           </a:solidFill>
           <a:ln w="12700">
             <a:solidFill>
-              <a:srgbClr val="333333"/>
+              <a:srgbClr val="6E9BD1"/>
             </a:solidFill>
             <a:prstDash val="solid"/>
           </a:ln>
@@ -2514,13 +2531,13 @@
             <a:r>
               <a:rPr lang="en-US" sz="1500" dirty="0">
                 <a:solidFill>
-                  <a:srgbClr val="D9954A"/>
+                  <a:srgbClr val="6E9BD1"/>
                 </a:solidFill>
                 <a:latin typeface="Cambria" pitchFamily="34" charset="0"/>
                 <a:ea typeface="Cambria" pitchFamily="34" charset="-122"/>
                 <a:cs typeface="Cambria" pitchFamily="34" charset="-120"/>
               </a:rPr>
-              <a:t>Keep you coming back</a:t>
+              <a:t>H1 · Overwhelm</a:t>
             </a:r>
             <a:endParaRPr lang="en-US" sz="1500" dirty="0"/>
           </a:p>
@@ -2535,7 +2552,7 @@
         <p:spPr>
           <a:xfrm>
             <a:off x="777240" y="2651760"/>
-            <a:ext cx="2194560" cy="1280160"/>
+            <a:ext cx="2194560" cy="1234440"/>
           </a:xfrm>
           <a:prstGeom prst="rect">
             <a:avLst/>
@@ -2551,7 +2568,7 @@
               <a:buNone/>
             </a:pPr>
             <a:r>
-              <a:rPr lang="en-US" sz="1100" dirty="0">
+              <a:rPr lang="en-US" sz="1050" dirty="0">
                 <a:solidFill>
                   <a:srgbClr val="93867A"/>
                 </a:solidFill>
@@ -2559,9 +2576,9 @@
                 <a:ea typeface="Calibri" pitchFamily="34" charset="-122"/>
                 <a:cs typeface="Calibri" pitchFamily="34" charset="-120"/>
               </a:rPr>
-              <a:t>Streaks. Reminders. Pop-ups. An AI coach you can't switch off. The same retention loops as a feed — pointed at your calm.</a:t>
-            </a:r>
-            <a:endParaRPr lang="en-US" sz="1100" dirty="0"/>
+              <a:t>Ten thousand apps. Forty-day challenges. A guru for every mood. The product that promised peace became one more marketplace to keep up with.</a:t>
+            </a:r>
+            <a:endParaRPr lang="en-US" sz="1050" dirty="0"/>
           </a:p>
         </p:txBody>
       </p:sp>
@@ -2574,7 +2591,7 @@
         <p:spPr>
           <a:xfrm>
             <a:off x="3291840" y="2057400"/>
-            <a:ext cx="2560320" cy="1691640"/>
+            <a:ext cx="2560320" cy="1874520"/>
           </a:xfrm>
           <a:prstGeom prst="rect">
             <a:avLst/>
@@ -2584,7 +2601,7 @@
           </a:solidFill>
           <a:ln w="12700">
             <a:solidFill>
-              <a:srgbClr val="333333"/>
+              <a:srgbClr val="6E9BD1"/>
             </a:solidFill>
             <a:prstDash val="solid"/>
           </a:ln>
@@ -2617,13 +2634,13 @@
             <a:r>
               <a:rPr lang="en-US" sz="1500" dirty="0">
                 <a:solidFill>
-                  <a:srgbClr val="D9954A"/>
+                  <a:srgbClr val="6E9BD1"/>
                 </a:solidFill>
                 <a:latin typeface="Cambria" pitchFamily="34" charset="0"/>
                 <a:ea typeface="Cambria" pitchFamily="34" charset="-122"/>
                 <a:cs typeface="Cambria" pitchFamily="34" charset="-120"/>
               </a:rPr>
-              <a:t>Give you more</a:t>
+              <a:t>H2 · The gap</a:t>
             </a:r>
             <a:endParaRPr lang="en-US" sz="1500" dirty="0"/>
           </a:p>
@@ -2638,7 +2655,7 @@
         <p:spPr>
           <a:xfrm>
             <a:off x="3520440" y="2651760"/>
-            <a:ext cx="2194560" cy="1280160"/>
+            <a:ext cx="2194560" cy="1234440"/>
           </a:xfrm>
           <a:prstGeom prst="rect">
             <a:avLst/>
@@ -2654,7 +2671,7 @@
               <a:buNone/>
             </a:pPr>
             <a:r>
-              <a:rPr lang="en-US" sz="1100" dirty="0">
+              <a:rPr lang="en-US" sz="1050" dirty="0">
                 <a:solidFill>
                   <a:srgbClr val="93867A"/>
                 </a:solidFill>
@@ -2662,9 +2679,9 @@
                 <a:ea typeface="Calibri" pitchFamily="34" charset="-122"/>
                 <a:cs typeface="Calibri" pitchFamily="34" charset="-120"/>
               </a:rPr>
-              <a:t>Five hundred guided sessions. Sleep stories. Masterclasses. Soundscapes. A thousand doors that all say “begin here”.</a:t>
-            </a:r>
-            <a:endParaRPr lang="en-US" sz="1100" dirty="0"/>
+              <a:t>Calm for twenty minutes on the cushion — then the same snap, the same second plate, the same midnight scroll. The practice stays in the session. Life doesn't.</a:t>
+            </a:r>
+            <a:endParaRPr lang="en-US" sz="1050" dirty="0"/>
           </a:p>
         </p:txBody>
       </p:sp>
@@ -2677,7 +2694,7 @@
         <p:spPr>
           <a:xfrm>
             <a:off x="6035040" y="2057400"/>
-            <a:ext cx="2560320" cy="1691640"/>
+            <a:ext cx="2560320" cy="1874520"/>
           </a:xfrm>
           <a:prstGeom prst="rect">
             <a:avLst/>
@@ -2685,9 +2702,9 @@
           <a:solidFill>
             <a:srgbClr val="161210"/>
           </a:solidFill>
-          <a:ln w="12700">
+          <a:ln w="9525">
             <a:solidFill>
-              <a:srgbClr val="333333"/>
+              <a:srgbClr val="D9954A"/>
             </a:solidFill>
             <a:prstDash val="solid"/>
           </a:ln>
@@ -2726,7 +2743,7 @@
                 <a:ea typeface="Cambria" pitchFamily="34" charset="-122"/>
                 <a:cs typeface="Cambria" pitchFamily="34" charset="-120"/>
               </a:rPr>
-              <a:t>Charge you more</a:t>
+              <a:t>The bet · Moment</a:t>
             </a:r>
             <a:endParaRPr lang="en-US" sz="1500" dirty="0"/>
           </a:p>
@@ -2741,7 +2758,7 @@
         <p:spPr>
           <a:xfrm>
             <a:off x="6263640" y="2651760"/>
-            <a:ext cx="2194560" cy="1280160"/>
+            <a:ext cx="2194560" cy="1234440"/>
           </a:xfrm>
           <a:prstGeom prst="rect">
             <a:avLst/>
@@ -2757,7 +2774,7 @@
               <a:buNone/>
             </a:pPr>
             <a:r>
-              <a:rPr lang="en-US" sz="1100" dirty="0">
+              <a:rPr lang="en-US" sz="1050" dirty="0">
                 <a:solidFill>
                   <a:srgbClr val="93867A"/>
                 </a:solidFill>
@@ -2765,9 +2782,9 @@
                 <a:ea typeface="Calibri" pitchFamily="34" charset="-122"/>
                 <a:cs typeface="Calibri" pitchFamily="34" charset="-120"/>
               </a:rPr>
-              <a:t>“Free” trials that bill on day one. Four screens to cancel. $70–$160 a year — for something that used to be a timer.</a:t>
-            </a:r>
-            <a:endParaRPr lang="en-US" sz="1100" dirty="0"/>
+              <a:t>One sentence about how you want to move through today. A pause every thirty minutes. One minute to breathe and choose again. Meditation inside the day.</a:t>
+            </a:r>
+            <a:endParaRPr lang="en-US" sz="1050" dirty="0"/>
           </a:p>
         </p:txBody>
       </p:sp>
@@ -2779,8 +2796,8 @@
         </p:nvSpPr>
         <p:spPr>
           <a:xfrm>
-            <a:off x="548640" y="4297680"/>
-            <a:ext cx="8046720" cy="365760"/>
+            <a:off x="548640" y="4206240"/>
+            <a:ext cx="8046720" cy="457200"/>
           </a:xfrm>
           <a:prstGeom prst="rect">
             <a:avLst/>
@@ -2804,7 +2821,7 @@
                 <a:ea typeface="Cambria" pitchFamily="34" charset="-122"/>
                 <a:cs typeface="Cambria" pitchFamily="34" charset="-120"/>
               </a:rPr>
-              <a:t>That was my opinion. Opinions don't win arguments — and they don't build products.</a:t>
+              <a:t>That was the bet. A bet is not a business — so before telling anyone, I tried to break it.</a:t>
             </a:r>
             <a:endParaRPr lang="en-US" sz="1400" dirty="0"/>
           </a:p>
@@ -2875,7 +2892,7 @@
                 <a:ea typeface="Courier New" pitchFamily="34" charset="-122"/>
                 <a:cs typeface="Courier New" pitchFamily="34" charset="-120"/>
               </a:rPr>
-              <a:t>QUESTION</a:t>
+              <a:t>METHOD</a:t>
             </a:r>
             <a:endParaRPr lang="en-US" sz="900" dirty="0"/>
           </a:p>
@@ -2890,7 +2907,7 @@
         <p:spPr>
           <a:xfrm>
             <a:off x="548640" y="457200"/>
-            <a:ext cx="5486400" cy="274320"/>
+            <a:ext cx="6400800" cy="274320"/>
           </a:xfrm>
           <a:prstGeom prst="rect">
             <a:avLst/>
@@ -2914,7 +2931,7 @@
                 <a:ea typeface="Courier New" pitchFamily="34" charset="-122"/>
                 <a:cs typeface="Courier New" pitchFamily="34" charset="-120"/>
               </a:rPr>
-              <a:t>THE QUESTION</a:t>
+              <a:t>THE QUESTION · CAN THE WEB PROVE ME WRONG?</a:t>
             </a:r>
             <a:endParaRPr lang="en-US" sz="900" dirty="0"/>
           </a:p>
@@ -2929,7 +2946,7 @@
         <p:spPr>
           <a:xfrm>
             <a:off x="548640" y="777240"/>
-            <a:ext cx="8046720" cy="640080"/>
+            <a:ext cx="8046720" cy="914400"/>
           </a:xfrm>
           <a:prstGeom prst="rect">
             <a:avLst/>
@@ -2945,7 +2962,7 @@
               <a:buNone/>
             </a:pPr>
             <a:r>
-              <a:rPr lang="en-US" sz="3000" dirty="0">
+              <a:rPr lang="en-US" sz="2400" dirty="0">
                 <a:solidFill>
                   <a:srgbClr val="EDE4D7"/>
                 </a:solidFill>
@@ -2953,100 +2970,22 @@
                 <a:ea typeface="Cambria" pitchFamily="34" charset="-122"/>
                 <a:cs typeface="Cambria" pitchFamily="34" charset="-120"/>
               </a:rPr>
-              <a:t>Is the pain real — or just mine?</a:t>
-            </a:r>
-            <a:endParaRPr lang="en-US" sz="3000" dirty="0"/>
-          </a:p>
-        </p:txBody>
-      </p:sp>
-      <p:sp>
-        <p:nvSpPr>
-          <p:cNvPr id="5" name="Text 3"/>
-          <p:cNvSpPr/>
-          <p:nvPr/>
-        </p:nvSpPr>
-        <p:spPr>
-          <a:xfrm>
-            <a:off x="548640" y="1508760"/>
-            <a:ext cx="4754880" cy="1463040"/>
-          </a:xfrm>
-          <a:prstGeom prst="rect">
-            <a:avLst/>
-          </a:prstGeom>
-          <a:noFill/>
-          <a:ln/>
-        </p:spPr>
-        <p:txBody>
-          <a:bodyPr wrap="square" lIns="0" tIns="0" rIns="0" bIns="0" rtlCol="0" anchor="t"/>
-          <a:lstStyle/>
-          <a:p>
-            <a:pPr indent="0" marL="0">
-              <a:buNone/>
-            </a:pPr>
-            <a:r>
-              <a:rPr lang="en-US" sz="1300" dirty="0">
-                <a:solidFill>
-                  <a:srgbClr val="93867A"/>
-                </a:solidFill>
-                <a:latin typeface="Calibri" pitchFamily="34" charset="0"/>
-                <a:ea typeface="Calibri" pitchFamily="34" charset="-122"/>
-                <a:cs typeface="Calibri" pitchFamily="34" charset="-120"/>
-              </a:rPr>
-              <a:t>I teach people to sit with a timer and count breaths. It works for the people in my room. But a room is not a market. Before building anything I wanted proof I couldn't argue with: real people, in their own words, counted.</a:t>
-            </a:r>
-            <a:endParaRPr lang="en-US" sz="1300" dirty="0"/>
-          </a:p>
-        </p:txBody>
-      </p:sp>
-      <p:sp>
-        <p:nvSpPr>
-          <p:cNvPr id="6" name="Text 4"/>
-          <p:cNvSpPr/>
-          <p:nvPr/>
-        </p:nvSpPr>
-        <p:spPr>
-          <a:xfrm>
-            <a:off x="548640" y="2971800"/>
-            <a:ext cx="4754880" cy="457200"/>
-          </a:xfrm>
-          <a:prstGeom prst="rect">
-            <a:avLst/>
-          </a:prstGeom>
-          <a:noFill/>
-          <a:ln/>
-        </p:spPr>
-        <p:txBody>
-          <a:bodyPr wrap="square" lIns="0" tIns="0" rIns="0" bIns="0" rtlCol="0" anchor="ctr"/>
-          <a:lstStyle/>
-          <a:p>
-            <a:pPr indent="0" marL="0">
-              <a:buNone/>
-            </a:pPr>
-            <a:r>
-              <a:rPr lang="en-US" sz="1300" dirty="0">
-                <a:solidFill>
-                  <a:srgbClr val="EDE4D7"/>
-                </a:solidFill>
-                <a:latin typeface="Calibri" pitchFamily="34" charset="0"/>
-                <a:ea typeface="Calibri" pitchFamily="34" charset="-122"/>
-                <a:cs typeface="Calibri" pitchFamily="34" charset="-120"/>
-              </a:rPr>
-              <a:t>So I asked the web — the places where people tell the truth about these apps:</a:t>
-            </a:r>
-            <a:endParaRPr lang="en-US" sz="1300" dirty="0"/>
-          </a:p>
-        </p:txBody>
-      </p:sp>
-      <p:sp>
-        <p:nvSpPr>
-          <p:cNvPr id="7" name="Shape 5"/>
-          <p:cNvSpPr/>
-          <p:nvPr/>
-        </p:nvSpPr>
-        <p:spPr>
-          <a:xfrm>
-            <a:off x="5577840" y="1508760"/>
-            <a:ext cx="3017520" cy="822960"/>
+              <a:t>Three sources. Twelve questions — half of them written to refute the hypothesis.</a:t>
+            </a:r>
+            <a:endParaRPr lang="en-US" sz="2400" dirty="0"/>
+          </a:p>
+        </p:txBody>
+      </p:sp>
+      <p:sp>
+        <p:nvSpPr>
+          <p:cNvPr id="5" name="Shape 3"/>
+          <p:cNvSpPr/>
+          <p:nvPr/>
+        </p:nvSpPr>
+        <p:spPr>
+          <a:xfrm>
+            <a:off x="548640" y="1828800"/>
+            <a:ext cx="4937760" cy="749808"/>
           </a:xfrm>
           <a:prstGeom prst="rect">
             <a:avLst/>
@@ -3064,14 +3003,14 @@
       </p:sp>
       <p:sp>
         <p:nvSpPr>
-          <p:cNvPr id="8" name="Text 6"/>
-          <p:cNvSpPr/>
-          <p:nvPr/>
-        </p:nvSpPr>
-        <p:spPr>
-          <a:xfrm>
-            <a:off x="5760720" y="1618488"/>
-            <a:ext cx="2743200" cy="274320"/>
+          <p:cNvPr id="6" name="Text 4"/>
+          <p:cNvSpPr/>
+          <p:nvPr/>
+        </p:nvSpPr>
+        <p:spPr>
+          <a:xfrm>
+            <a:off x="731520" y="1920240"/>
+            <a:ext cx="4572000" cy="274320"/>
           </a:xfrm>
           <a:prstGeom prst="rect">
             <a:avLst/>
@@ -3103,14 +3042,14 @@
       </p:sp>
       <p:sp>
         <p:nvSpPr>
-          <p:cNvPr id="9" name="Text 7"/>
-          <p:cNvSpPr/>
-          <p:nvPr/>
-        </p:nvSpPr>
-        <p:spPr>
-          <a:xfrm>
-            <a:off x="5760720" y="1892808"/>
-            <a:ext cx="2743200" cy="411480"/>
+          <p:cNvPr id="7" name="Text 5"/>
+          <p:cNvSpPr/>
+          <p:nvPr/>
+        </p:nvSpPr>
+        <p:spPr>
+          <a:xfrm>
+            <a:off x="731520" y="2194560"/>
+            <a:ext cx="4572000" cy="365760"/>
           </a:xfrm>
           <a:prstGeom prst="rect">
             <a:avLst/>
@@ -3134,7 +3073,7 @@
                 <a:ea typeface="Calibri" pitchFamily="34" charset="-122"/>
                 <a:cs typeface="Calibri" pitchFamily="34" charset="-120"/>
               </a:rPr>
-              <a:t>Calm · Headspace · Waking Up — 210 of them negative</a:t>
+              <a:t>Calm · Headspace · Waking Up — 210 negative. Tests H1.</a:t>
             </a:r>
             <a:endParaRPr lang="en-US" sz="950" dirty="0"/>
           </a:p>
@@ -3142,14 +3081,14 @@
       </p:sp>
       <p:sp>
         <p:nvSpPr>
-          <p:cNvPr id="10" name="Shape 8"/>
-          <p:cNvSpPr/>
-          <p:nvPr/>
-        </p:nvSpPr>
-        <p:spPr>
-          <a:xfrm>
-            <a:off x="5577840" y="2468880"/>
-            <a:ext cx="3017520" cy="822960"/>
+          <p:cNvPr id="8" name="Shape 6"/>
+          <p:cNvSpPr/>
+          <p:nvPr/>
+        </p:nvSpPr>
+        <p:spPr>
+          <a:xfrm>
+            <a:off x="548640" y="2697480"/>
+            <a:ext cx="4937760" cy="749808"/>
           </a:xfrm>
           <a:prstGeom prst="rect">
             <a:avLst/>
@@ -3167,14 +3106,14 @@
       </p:sp>
       <p:sp>
         <p:nvSpPr>
-          <p:cNvPr id="11" name="Text 9"/>
-          <p:cNvSpPr/>
-          <p:nvPr/>
-        </p:nvSpPr>
-        <p:spPr>
-          <a:xfrm>
-            <a:off x="5760720" y="2578608"/>
-            <a:ext cx="2743200" cy="274320"/>
+          <p:cNvPr id="9" name="Text 7"/>
+          <p:cNvSpPr/>
+          <p:nvPr/>
+        </p:nvSpPr>
+        <p:spPr>
+          <a:xfrm>
+            <a:off x="731520" y="2788920"/>
+            <a:ext cx="4572000" cy="274320"/>
           </a:xfrm>
           <a:prstGeom prst="rect">
             <a:avLst/>
@@ -3206,14 +3145,14 @@
       </p:sp>
       <p:sp>
         <p:nvSpPr>
-          <p:cNvPr id="12" name="Text 10"/>
-          <p:cNvSpPr/>
-          <p:nvPr/>
-        </p:nvSpPr>
-        <p:spPr>
-          <a:xfrm>
-            <a:off x="5760720" y="2852928"/>
-            <a:ext cx="2743200" cy="411480"/>
+          <p:cNvPr id="10" name="Text 8"/>
+          <p:cNvSpPr/>
+          <p:nvPr/>
+        </p:nvSpPr>
+        <p:spPr>
+          <a:xfrm>
+            <a:off x="731520" y="3063240"/>
+            <a:ext cx="4572000" cy="365760"/>
           </a:xfrm>
           <a:prstGeom prst="rect">
             <a:avLst/>
@@ -3237,7 +3176,7 @@
                 <a:ea typeface="Calibri" pitchFamily="34" charset="-122"/>
                 <a:cs typeface="Calibri" pitchFamily="34" charset="-120"/>
               </a:rPr>
-              <a:t>r/Meditation · r/getdisciplined — starting, and quitting</a:t>
+              <a:t>r/Meditation · r/getdisciplined — starting, quitting, sticking.</a:t>
             </a:r>
             <a:endParaRPr lang="en-US" sz="950" dirty="0"/>
           </a:p>
@@ -3245,14 +3184,14 @@
       </p:sp>
       <p:sp>
         <p:nvSpPr>
-          <p:cNvPr id="13" name="Shape 11"/>
-          <p:cNvSpPr/>
-          <p:nvPr/>
-        </p:nvSpPr>
-        <p:spPr>
-          <a:xfrm>
-            <a:off x="5577840" y="3429000"/>
-            <a:ext cx="3017520" cy="822960"/>
+          <p:cNvPr id="11" name="Shape 9"/>
+          <p:cNvSpPr/>
+          <p:nvPr/>
+        </p:nvSpPr>
+        <p:spPr>
+          <a:xfrm>
+            <a:off x="548640" y="3566160"/>
+            <a:ext cx="4937760" cy="749808"/>
           </a:xfrm>
           <a:prstGeom prst="rect">
             <a:avLst/>
@@ -3270,14 +3209,14 @@
       </p:sp>
       <p:sp>
         <p:nvSpPr>
-          <p:cNvPr id="14" name="Text 12"/>
-          <p:cNvSpPr/>
-          <p:nvPr/>
-        </p:nvSpPr>
-        <p:spPr>
-          <a:xfrm>
-            <a:off x="5760720" y="3538728"/>
-            <a:ext cx="2743200" cy="274320"/>
+          <p:cNvPr id="12" name="Text 10"/>
+          <p:cNvSpPr/>
+          <p:nvPr/>
+        </p:nvSpPr>
+        <p:spPr>
+          <a:xfrm>
+            <a:off x="731520" y="3657600"/>
+            <a:ext cx="4572000" cy="274320"/>
           </a:xfrm>
           <a:prstGeom prst="rect">
             <a:avLst/>
@@ -3301,7 +3240,7 @@
                 <a:ea typeface="Courier New" pitchFamily="34" charset="-122"/>
                 <a:cs typeface="Courier New" pitchFamily="34" charset="-120"/>
               </a:rPr>
-              <a:t>42 search results</a:t>
+              <a:t>104 search results · 12 queries</a:t>
             </a:r>
             <a:endParaRPr lang="en-US" sz="1100" dirty="0"/>
           </a:p>
@@ -3309,14 +3248,14 @@
       </p:sp>
       <p:sp>
         <p:nvSpPr>
-          <p:cNvPr id="15" name="Text 13"/>
-          <p:cNvSpPr/>
-          <p:nvPr/>
-        </p:nvSpPr>
-        <p:spPr>
-          <a:xfrm>
-            <a:off x="5760720" y="3813048"/>
-            <a:ext cx="2743200" cy="411480"/>
+          <p:cNvPr id="13" name="Text 11"/>
+          <p:cNvSpPr/>
+          <p:nvPr/>
+        </p:nvSpPr>
+        <p:spPr>
+          <a:xfrm>
+            <a:off x="731520" y="3931920"/>
+            <a:ext cx="4572000" cy="365760"/>
           </a:xfrm>
           <a:prstGeom prst="rect">
             <a:avLst/>
@@ -3340,7 +3279,7 @@
                 <a:ea typeface="Calibri" pitchFamily="34" charset="-122"/>
                 <a:cs typeface="Calibri" pitchFamily="34" charset="-120"/>
               </a:rPr>
-              <a:t>how beginners actually ask, e.g. “how to start meditating without an app”</a:t>
+              <a:t>“meditate every day but still reactive” · “meditation doesn't carry over into daily life” · “mindfulness bell app” · “one minute meditation reminder app”</a:t>
             </a:r>
             <a:endParaRPr lang="en-US" sz="950" dirty="0"/>
           </a:p>
@@ -3348,13 +3287,106 @@
       </p:sp>
       <p:sp>
         <p:nvSpPr>
-          <p:cNvPr id="16" name="Text 14"/>
-          <p:cNvSpPr/>
-          <p:nvPr/>
-        </p:nvSpPr>
-        <p:spPr>
-          <a:xfrm>
-            <a:off x="548640" y="4434840"/>
+          <p:cNvPr id="14" name="Text 12"/>
+          <p:cNvSpPr/>
+          <p:nvPr/>
+        </p:nvSpPr>
+        <p:spPr>
+          <a:xfrm>
+            <a:off x="5760720" y="1828800"/>
+            <a:ext cx="2834640" cy="2651760"/>
+          </a:xfrm>
+          <a:prstGeom prst="rect">
+            <a:avLst/>
+          </a:prstGeom>
+          <a:noFill/>
+          <a:ln/>
+        </p:spPr>
+        <p:txBody>
+          <a:bodyPr wrap="square" lIns="0" tIns="0" rIns="0" bIns="0" rtlCol="0" anchor="t"/>
+          <a:lstStyle/>
+          <a:p>
+            <a:pPr indent="0" marL="0">
+              <a:buNone/>
+            </a:pPr>
+            <a:r>
+              <a:rPr lang="en-US" sz="1400" dirty="0">
+                <a:solidFill>
+                  <a:srgbClr val="EDE4D7"/>
+                </a:solidFill>
+                <a:latin typeface="Cambria" pitchFamily="34" charset="0"/>
+                <a:ea typeface="Cambria" pitchFamily="34" charset="-122"/>
+                <a:cs typeface="Cambria" pitchFamily="34" charset="-120"/>
+              </a:rPr>
+              <a:t>Why refuting queries?
+</a:t>
+            </a:r>
+            <a:endParaRPr lang="en-US" sz="1400" dirty="0"/>
+          </a:p>
+          <a:p>
+            <a:pPr indent="0" marL="0">
+              <a:buNone/>
+            </a:pPr>
+            <a:r>
+              <a:rPr lang="en-US" sz="1100" dirty="0">
+                <a:solidFill>
+                  <a:srgbClr val="93867A"/>
+                </a:solidFill>
+                <a:latin typeface="Calibri" pitchFamily="34" charset="0"/>
+                <a:ea typeface="Calibri" pitchFamily="34" charset="-122"/>
+                <a:cs typeface="Calibri" pitchFamily="34" charset="-120"/>
+              </a:rPr>
+              <a:t>If I only searched for people who agree with me, the web would happily agree. So four of the twelve queries looked for the opposite: people saying meditation does carry over, and products that already do what Moment does.
+</a:t>
+            </a:r>
+            <a:endParaRPr lang="en-US" sz="1400" dirty="0"/>
+          </a:p>
+          <a:p>
+            <a:pPr indent="0" marL="0">
+              <a:buNone/>
+            </a:pPr>
+            <a:r>
+              <a:rPr lang="en-US" sz="1400" dirty="0">
+                <a:solidFill>
+                  <a:srgbClr val="EDE4D7"/>
+                </a:solidFill>
+                <a:latin typeface="Cambria" pitchFamily="34" charset="0"/>
+                <a:ea typeface="Cambria" pitchFamily="34" charset="-122"/>
+                <a:cs typeface="Cambria" pitchFamily="34" charset="-120"/>
+              </a:rPr>
+              <a:t>Rules
+</a:t>
+            </a:r>
+            <a:endParaRPr lang="en-US" sz="1400" dirty="0"/>
+          </a:p>
+          <a:p>
+            <a:pPr indent="0" marL="0">
+              <a:buNone/>
+            </a:pPr>
+            <a:r>
+              <a:rPr lang="en-US" sz="1100" dirty="0">
+                <a:solidFill>
+                  <a:srgbClr val="93867A"/>
+                </a:solidFill>
+                <a:latin typeface="Calibri" pitchFamily="34" charset="0"/>
+                <a:ea typeface="Calibri" pitchFamily="34" charset="-122"/>
+                <a:cs typeface="Calibri" pitchFamily="34" charset="-120"/>
+              </a:rPr>
+              <a:t>Every quote verbatim. Every percentage computed. Every source credited by the path that actually served it.</a:t>
+            </a:r>
+            <a:endParaRPr lang="en-US" sz="1400" dirty="0"/>
+          </a:p>
+        </p:txBody>
+      </p:sp>
+      <p:sp>
+        <p:nvSpPr>
+          <p:cNvPr id="15" name="Text 13"/>
+          <p:cNvSpPr/>
+          <p:nvPr/>
+        </p:nvSpPr>
+        <p:spPr>
+          <a:xfrm>
+            <a:off x="548640" y="4572000"/>
             <a:ext cx="8046720" cy="274320"/>
           </a:xfrm>
           <a:prstGeom prst="rect">
@@ -3379,7 +3411,7 @@
                 <a:ea typeface="Courier New" pitchFamily="34" charset="-122"/>
                 <a:cs typeface="Courier New" pitchFamily="34" charset="-120"/>
               </a:rPr>
-              <a:t>Collected on Aug 21, 2026 via Bright Data SERP API + Apple's public review feed. How, on slide 8.</a:t>
+              <a:t>Bright Data SERP API + Apple's public review feed · Aug 21–22, 2026</a:t>
             </a:r>
             <a:endParaRPr lang="en-US" sz="850" dirty="0"/>
           </a:p>
@@ -3450,7 +3482,7 @@
                 <a:ea typeface="Courier New" pitchFamily="34" charset="-122"/>
                 <a:cs typeface="Courier New" pitchFamily="34" charset="-120"/>
               </a:rPr>
-              <a:t>PROOF 1/3</a:t>
+              <a:t>H1 · HOLDS</a:t>
             </a:r>
             <a:endParaRPr lang="en-US" sz="900" dirty="0"/>
           </a:p>
@@ -3465,7 +3497,7 @@
         <p:spPr>
           <a:xfrm>
             <a:off x="548640" y="457200"/>
-            <a:ext cx="5486400" cy="274320"/>
+            <a:ext cx="6400800" cy="274320"/>
           </a:xfrm>
           <a:prstGeom prst="rect">
             <a:avLst/>
@@ -3489,7 +3521,7 @@
                 <a:ea typeface="Courier New" pitchFamily="34" charset="-122"/>
                 <a:cs typeface="Courier New" pitchFamily="34" charset="-120"/>
               </a:rPr>
-              <a:t>PROOF · 210 NEGATIVE REVIEWS, CLASSIFIED</a:t>
+              <a:t>RESULT · OVERWHELM · 210 NEGATIVE REVIEWS, CLASSIFIED</a:t>
             </a:r>
             <a:endParaRPr lang="en-US" sz="900" dirty="0"/>
           </a:p>
@@ -3528,7 +3560,7 @@
                 <a:ea typeface="Cambria" pitchFamily="34" charset="-122"/>
                 <a:cs typeface="Cambria" pitchFamily="34" charset="-120"/>
               </a:rPr>
-              <a:t>Half of the anger is about money. Not one complaint asks for more content.</a:t>
+              <a:t>H1 holds. People are not asking for more. They are asking for less — and to be left alone.</a:t>
             </a:r>
             <a:endParaRPr lang="en-US" sz="2400" dirty="0"/>
           </a:p>
@@ -3583,7 +3615,7 @@
                 <a:ea typeface="Cambria" pitchFamily="34" charset="-122"/>
                 <a:cs typeface="Cambria" pitchFamily="34" charset="-120"/>
               </a:rPr>
-              <a:t>“Literally nothing is free. To use anything they make you do a trial of their paid service. I can get all of this on YouTube, why would I pay for it? Greedy greedy greedy.”</a:t>
+              <a:t>“Now I just feel overwhelmed with the amount of content. A feature that randomly selects a session would reduce decision fatigue.”</a:t>
             </a:r>
             <a:endParaRPr lang="en-US" sz="1200" dirty="0"/>
           </a:p>
@@ -3637,7 +3669,7 @@
         <p:spPr>
           <a:xfrm>
             <a:off x="5394960" y="3200400"/>
-            <a:ext cx="3200400" cy="640080"/>
+            <a:ext cx="3200400" cy="777240"/>
           </a:xfrm>
           <a:prstGeom prst="rect">
             <a:avLst/>
@@ -3661,7 +3693,7 @@
                 <a:ea typeface="Cambria" pitchFamily="34" charset="-122"/>
                 <a:cs typeface="Cambria" pitchFamily="34" charset="-120"/>
               </a:rPr>
-              <a:t>“A company promoting mental wellness should not create stress through questionable billing practices.”</a:t>
+              <a:t>“There's constant notifications and pop-ups to engage with their AI chat bot Ebb that you cannot turn off.”</a:t>
             </a:r>
             <a:endParaRPr lang="en-US" sz="1200" dirty="0"/>
           </a:p>
@@ -3675,7 +3707,7 @@
         </p:nvSpPr>
         <p:spPr>
           <a:xfrm>
-            <a:off x="5394960" y="3886200"/>
+            <a:off x="5394960" y="4023360"/>
             <a:ext cx="3200400" cy="228600"/>
           </a:xfrm>
           <a:prstGeom prst="rect">
@@ -3810,7 +3842,7 @@
                 <a:ea typeface="Courier New" pitchFamily="34" charset="-122"/>
                 <a:cs typeface="Courier New" pitchFamily="34" charset="-120"/>
               </a:rPr>
-              <a:t>PROOF 2/3</a:t>
+              <a:t>H2 · HOLDS</a:t>
             </a:r>
             <a:endParaRPr lang="en-US" sz="900" dirty="0"/>
           </a:p>
@@ -3849,7 +3881,7 @@
                 <a:ea typeface="Courier New" pitchFamily="34" charset="-122"/>
                 <a:cs typeface="Courier New" pitchFamily="34" charset="-120"/>
               </a:rPr>
-              <a:t>PROOF · THE RETENTION LOOP, IN THEIR OWN WORDS</a:t>
+              <a:t>RESULT · THE GAP · R/MEDITATION, IN THEIR OWN WORDS</a:t>
             </a:r>
             <a:endParaRPr lang="en-US" sz="900" dirty="0"/>
           </a:p>
@@ -3888,7 +3920,7 @@
                 <a:ea typeface="Cambria" pitchFamily="34" charset="-122"/>
                 <a:cs typeface="Cambria" pitchFamily="34" charset="-120"/>
               </a:rPr>
-              <a:t>The “social-feed playbook” wasn't my metaphor. Users describe it themselves.</a:t>
+              <a:t>H2 holds — for the people it fails. And they prescribe the bridge themselves.</a:t>
             </a:r>
             <a:endParaRPr lang="en-US" sz="2400" dirty="0"/>
           </a:p>
@@ -3927,7 +3959,7 @@
                 <a:ea typeface="Cambria" pitchFamily="34" charset="-122"/>
                 <a:cs typeface="Cambria" pitchFamily="34" charset="-120"/>
               </a:rPr>
-              <a:t>“There's constant notifications and pop-ups to engage with their AI chat bot Ebb that you cannot turn off.”</a:t>
+              <a:t>“meditation helps me identify when I am not being present, However, when another same trigger arose, I was still reactive.”</a:t>
             </a:r>
             <a:endParaRPr lang="en-US" sz="1300" dirty="0"/>
           </a:p>
@@ -3966,7 +3998,7 @@
                 <a:ea typeface="Courier New" pitchFamily="34" charset="-122"/>
                 <a:cs typeface="Courier New" pitchFamily="34" charset="-120"/>
               </a:rPr>
-              <a:t>HEADSPACE · APP-STORE REVIEW</a:t>
+              <a:t>R/MEDITATION · VIA BRIGHT DATA SERP</a:t>
             </a:r>
             <a:endParaRPr lang="en-US" sz="750" dirty="0"/>
           </a:p>
@@ -4005,7 +4037,7 @@
                 <a:ea typeface="Cambria" pitchFamily="34" charset="-122"/>
                 <a:cs typeface="Cambria" pitchFamily="34" charset="-120"/>
               </a:rPr>
-              <a:t>“Went through 4 different rounds of asking me if I'm sure I want to cancel. Then I get to a screen that in LARGE letters says “No problem.” … Two weeks later I see a charge for the app.”</a:t>
+              <a:t>“It's been 2years already into meditation. I am still dealing with intrusive thoughts, anxiety.”</a:t>
             </a:r>
             <a:endParaRPr lang="en-US" sz="1300" dirty="0"/>
           </a:p>
@@ -4044,7 +4076,7 @@
                 <a:ea typeface="Courier New" pitchFamily="34" charset="-122"/>
                 <a:cs typeface="Courier New" pitchFamily="34" charset="-120"/>
               </a:rPr>
-              <a:t>CALM · APP-STORE REVIEW</a:t>
+              <a:t>R/MEDITATION · 151 VOTES</a:t>
             </a:r>
             <a:endParaRPr lang="en-US" sz="750" dirty="0"/>
           </a:p>
@@ -4083,7 +4115,7 @@
                 <a:ea typeface="Cambria" pitchFamily="34" charset="-122"/>
                 <a:cs typeface="Cambria" pitchFamily="34" charset="-120"/>
               </a:rPr>
-              <a:t>“Congrats instead of lowering my heart rate I have increased my rage.”</a:t>
+              <a:t>“In order to change your behavior, you need to begin to bring your meditative mindset into daily life when you are in the act of making decisions…”</a:t>
             </a:r>
             <a:endParaRPr lang="en-US" sz="1300" dirty="0"/>
           </a:p>
@@ -4122,7 +4154,7 @@
                 <a:ea typeface="Courier New" pitchFamily="34" charset="-122"/>
                 <a:cs typeface="Courier New" pitchFamily="34" charset="-120"/>
               </a:rPr>
-              <a:t>HEADSPACE · APP-STORE REVIEW</a:t>
+              <a:t>R/MEDITATION · VIA BRIGHT DATA SERP</a:t>
             </a:r>
             <a:endParaRPr lang="en-US" sz="750" dirty="0"/>
           </a:p>
@@ -4136,8 +4168,8 @@
         </p:nvSpPr>
         <p:spPr>
           <a:xfrm>
-            <a:off x="548640" y="4160520"/>
-            <a:ext cx="8046720" cy="457200"/>
+            <a:off x="548640" y="4069080"/>
+            <a:ext cx="8046720" cy="548640"/>
           </a:xfrm>
           <a:prstGeom prst="rect">
             <a:avLst/>
@@ -4153,7 +4185,7 @@
               <a:buNone/>
             </a:pPr>
             <a:r>
-              <a:rPr lang="en-US" sz="1400" i="1" dirty="0">
+              <a:rPr lang="en-US" sz="1300" i="1" dirty="0">
                 <a:solidFill>
                   <a:srgbClr val="EDE4D7"/>
                 </a:solidFill>
@@ -4161,9 +4193,9 @@
                 <a:ea typeface="Cambria" pitchFamily="34" charset="-122"/>
                 <a:cs typeface="Cambria" pitchFamily="34" charset="-120"/>
               </a:rPr>
-              <a:t>Reminders, dark-pattern cancellation, rage. The product that promised calm is generating the opposite — and people notice.</a:t>
-            </a:r>
-            <a:endParaRPr lang="en-US" sz="1400" dirty="0"/>
+              <a:t>Honest caveat: not universal. Some long-term meditators report being less reactive. The gap is real for the people who are asking — and they are the market.</a:t>
+            </a:r>
+            <a:endParaRPr lang="en-US" sz="1300" dirty="0"/>
           </a:p>
         </p:txBody>
       </p:sp>
@@ -4232,7 +4264,7 @@
                 <a:ea typeface="Courier New" pitchFamily="34" charset="-122"/>
                 <a:cs typeface="Courier New" pitchFamily="34" charset="-120"/>
               </a:rPr>
-              <a:t>PROOF 3/3</a:t>
+              <a:t>PUSHBACK</a:t>
             </a:r>
             <a:endParaRPr lang="en-US" sz="900" dirty="0"/>
           </a:p>
@@ -4271,7 +4303,7 @@
                 <a:ea typeface="Courier New" pitchFamily="34" charset="-122"/>
                 <a:cs typeface="Courier New" pitchFamily="34" charset="-120"/>
               </a:rPr>
-              <a:t>PROOF · WHAT PEOPLE ASK FOR INSTEAD</a:t>
+              <a:t>RESULT · WHAT THE WEB REFUTED</a:t>
             </a:r>
             <a:endParaRPr lang="en-US" sz="900" dirty="0"/>
           </a:p>
@@ -4286,7 +4318,7 @@
         <p:spPr>
           <a:xfrm>
             <a:off x="548640" y="777240"/>
-            <a:ext cx="8046720" cy="640080"/>
+            <a:ext cx="8046720" cy="914400"/>
           </a:xfrm>
           <a:prstGeom prst="rect">
             <a:avLst/>
@@ -4302,7 +4334,7 @@
               <a:buNone/>
             </a:pPr>
             <a:r>
-              <a:rPr lang="en-US" sz="2600" dirty="0">
+              <a:rPr lang="en-US" sz="2400" dirty="0">
                 <a:solidFill>
                   <a:srgbClr val="EDE4D7"/>
                 </a:solidFill>
@@ -4310,50 +4342,36 @@
                 <a:ea typeface="Cambria" pitchFamily="34" charset="-122"/>
                 <a:cs typeface="Cambria" pitchFamily="34" charset="-120"/>
               </a:rPr>
-              <a:t>The market names the product for me: a timer.</a:t>
-            </a:r>
-            <a:endParaRPr lang="en-US" sz="2600" dirty="0"/>
-          </a:p>
-        </p:txBody>
-      </p:sp>
-      <p:sp>
-        <p:nvSpPr>
-          <p:cNvPr id="5" name="Text 3"/>
-          <p:cNvSpPr/>
-          <p:nvPr/>
-        </p:nvSpPr>
-        <p:spPr>
-          <a:xfrm>
-            <a:off x="548640" y="1554480"/>
-            <a:ext cx="4754880" cy="1097280"/>
-          </a:xfrm>
-          <a:prstGeom prst="rect">
-            <a:avLst/>
-          </a:prstGeom>
-          <a:noFill/>
-          <a:ln/>
-        </p:spPr>
-        <p:txBody>
-          <a:bodyPr wrap="square" lIns="0" tIns="0" rIns="0" bIns="0" rtlCol="0" anchor="t"/>
-          <a:lstStyle/>
-          <a:p>
-            <a:pPr indent="0" marL="0">
-              <a:buNone/>
-            </a:pPr>
-            <a:r>
-              <a:rPr lang="en-US" sz="1800" i="1" dirty="0">
-                <a:solidFill>
-                  <a:srgbClr val="6E9BD1"/>
-                </a:solidFill>
-                <a:latin typeface="Cambria" pitchFamily="34" charset="0"/>
-                <a:ea typeface="Cambria" pitchFamily="34" charset="-122"/>
-                <a:cs typeface="Cambria" pitchFamily="34" charset="-120"/>
-              </a:rPr>
-              <a:t>“The idea that we now need to pay a $70 yearly subscription for a timer is embarrassingly greedy.”</a:t>
-            </a:r>
-            <a:endParaRPr lang="en-US" sz="1800" dirty="0"/>
-          </a:p>
-        </p:txBody>
+              <a:t>The interrupt is not new. The minute is not new. Moment cannot be “a reminder app”.</a:t>
+            </a:r>
+            <a:endParaRPr lang="en-US" sz="2400" dirty="0"/>
+          </a:p>
+        </p:txBody>
+      </p:sp>
+      <p:sp>
+        <p:nvSpPr>
+          <p:cNvPr id="5" name="Shape 3"/>
+          <p:cNvSpPr/>
+          <p:nvPr/>
+        </p:nvSpPr>
+        <p:spPr>
+          <a:xfrm>
+            <a:off x="548640" y="1901952"/>
+            <a:ext cx="118872" cy="118872"/>
+          </a:xfrm>
+          <a:prstGeom prst="ellipse">
+            <a:avLst/>
+          </a:prstGeom>
+          <a:solidFill>
+            <a:srgbClr val="6E9BD1"/>
+          </a:solidFill>
+          <a:ln w="12700">
+            <a:solidFill>
+              <a:srgbClr val="333333"/>
+            </a:solidFill>
+            <a:prstDash val="solid"/>
+          </a:ln>
+        </p:spPr>
       </p:sp>
       <p:sp>
         <p:nvSpPr>
@@ -4363,8 +4381,8 @@
         </p:nvSpPr>
         <p:spPr>
           <a:xfrm>
-            <a:off x="548640" y="2697480"/>
-            <a:ext cx="4754880" cy="228600"/>
+            <a:off x="822960" y="1828800"/>
+            <a:ext cx="2377440" cy="274320"/>
           </a:xfrm>
           <a:prstGeom prst="rect">
             <a:avLst/>
@@ -4380,17 +4398,17 @@
               <a:buNone/>
             </a:pPr>
             <a:r>
-              <a:rPr lang="en-US" sz="750" spc="80" kern="0" dirty="0">
-                <a:solidFill>
-                  <a:srgbClr val="3D5573"/>
+              <a:rPr lang="en-US" sz="1050" b="1" dirty="0">
+                <a:solidFill>
+                  <a:srgbClr val="EDE4D7"/>
                 </a:solidFill>
                 <a:latin typeface="Courier New" pitchFamily="34" charset="0"/>
                 <a:ea typeface="Courier New" pitchFamily="34" charset="-122"/>
                 <a:cs typeface="Courier New" pitchFamily="34" charset="-120"/>
               </a:rPr>
-              <a:t>R/MEDITATION · VIA BRIGHT DATA SERP</a:t>
-            </a:r>
-            <a:endParaRPr lang="en-US" sz="750" dirty="0"/>
+              <a:t>Mindfulness Bell</a:t>
+            </a:r>
+            <a:endParaRPr lang="en-US" sz="1050" dirty="0"/>
           </a:p>
         </p:txBody>
       </p:sp>
@@ -4402,8 +4420,8 @@
         </p:nvSpPr>
         <p:spPr>
           <a:xfrm>
-            <a:off x="548640" y="3063240"/>
-            <a:ext cx="4754880" cy="685800"/>
+            <a:off x="3200400" y="1828800"/>
+            <a:ext cx="2377440" cy="502920"/>
           </a:xfrm>
           <a:prstGeom prst="rect">
             <a:avLst/>
@@ -4419,30 +4437,55 @@
               <a:buNone/>
             </a:pPr>
             <a:r>
-              <a:rPr lang="en-US" sz="1300" i="1" dirty="0">
-                <a:solidFill>
-                  <a:srgbClr val="6E9BD1"/>
-                </a:solidFill>
-                <a:latin typeface="Cambria" pitchFamily="34" charset="0"/>
-                <a:ea typeface="Cambria" pitchFamily="34" charset="-122"/>
-                <a:cs typeface="Cambria" pitchFamily="34" charset="-120"/>
-              </a:rPr>
-              <a:t>“It's simple enough that I actually use it. Here's the practice: Sit or lie down comfortably. Set a timer for 3–5…”</a:t>
-            </a:r>
-            <a:endParaRPr lang="en-US" sz="1300" dirty="0"/>
-          </a:p>
-        </p:txBody>
-      </p:sp>
-      <p:sp>
-        <p:nvSpPr>
-          <p:cNvPr id="8" name="Text 6"/>
-          <p:cNvSpPr/>
-          <p:nvPr/>
-        </p:nvSpPr>
-        <p:spPr>
-          <a:xfrm>
-            <a:off x="548640" y="3794760"/>
-            <a:ext cx="4754880" cy="228600"/>
+              <a:rPr lang="en-US" sz="1000" dirty="0">
+                <a:solidFill>
+                  <a:srgbClr val="93867A"/>
+                </a:solidFill>
+                <a:latin typeface="Calibri" pitchFamily="34" charset="0"/>
+                <a:ea typeface="Calibri" pitchFamily="34" charset="-122"/>
+                <a:cs typeface="Calibri" pitchFamily="34" charset="-120"/>
+              </a:rPr>
+              <a:t>interval or random bells, all day</a:t>
+            </a:r>
+            <a:endParaRPr lang="en-US" sz="1000" dirty="0"/>
+          </a:p>
+        </p:txBody>
+      </p:sp>
+      <p:sp>
+        <p:nvSpPr>
+          <p:cNvPr id="8" name="Shape 6"/>
+          <p:cNvSpPr/>
+          <p:nvPr/>
+        </p:nvSpPr>
+        <p:spPr>
+          <a:xfrm>
+            <a:off x="548640" y="2468880"/>
+            <a:ext cx="118872" cy="118872"/>
+          </a:xfrm>
+          <a:prstGeom prst="ellipse">
+            <a:avLst/>
+          </a:prstGeom>
+          <a:solidFill>
+            <a:srgbClr val="6E9BD1"/>
+          </a:solidFill>
+          <a:ln w="12700">
+            <a:solidFill>
+              <a:srgbClr val="333333"/>
+            </a:solidFill>
+            <a:prstDash val="solid"/>
+          </a:ln>
+        </p:spPr>
+      </p:sp>
+      <p:sp>
+        <p:nvSpPr>
+          <p:cNvPr id="9" name="Text 7"/>
+          <p:cNvSpPr/>
+          <p:nvPr/>
+        </p:nvSpPr>
+        <p:spPr>
+          <a:xfrm>
+            <a:off x="822960" y="2395728"/>
+            <a:ext cx="2377440" cy="274320"/>
           </a:xfrm>
           <a:prstGeom prst="rect">
             <a:avLst/>
@@ -4458,30 +4501,275 @@
               <a:buNone/>
             </a:pPr>
             <a:r>
-              <a:rPr lang="en-US" sz="750" spc="80" kern="0" dirty="0">
-                <a:solidFill>
-                  <a:srgbClr val="3D5573"/>
+              <a:rPr lang="en-US" sz="1050" b="1" dirty="0">
+                <a:solidFill>
+                  <a:srgbClr val="EDE4D7"/>
                 </a:solidFill>
                 <a:latin typeface="Courier New" pitchFamily="34" charset="0"/>
                 <a:ea typeface="Courier New" pitchFamily="34" charset="-122"/>
                 <a:cs typeface="Courier New" pitchFamily="34" charset="-120"/>
               </a:rPr>
-              <a:t>R/MEDITATION · VIA BRIGHT DATA SERP</a:t>
-            </a:r>
-            <a:endParaRPr lang="en-US" sz="750" dirty="0"/>
-          </a:p>
-        </p:txBody>
-      </p:sp>
-      <p:sp>
-        <p:nvSpPr>
-          <p:cNvPr id="9" name="Shape 7"/>
-          <p:cNvSpPr/>
-          <p:nvPr/>
-        </p:nvSpPr>
-        <p:spPr>
-          <a:xfrm>
-            <a:off x="5669280" y="1554480"/>
-            <a:ext cx="2926080" cy="2926080"/>
+              <a:t>MindBell · Chill · Remindfulness</a:t>
+            </a:r>
+            <a:endParaRPr lang="en-US" sz="1050" dirty="0"/>
+          </a:p>
+        </p:txBody>
+      </p:sp>
+      <p:sp>
+        <p:nvSpPr>
+          <p:cNvPr id="10" name="Text 8"/>
+          <p:cNvSpPr/>
+          <p:nvPr/>
+        </p:nvSpPr>
+        <p:spPr>
+          <a:xfrm>
+            <a:off x="3200400" y="2395728"/>
+            <a:ext cx="2377440" cy="502920"/>
+          </a:xfrm>
+          <a:prstGeom prst="rect">
+            <a:avLst/>
+          </a:prstGeom>
+          <a:noFill/>
+          <a:ln/>
+        </p:spPr>
+        <p:txBody>
+          <a:bodyPr wrap="square" lIns="0" tIns="0" rIns="0" bIns="0" rtlCol="0" anchor="t"/>
+          <a:lstStyle/>
+          <a:p>
+            <a:pPr indent="0" marL="0">
+              <a:buNone/>
+            </a:pPr>
+            <a:r>
+              <a:rPr lang="en-US" sz="1000" dirty="0">
+                <a:solidFill>
+                  <a:srgbClr val="93867A"/>
+                </a:solidFill>
+                <a:latin typeface="Calibri" pitchFamily="34" charset="0"/>
+                <a:ea typeface="Calibri" pitchFamily="34" charset="-122"/>
+                <a:cs typeface="Calibri" pitchFamily="34" charset="-120"/>
+              </a:rPr>
+              <a:t>reminder apps, quotes, gentle pings</a:t>
+            </a:r>
+            <a:endParaRPr lang="en-US" sz="1000" dirty="0"/>
+          </a:p>
+        </p:txBody>
+      </p:sp>
+      <p:sp>
+        <p:nvSpPr>
+          <p:cNvPr id="11" name="Shape 9"/>
+          <p:cNvSpPr/>
+          <p:nvPr/>
+        </p:nvSpPr>
+        <p:spPr>
+          <a:xfrm>
+            <a:off x="548640" y="3035808"/>
+            <a:ext cx="118872" cy="118872"/>
+          </a:xfrm>
+          <a:prstGeom prst="ellipse">
+            <a:avLst/>
+          </a:prstGeom>
+          <a:solidFill>
+            <a:srgbClr val="6E9BD1"/>
+          </a:solidFill>
+          <a:ln w="12700">
+            <a:solidFill>
+              <a:srgbClr val="333333"/>
+            </a:solidFill>
+            <a:prstDash val="solid"/>
+          </a:ln>
+        </p:spPr>
+      </p:sp>
+      <p:sp>
+        <p:nvSpPr>
+          <p:cNvPr id="12" name="Text 10"/>
+          <p:cNvSpPr/>
+          <p:nvPr/>
+        </p:nvSpPr>
+        <p:spPr>
+          <a:xfrm>
+            <a:off x="822960" y="2962656"/>
+            <a:ext cx="2377440" cy="274320"/>
+          </a:xfrm>
+          <a:prstGeom prst="rect">
+            <a:avLst/>
+          </a:prstGeom>
+          <a:noFill/>
+          <a:ln/>
+        </p:spPr>
+        <p:txBody>
+          <a:bodyPr wrap="square" lIns="0" tIns="0" rIns="0" bIns="0" rtlCol="0" anchor="ctr"/>
+          <a:lstStyle/>
+          <a:p>
+            <a:pPr indent="0" marL="0">
+              <a:buNone/>
+            </a:pPr>
+            <a:r>
+              <a:rPr lang="en-US" sz="1050" b="1" dirty="0">
+                <a:solidFill>
+                  <a:srgbClr val="EDE4D7"/>
+                </a:solidFill>
+                <a:latin typeface="Courier New" pitchFamily="34" charset="0"/>
+                <a:ea typeface="Courier New" pitchFamily="34" charset="-122"/>
+                <a:cs typeface="Courier New" pitchFamily="34" charset="-120"/>
+              </a:rPr>
+              <a:t>One-Moment Meditation®</a:t>
+            </a:r>
+            <a:endParaRPr lang="en-US" sz="1050" dirty="0"/>
+          </a:p>
+        </p:txBody>
+      </p:sp>
+      <p:sp>
+        <p:nvSpPr>
+          <p:cNvPr id="13" name="Text 11"/>
+          <p:cNvSpPr/>
+          <p:nvPr/>
+        </p:nvSpPr>
+        <p:spPr>
+          <a:xfrm>
+            <a:off x="3200400" y="2962656"/>
+            <a:ext cx="2377440" cy="502920"/>
+          </a:xfrm>
+          <a:prstGeom prst="rect">
+            <a:avLst/>
+          </a:prstGeom>
+          <a:noFill/>
+          <a:ln/>
+        </p:spPr>
+        <p:txBody>
+          <a:bodyPr wrap="square" lIns="0" tIns="0" rIns="0" bIns="0" rtlCol="0" anchor="t"/>
+          <a:lstStyle/>
+          <a:p>
+            <a:pPr indent="0" marL="0">
+              <a:buNone/>
+            </a:pPr>
+            <a:r>
+              <a:rPr lang="en-US" sz="1000" dirty="0">
+                <a:solidFill>
+                  <a:srgbClr val="93867A"/>
+                </a:solidFill>
+                <a:latin typeface="Calibri" pitchFamily="34" charset="0"/>
+                <a:ea typeface="Calibri" pitchFamily="34" charset="-122"/>
+                <a:cs typeface="Calibri" pitchFamily="34" charset="-120"/>
+              </a:rPr>
+              <a:t>a one-minute exercise + reminders — and a registered mark</a:t>
+            </a:r>
+            <a:endParaRPr lang="en-US" sz="1000" dirty="0"/>
+          </a:p>
+        </p:txBody>
+      </p:sp>
+      <p:sp>
+        <p:nvSpPr>
+          <p:cNvPr id="14" name="Shape 12"/>
+          <p:cNvSpPr/>
+          <p:nvPr/>
+        </p:nvSpPr>
+        <p:spPr>
+          <a:xfrm>
+            <a:off x="548640" y="3602736"/>
+            <a:ext cx="118872" cy="118872"/>
+          </a:xfrm>
+          <a:prstGeom prst="ellipse">
+            <a:avLst/>
+          </a:prstGeom>
+          <a:solidFill>
+            <a:srgbClr val="6E9BD1"/>
+          </a:solidFill>
+          <a:ln w="12700">
+            <a:solidFill>
+              <a:srgbClr val="333333"/>
+            </a:solidFill>
+            <a:prstDash val="solid"/>
+          </a:ln>
+        </p:spPr>
+      </p:sp>
+      <p:sp>
+        <p:nvSpPr>
+          <p:cNvPr id="15" name="Text 13"/>
+          <p:cNvSpPr/>
+          <p:nvPr/>
+        </p:nvSpPr>
+        <p:spPr>
+          <a:xfrm>
+            <a:off x="822960" y="3529584"/>
+            <a:ext cx="2377440" cy="274320"/>
+          </a:xfrm>
+          <a:prstGeom prst="rect">
+            <a:avLst/>
+          </a:prstGeom>
+          <a:noFill/>
+          <a:ln/>
+        </p:spPr>
+        <p:txBody>
+          <a:bodyPr wrap="square" lIns="0" tIns="0" rIns="0" bIns="0" rtlCol="0" anchor="ctr"/>
+          <a:lstStyle/>
+          <a:p>
+            <a:pPr indent="0" marL="0">
+              <a:buNone/>
+            </a:pPr>
+            <a:r>
+              <a:rPr lang="en-US" sz="1050" b="1" dirty="0">
+                <a:solidFill>
+                  <a:srgbClr val="EDE4D7"/>
+                </a:solidFill>
+                <a:latin typeface="Courier New" pitchFamily="34" charset="0"/>
+                <a:ea typeface="Courier New" pitchFamily="34" charset="-122"/>
+                <a:cs typeface="Courier New" pitchFamily="34" charset="-120"/>
+              </a:rPr>
+              <a:t>Insight Timer</a:t>
+            </a:r>
+            <a:endParaRPr lang="en-US" sz="1050" dirty="0"/>
+          </a:p>
+        </p:txBody>
+      </p:sp>
+      <p:sp>
+        <p:nvSpPr>
+          <p:cNvPr id="16" name="Text 14"/>
+          <p:cNvSpPr/>
+          <p:nvPr/>
+        </p:nvSpPr>
+        <p:spPr>
+          <a:xfrm>
+            <a:off x="3200400" y="3529584"/>
+            <a:ext cx="2377440" cy="502920"/>
+          </a:xfrm>
+          <a:prstGeom prst="rect">
+            <a:avLst/>
+          </a:prstGeom>
+          <a:noFill/>
+          <a:ln/>
+        </p:spPr>
+        <p:txBody>
+          <a:bodyPr wrap="square" lIns="0" tIns="0" rIns="0" bIns="0" rtlCol="0" anchor="t"/>
+          <a:lstStyle/>
+          <a:p>
+            <a:pPr indent="0" marL="0">
+              <a:buNone/>
+            </a:pPr>
+            <a:r>
+              <a:rPr lang="en-US" sz="1000" dirty="0">
+                <a:solidFill>
+                  <a:srgbClr val="93867A"/>
+                </a:solidFill>
+                <a:latin typeface="Calibri" pitchFamily="34" charset="0"/>
+                <a:ea typeface="Calibri" pitchFamily="34" charset="-122"/>
+                <a:cs typeface="Calibri" pitchFamily="34" charset="-120"/>
+              </a:rPr>
+              <a:t>owns the SERP for “one minute meditation reminder app”</a:t>
+            </a:r>
+            <a:endParaRPr lang="en-US" sz="1000" dirty="0"/>
+          </a:p>
+        </p:txBody>
+      </p:sp>
+      <p:sp>
+        <p:nvSpPr>
+          <p:cNvPr id="17" name="Shape 15"/>
+          <p:cNvSpPr/>
+          <p:nvPr/>
+        </p:nvSpPr>
+        <p:spPr>
+          <a:xfrm>
+            <a:off x="5852160" y="1783080"/>
+            <a:ext cx="2743200" cy="2514600"/>
           </a:xfrm>
           <a:prstGeom prst="rect">
             <a:avLst/>
@@ -4499,14 +4787,14 @@
       </p:sp>
       <p:sp>
         <p:nvSpPr>
-          <p:cNvPr id="10" name="Text 8"/>
-          <p:cNvSpPr/>
-          <p:nvPr/>
-        </p:nvSpPr>
-        <p:spPr>
-          <a:xfrm>
-            <a:off x="5897880" y="1737360"/>
-            <a:ext cx="2560320" cy="274320"/>
+          <p:cNvPr id="18" name="Text 16"/>
+          <p:cNvSpPr/>
+          <p:nvPr/>
+        </p:nvSpPr>
+        <p:spPr>
+          <a:xfrm>
+            <a:off x="6035040" y="1920240"/>
+            <a:ext cx="2468880" cy="274320"/>
           </a:xfrm>
           <a:prstGeom prst="rect">
             <a:avLst/>
@@ -4522,69 +4810,108 @@
               <a:buNone/>
             </a:pPr>
             <a:r>
-              <a:rPr lang="en-US" sz="900" spc="150" kern="0" dirty="0">
-                <a:solidFill>
-                  <a:srgbClr val="6E9BD1"/>
+              <a:rPr lang="en-US" sz="850" spc="150" kern="0" dirty="0">
+                <a:solidFill>
+                  <a:srgbClr val="D9954A"/>
                 </a:solidFill>
                 <a:latin typeface="Courier New" pitchFamily="34" charset="0"/>
                 <a:ea typeface="Courier New" pitchFamily="34" charset="-122"/>
                 <a:cs typeface="Courier New" pitchFamily="34" charset="-120"/>
               </a:rPr>
-              <a:t>THE SEARCH GAP</a:t>
-            </a:r>
-            <a:endParaRPr lang="en-US" sz="900" dirty="0"/>
-          </a:p>
-        </p:txBody>
-      </p:sp>
-      <p:sp>
-        <p:nvSpPr>
-          <p:cNvPr id="11" name="Text 9"/>
-          <p:cNvSpPr/>
-          <p:nvPr/>
-        </p:nvSpPr>
-        <p:spPr>
-          <a:xfrm>
-            <a:off x="5897880" y="2057400"/>
-            <a:ext cx="2560320" cy="548640"/>
-          </a:xfrm>
-          <a:prstGeom prst="rect">
-            <a:avLst/>
-          </a:prstGeom>
-          <a:noFill/>
-          <a:ln/>
-        </p:spPr>
-        <p:txBody>
-          <a:bodyPr wrap="square" lIns="0" tIns="0" rIns="0" bIns="0" rtlCol="0" anchor="ctr"/>
-          <a:lstStyle/>
-          <a:p>
-            <a:pPr indent="0" marL="0">
-              <a:buNone/>
-            </a:pPr>
-            <a:r>
-              <a:rPr lang="en-US" sz="1300" i="1" dirty="0">
-                <a:solidFill>
-                  <a:srgbClr val="EDE4D7"/>
+              <a:t>WHAT NO RESULT OFFERS</a:t>
+            </a:r>
+            <a:endParaRPr lang="en-US" sz="850" dirty="0"/>
+          </a:p>
+        </p:txBody>
+      </p:sp>
+      <p:sp>
+        <p:nvSpPr>
+          <p:cNvPr id="19" name="Text 17"/>
+          <p:cNvSpPr/>
+          <p:nvPr/>
+        </p:nvSpPr>
+        <p:spPr>
+          <a:xfrm>
+            <a:off x="6035040" y="2240280"/>
+            <a:ext cx="2377440" cy="777240"/>
+          </a:xfrm>
+          <a:prstGeom prst="rect">
+            <a:avLst/>
+          </a:prstGeom>
+          <a:noFill/>
+          <a:ln/>
+        </p:spPr>
+        <p:txBody>
+          <a:bodyPr wrap="square" lIns="0" tIns="0" rIns="0" bIns="0" rtlCol="0" anchor="t"/>
+          <a:lstStyle/>
+          <a:p>
+            <a:pPr indent="0" marL="0">
+              <a:buNone/>
+            </a:pPr>
+            <a:r>
+              <a:rPr lang="en-US" sz="1200" i="1" dirty="0">
+                <a:solidFill>
+                  <a:srgbClr val="6E9BD1"/>
                 </a:solidFill>
                 <a:latin typeface="Cambria" pitchFamily="34" charset="0"/>
                 <a:ea typeface="Cambria" pitchFamily="34" charset="-122"/>
                 <a:cs typeface="Cambria" pitchFamily="34" charset="-120"/>
               </a:rPr>
-              <a:t>“how to start meditating without an app”</a:t>
-            </a:r>
-            <a:endParaRPr lang="en-US" sz="1300" dirty="0"/>
-          </a:p>
-        </p:txBody>
-      </p:sp>
-      <p:sp>
-        <p:nvSpPr>
-          <p:cNvPr id="12" name="Text 10"/>
-          <p:cNvSpPr/>
-          <p:nvPr/>
-        </p:nvSpPr>
-        <p:spPr>
-          <a:xfrm>
-            <a:off x="5897880" y="2697480"/>
-            <a:ext cx="2560320" cy="640080"/>
+              <a:t>“My morning yoga includes setting an intention for the day… 23 minutes later I'm in the thick of…”</a:t>
+            </a:r>
+            <a:endParaRPr lang="en-US" sz="1200" dirty="0"/>
+          </a:p>
+        </p:txBody>
+      </p:sp>
+      <p:sp>
+        <p:nvSpPr>
+          <p:cNvPr id="20" name="Text 18"/>
+          <p:cNvSpPr/>
+          <p:nvPr/>
+        </p:nvSpPr>
+        <p:spPr>
+          <a:xfrm>
+            <a:off x="6035040" y="3063240"/>
+            <a:ext cx="2377440" cy="228600"/>
+          </a:xfrm>
+          <a:prstGeom prst="rect">
+            <a:avLst/>
+          </a:prstGeom>
+          <a:noFill/>
+          <a:ln/>
+        </p:spPr>
+        <p:txBody>
+          <a:bodyPr wrap="square" lIns="0" tIns="0" rIns="0" bIns="0" rtlCol="0" anchor="ctr"/>
+          <a:lstStyle/>
+          <a:p>
+            <a:pPr indent="0" marL="0">
+              <a:buNone/>
+            </a:pPr>
+            <a:r>
+              <a:rPr lang="en-US" sz="750" spc="80" kern="0" dirty="0">
+                <a:solidFill>
+                  <a:srgbClr val="3D5573"/>
+                </a:solidFill>
+                <a:latin typeface="Courier New" pitchFamily="34" charset="0"/>
+                <a:ea typeface="Courier New" pitchFamily="34" charset="-122"/>
+                <a:cs typeface="Courier New" pitchFamily="34" charset="-120"/>
+              </a:rPr>
+              <a:t>R/SELFIMPROVEMENT · VIA SERP</a:t>
+            </a:r>
+            <a:endParaRPr lang="en-US" sz="750" dirty="0"/>
+          </a:p>
+        </p:txBody>
+      </p:sp>
+      <p:sp>
+        <p:nvSpPr>
+          <p:cNvPr id="21" name="Text 19"/>
+          <p:cNvSpPr/>
+          <p:nvPr/>
+        </p:nvSpPr>
+        <p:spPr>
+          <a:xfrm>
+            <a:off x="6035040" y="3520440"/>
+            <a:ext cx="2377440" cy="640080"/>
           </a:xfrm>
           <a:prstGeom prst="rect">
             <a:avLst/>
@@ -4600,46 +4927,7 @@
               <a:buNone/>
             </a:pPr>
             <a:r>
-              <a:rPr lang="en-US" sz="1100" dirty="0">
-                <a:solidFill>
-                  <a:srgbClr val="93867A"/>
-                </a:solidFill>
-                <a:latin typeface="Calibri" pitchFamily="34" charset="0"/>
-                <a:ea typeface="Calibri" pitchFamily="34" charset="-122"/>
-                <a:cs typeface="Calibri" pitchFamily="34" charset="-120"/>
-              </a:rPr>
-              <a:t>9 results. Reddit, blogs, a Facebook group, Quora, a Headspace article.</a:t>
-            </a:r>
-            <a:endParaRPr lang="en-US" sz="1100" dirty="0"/>
-          </a:p>
-        </p:txBody>
-      </p:sp>
-      <p:sp>
-        <p:nvSpPr>
-          <p:cNvPr id="13" name="Text 11"/>
-          <p:cNvSpPr/>
-          <p:nvPr/>
-        </p:nvSpPr>
-        <p:spPr>
-          <a:xfrm>
-            <a:off x="5897880" y="3429000"/>
-            <a:ext cx="2560320" cy="365760"/>
-          </a:xfrm>
-          <a:prstGeom prst="rect">
-            <a:avLst/>
-          </a:prstGeom>
-          <a:noFill/>
-          <a:ln/>
-        </p:spPr>
-        <p:txBody>
-          <a:bodyPr wrap="square" lIns="0" tIns="0" rIns="0" bIns="0" rtlCol="0" anchor="ctr"/>
-          <a:lstStyle/>
-          <a:p>
-            <a:pPr indent="0" marL="0">
-              <a:buNone/>
-            </a:pPr>
-            <a:r>
-              <a:rPr lang="en-US" sz="1500" dirty="0">
+              <a:rPr lang="en-US" sz="1300" dirty="0">
                 <a:solidFill>
                   <a:srgbClr val="D9954A"/>
                 </a:solidFill>
@@ -4647,48 +4935,48 @@
                 <a:ea typeface="Cambria" pitchFamily="34" charset="-122"/>
                 <a:cs typeface="Cambria" pitchFamily="34" charset="-120"/>
               </a:rPr>
-              <a:t>Not one of them is a timer.</a:t>
-            </a:r>
-            <a:endParaRPr lang="en-US" sz="1500" dirty="0"/>
-          </a:p>
-        </p:txBody>
-      </p:sp>
-      <p:sp>
-        <p:nvSpPr>
-          <p:cNvPr id="14" name="Text 12"/>
-          <p:cNvSpPr/>
-          <p:nvPr/>
-        </p:nvSpPr>
-        <p:spPr>
-          <a:xfrm>
-            <a:off x="5897880" y="3840480"/>
-            <a:ext cx="2560320" cy="548640"/>
-          </a:xfrm>
-          <a:prstGeom prst="rect">
-            <a:avLst/>
-          </a:prstGeom>
-          <a:noFill/>
-          <a:ln/>
-        </p:spPr>
-        <p:txBody>
-          <a:bodyPr wrap="square" lIns="0" tIns="0" rIns="0" bIns="0" rtlCol="0" anchor="t"/>
-          <a:lstStyle/>
-          <a:p>
-            <a:pPr indent="0" marL="0">
-              <a:buNone/>
-            </a:pPr>
-            <a:r>
-              <a:rPr lang="en-US" sz="1050" dirty="0">
-                <a:solidFill>
-                  <a:srgbClr val="93867A"/>
-                </a:solidFill>
-                <a:latin typeface="Calibri" pitchFamily="34" charset="0"/>
-                <a:ea typeface="Calibri" pitchFamily="34" charset="-122"/>
-                <a:cs typeface="Calibri" pitchFamily="34" charset="-120"/>
-              </a:rPr>
-              <a:t>People are searching for the way out. Nobody is standing there.</a:t>
-            </a:r>
-            <a:endParaRPr lang="en-US" sz="1050" dirty="0"/>
+              <a:t>Remembering your own sentence at the moment it matters.</a:t>
+            </a:r>
+            <a:endParaRPr lang="en-US" sz="1300" dirty="0"/>
+          </a:p>
+        </p:txBody>
+      </p:sp>
+      <p:sp>
+        <p:nvSpPr>
+          <p:cNvPr id="22" name="Text 20"/>
+          <p:cNvSpPr/>
+          <p:nvPr/>
+        </p:nvSpPr>
+        <p:spPr>
+          <a:xfrm>
+            <a:off x="548640" y="4434840"/>
+            <a:ext cx="8046720" cy="365760"/>
+          </a:xfrm>
+          <a:prstGeom prst="rect">
+            <a:avLst/>
+          </a:prstGeom>
+          <a:noFill/>
+          <a:ln/>
+        </p:spPr>
+        <p:txBody>
+          <a:bodyPr wrap="square" lIns="0" tIns="0" rIns="0" bIns="0" rtlCol="0" anchor="ctr"/>
+          <a:lstStyle/>
+          <a:p>
+            <a:pPr indent="0" marL="0">
+              <a:buNone/>
+            </a:pPr>
+            <a:r>
+              <a:rPr lang="en-US" sz="1400" i="1" dirty="0">
+                <a:solidFill>
+                  <a:srgbClr val="EDE4D7"/>
+                </a:solidFill>
+                <a:latin typeface="Cambria" pitchFamily="34" charset="0"/>
+                <a:ea typeface="Cambria" pitchFamily="34" charset="-122"/>
+                <a:cs typeface="Cambria" pitchFamily="34" charset="-120"/>
+              </a:rPr>
+              <a:t>The bell is taken. The minute is taken. The intention is not.</a:t>
+            </a:r>
+            <a:endParaRPr lang="en-US" sz="1400" dirty="0"/>
           </a:p>
         </p:txBody>
       </p:sp>
@@ -4757,7 +5045,7 @@
                 <a:ea typeface="Courier New" pitchFamily="34" charset="-122"/>
                 <a:cs typeface="Courier New" pitchFamily="34" charset="-120"/>
               </a:rPr>
-              <a:t>FIX</a:t>
+              <a:t>THE FIX</a:t>
             </a:r>
             <a:endParaRPr lang="en-US" sz="900" dirty="0"/>
           </a:p>
@@ -4796,7 +5084,7 @@
                 <a:ea typeface="Courier New" pitchFamily="34" charset="-122"/>
                 <a:cs typeface="Courier New" pitchFamily="34" charset="-120"/>
               </a:rPr>
-              <a:t>THE FIX · FIRST BREATH</a:t>
+              <a:t>MOMENT · SHARPENED BY THE DATA</a:t>
             </a:r>
             <a:endParaRPr lang="en-US" sz="900" dirty="0"/>
           </a:p>
@@ -4811,7 +5099,7 @@
         <p:spPr>
           <a:xfrm>
             <a:off x="548640" y="777240"/>
-            <a:ext cx="8046720" cy="914400"/>
+            <a:ext cx="8046720" cy="640080"/>
           </a:xfrm>
           <a:prstGeom prst="rect">
             <a:avLst/>
@@ -4827,7 +5115,7 @@
               <a:buNone/>
             </a:pPr>
             <a:r>
-              <a:rPr lang="en-US" sz="2400" dirty="0">
+              <a:rPr lang="en-US" sz="2600" dirty="0">
                 <a:solidFill>
                   <a:srgbClr val="EDE4D7"/>
                 </a:solidFill>
@@ -4835,9 +5123,9 @@
                 <a:ea typeface="Cambria" pitchFamily="34" charset="-122"/>
                 <a:cs typeface="Cambria" pitchFamily="34" charset="-120"/>
               </a:rPr>
-              <a:t>The data didn't give me a product. It gave me permission to remove everything else.</a:t>
-            </a:r>
-            <a:endParaRPr lang="en-US" sz="2400" dirty="0"/>
+              <a:t>The data didn't confirm the product. It sharpened it.</a:t>
+            </a:r>
+            <a:endParaRPr lang="en-US" sz="2600" dirty="0"/>
           </a:p>
         </p:txBody>
       </p:sp>
@@ -4849,7 +5137,7 @@
         </p:nvSpPr>
         <p:spPr>
           <a:xfrm>
-            <a:off x="548640" y="1828800"/>
+            <a:off x="548640" y="1554480"/>
             <a:ext cx="3657600" cy="228600"/>
           </a:xfrm>
           <a:prstGeom prst="rect">
@@ -4868,13 +5156,13 @@
             <a:r>
               <a:rPr lang="en-US" sz="850" spc="150" kern="0" dirty="0">
                 <a:solidFill>
-                  <a:srgbClr val="93867A"/>
+                  <a:srgbClr val="6E9BD1"/>
                 </a:solidFill>
                 <a:latin typeface="Courier New" pitchFamily="34" charset="0"/>
                 <a:ea typeface="Courier New" pitchFamily="34" charset="-122"/>
                 <a:cs typeface="Courier New" pitchFamily="34" charset="-120"/>
               </a:rPr>
-              <a:t>THE PAIN</a:t>
+              <a:t>WHAT THE WEB SAID</a:t>
             </a:r>
             <a:endParaRPr lang="en-US" sz="850" dirty="0"/>
           </a:p>
@@ -4888,7 +5176,7 @@
         </p:nvSpPr>
         <p:spPr>
           <a:xfrm>
-            <a:off x="4846320" y="1828800"/>
+            <a:off x="4846320" y="1554480"/>
             <a:ext cx="3657600" cy="228600"/>
           </a:xfrm>
           <a:prstGeom prst="rect">
@@ -4913,7 +5201,7 @@
                 <a:ea typeface="Courier New" pitchFamily="34" charset="-122"/>
                 <a:cs typeface="Courier New" pitchFamily="34" charset="-120"/>
               </a:rPr>
-              <a:t>WHAT FIRST BREATH DOES</a:t>
+              <a:t>WHAT MOMENT DOES</a:t>
             </a:r>
             <a:endParaRPr lang="en-US" sz="850" dirty="0"/>
           </a:p>
@@ -4927,8 +5215,47 @@
         </p:nvSpPr>
         <p:spPr>
           <a:xfrm>
-            <a:off x="548640" y="2148840"/>
-            <a:ext cx="3108960" cy="274320"/>
+            <a:off x="548640" y="1874520"/>
+            <a:ext cx="3291840" cy="548640"/>
+          </a:xfrm>
+          <a:prstGeom prst="rect">
+            <a:avLst/>
+          </a:prstGeom>
+          <a:noFill/>
+          <a:ln/>
+        </p:spPr>
+        <p:txBody>
+          <a:bodyPr wrap="square" lIns="0" tIns="0" rIns="0" bIns="0" rtlCol="0" anchor="t"/>
+          <a:lstStyle/>
+          <a:p>
+            <a:pPr indent="0" marL="0">
+              <a:buNone/>
+            </a:pPr>
+            <a:r>
+              <a:rPr lang="en-US" sz="1150" dirty="0">
+                <a:solidFill>
+                  <a:srgbClr val="EDE4D7"/>
+                </a:solidFill>
+                <a:latin typeface="Calibri" pitchFamily="34" charset="0"/>
+                <a:ea typeface="Calibri" pitchFamily="34" charset="-122"/>
+                <a:cs typeface="Calibri" pitchFamily="34" charset="-120"/>
+              </a:rPr>
+              <a:t>Overwhelm — 20% choice overload, 48% billing rage</a:t>
+            </a:r>
+            <a:endParaRPr lang="en-US" sz="1150" dirty="0"/>
+          </a:p>
+        </p:txBody>
+      </p:sp>
+      <p:sp>
+        <p:nvSpPr>
+          <p:cNvPr id="8" name="Text 6"/>
+          <p:cNvSpPr/>
+          <p:nvPr/>
+        </p:nvSpPr>
+        <p:spPr>
+          <a:xfrm>
+            <a:off x="3931920" y="1892808"/>
+            <a:ext cx="548640" cy="320040"/>
           </a:xfrm>
           <a:prstGeom prst="rect">
             <a:avLst/>
@@ -4940,11 +5267,440 @@
           <a:bodyPr wrap="square" lIns="0" tIns="0" rIns="0" bIns="0" rtlCol="0" anchor="ctr"/>
           <a:lstStyle/>
           <a:p>
-            <a:pPr indent="0" marL="0">
-              <a:buNone/>
-            </a:pPr>
-            <a:r>
-              <a:rPr lang="en-US" sz="1300" dirty="0">
+            <a:pPr algn="ctr" indent="0" marL="0">
+              <a:buNone/>
+            </a:pPr>
+            <a:r>
+              <a:rPr lang="en-US" sz="1600" dirty="0">
+                <a:solidFill>
+                  <a:srgbClr val="4A423A"/>
+                </a:solidFill>
+                <a:latin typeface="Calibri" pitchFamily="34" charset="0"/>
+                <a:ea typeface="Calibri" pitchFamily="34" charset="-122"/>
+                <a:cs typeface="Calibri" pitchFamily="34" charset="-120"/>
+              </a:rPr>
+              <a:t>→</a:t>
+            </a:r>
+            <a:endParaRPr lang="en-US" sz="1600" dirty="0"/>
+          </a:p>
+        </p:txBody>
+      </p:sp>
+      <p:sp>
+        <p:nvSpPr>
+          <p:cNvPr id="9" name="Text 7"/>
+          <p:cNvSpPr/>
+          <p:nvPr/>
+        </p:nvSpPr>
+        <p:spPr>
+          <a:xfrm>
+            <a:off x="4846320" y="1874520"/>
+            <a:ext cx="3749040" cy="548640"/>
+          </a:xfrm>
+          <a:prstGeom prst="rect">
+            <a:avLst/>
+          </a:prstGeom>
+          <a:noFill/>
+          <a:ln/>
+        </p:spPr>
+        <p:txBody>
+          <a:bodyPr wrap="square" lIns="0" tIns="0" rIns="0" bIns="0" rtlCol="0" anchor="t"/>
+          <a:lstStyle/>
+          <a:p>
+            <a:pPr indent="0" marL="0">
+              <a:buNone/>
+            </a:pPr>
+            <a:r>
+              <a:rPr lang="en-US" sz="1150" dirty="0">
+                <a:solidFill>
+                  <a:srgbClr val="D9954A"/>
+                </a:solidFill>
+                <a:latin typeface="Calibri" pitchFamily="34" charset="0"/>
+                <a:ea typeface="Calibri" pitchFamily="34" charset="-122"/>
+                <a:cs typeface="Calibri" pitchFamily="34" charset="-120"/>
+              </a:rPr>
+              <a:t>No library. No course. No streak. One sentence and one minute.</a:t>
+            </a:r>
+            <a:endParaRPr lang="en-US" sz="1150" dirty="0"/>
+          </a:p>
+        </p:txBody>
+      </p:sp>
+      <p:sp>
+        <p:nvSpPr>
+          <p:cNvPr id="10" name="Text 8"/>
+          <p:cNvSpPr/>
+          <p:nvPr/>
+        </p:nvSpPr>
+        <p:spPr>
+          <a:xfrm>
+            <a:off x="548640" y="2532888"/>
+            <a:ext cx="3291840" cy="548640"/>
+          </a:xfrm>
+          <a:prstGeom prst="rect">
+            <a:avLst/>
+          </a:prstGeom>
+          <a:noFill/>
+          <a:ln/>
+        </p:spPr>
+        <p:txBody>
+          <a:bodyPr wrap="square" lIns="0" tIns="0" rIns="0" bIns="0" rtlCol="0" anchor="t"/>
+          <a:lstStyle/>
+          <a:p>
+            <a:pPr indent="0" marL="0">
+              <a:buNone/>
+            </a:pPr>
+            <a:r>
+              <a:rPr lang="en-US" sz="1150" dirty="0">
+                <a:solidFill>
+                  <a:srgbClr val="EDE4D7"/>
+                </a:solidFill>
+                <a:latin typeface="Calibri" pitchFamily="34" charset="0"/>
+                <a:ea typeface="Calibri" pitchFamily="34" charset="-122"/>
+                <a:cs typeface="Calibri" pitchFamily="34" charset="-120"/>
+              </a:rPr>
+              <a:t>The gap — calm in the session, reactive in life</a:t>
+            </a:r>
+            <a:endParaRPr lang="en-US" sz="1150" dirty="0"/>
+          </a:p>
+        </p:txBody>
+      </p:sp>
+      <p:sp>
+        <p:nvSpPr>
+          <p:cNvPr id="11" name="Text 9"/>
+          <p:cNvSpPr/>
+          <p:nvPr/>
+        </p:nvSpPr>
+        <p:spPr>
+          <a:xfrm>
+            <a:off x="3931920" y="2551176"/>
+            <a:ext cx="548640" cy="320040"/>
+          </a:xfrm>
+          <a:prstGeom prst="rect">
+            <a:avLst/>
+          </a:prstGeom>
+          <a:noFill/>
+          <a:ln/>
+        </p:spPr>
+        <p:txBody>
+          <a:bodyPr wrap="square" lIns="0" tIns="0" rIns="0" bIns="0" rtlCol="0" anchor="ctr"/>
+          <a:lstStyle/>
+          <a:p>
+            <a:pPr algn="ctr" indent="0" marL="0">
+              <a:buNone/>
+            </a:pPr>
+            <a:r>
+              <a:rPr lang="en-US" sz="1600" dirty="0">
+                <a:solidFill>
+                  <a:srgbClr val="4A423A"/>
+                </a:solidFill>
+                <a:latin typeface="Calibri" pitchFamily="34" charset="0"/>
+                <a:ea typeface="Calibri" pitchFamily="34" charset="-122"/>
+                <a:cs typeface="Calibri" pitchFamily="34" charset="-120"/>
+              </a:rPr>
+              <a:t>→</a:t>
+            </a:r>
+            <a:endParaRPr lang="en-US" sz="1600" dirty="0"/>
+          </a:p>
+        </p:txBody>
+      </p:sp>
+      <p:sp>
+        <p:nvSpPr>
+          <p:cNvPr id="12" name="Text 10"/>
+          <p:cNvSpPr/>
+          <p:nvPr/>
+        </p:nvSpPr>
+        <p:spPr>
+          <a:xfrm>
+            <a:off x="4846320" y="2532888"/>
+            <a:ext cx="3749040" cy="548640"/>
+          </a:xfrm>
+          <a:prstGeom prst="rect">
+            <a:avLst/>
+          </a:prstGeom>
+          <a:noFill/>
+          <a:ln/>
+        </p:spPr>
+        <p:txBody>
+          <a:bodyPr wrap="square" lIns="0" tIns="0" rIns="0" bIns="0" rtlCol="0" anchor="t"/>
+          <a:lstStyle/>
+          <a:p>
+            <a:pPr indent="0" marL="0">
+              <a:buNone/>
+            </a:pPr>
+            <a:r>
+              <a:rPr lang="en-US" sz="1150" dirty="0">
+                <a:solidFill>
+                  <a:srgbClr val="D9954A"/>
+                </a:solidFill>
+                <a:latin typeface="Calibri" pitchFamily="34" charset="0"/>
+                <a:ea typeface="Calibri" pitchFamily="34" charset="-122"/>
+                <a:cs typeface="Calibri" pitchFamily="34" charset="-120"/>
+              </a:rPr>
+              <a:t>The pause happens inside the day: every 30 minutes, in the hours you pick.</a:t>
+            </a:r>
+            <a:endParaRPr lang="en-US" sz="1150" dirty="0"/>
+          </a:p>
+        </p:txBody>
+      </p:sp>
+      <p:sp>
+        <p:nvSpPr>
+          <p:cNvPr id="13" name="Text 11"/>
+          <p:cNvSpPr/>
+          <p:nvPr/>
+        </p:nvSpPr>
+        <p:spPr>
+          <a:xfrm>
+            <a:off x="548640" y="3191256"/>
+            <a:ext cx="3291840" cy="548640"/>
+          </a:xfrm>
+          <a:prstGeom prst="rect">
+            <a:avLst/>
+          </a:prstGeom>
+          <a:noFill/>
+          <a:ln/>
+        </p:spPr>
+        <p:txBody>
+          <a:bodyPr wrap="square" lIns="0" tIns="0" rIns="0" bIns="0" rtlCol="0" anchor="t"/>
+          <a:lstStyle/>
+          <a:p>
+            <a:pPr indent="0" marL="0">
+              <a:buNone/>
+            </a:pPr>
+            <a:r>
+              <a:rPr lang="en-US" sz="1150" dirty="0">
+                <a:solidFill>
+                  <a:srgbClr val="EDE4D7"/>
+                </a:solidFill>
+                <a:latin typeface="Calibri" pitchFamily="34" charset="0"/>
+                <a:ea typeface="Calibri" pitchFamily="34" charset="-122"/>
+                <a:cs typeface="Calibri" pitchFamily="34" charset="-120"/>
+              </a:rPr>
+              <a:t>The pushback — bells and minutes already exist</a:t>
+            </a:r>
+            <a:endParaRPr lang="en-US" sz="1150" dirty="0"/>
+          </a:p>
+        </p:txBody>
+      </p:sp>
+      <p:sp>
+        <p:nvSpPr>
+          <p:cNvPr id="14" name="Text 12"/>
+          <p:cNvSpPr/>
+          <p:nvPr/>
+        </p:nvSpPr>
+        <p:spPr>
+          <a:xfrm>
+            <a:off x="3931920" y="3209544"/>
+            <a:ext cx="548640" cy="320040"/>
+          </a:xfrm>
+          <a:prstGeom prst="rect">
+            <a:avLst/>
+          </a:prstGeom>
+          <a:noFill/>
+          <a:ln/>
+        </p:spPr>
+        <p:txBody>
+          <a:bodyPr wrap="square" lIns="0" tIns="0" rIns="0" bIns="0" rtlCol="0" anchor="ctr"/>
+          <a:lstStyle/>
+          <a:p>
+            <a:pPr algn="ctr" indent="0" marL="0">
+              <a:buNone/>
+            </a:pPr>
+            <a:r>
+              <a:rPr lang="en-US" sz="1600" dirty="0">
+                <a:solidFill>
+                  <a:srgbClr val="4A423A"/>
+                </a:solidFill>
+                <a:latin typeface="Calibri" pitchFamily="34" charset="0"/>
+                <a:ea typeface="Calibri" pitchFamily="34" charset="-122"/>
+                <a:cs typeface="Calibri" pitchFamily="34" charset="-120"/>
+              </a:rPr>
+              <a:t>→</a:t>
+            </a:r>
+            <a:endParaRPr lang="en-US" sz="1600" dirty="0"/>
+          </a:p>
+        </p:txBody>
+      </p:sp>
+      <p:sp>
+        <p:nvSpPr>
+          <p:cNvPr id="15" name="Text 13"/>
+          <p:cNvSpPr/>
+          <p:nvPr/>
+        </p:nvSpPr>
+        <p:spPr>
+          <a:xfrm>
+            <a:off x="4846320" y="3191256"/>
+            <a:ext cx="3749040" cy="548640"/>
+          </a:xfrm>
+          <a:prstGeom prst="rect">
+            <a:avLst/>
+          </a:prstGeom>
+          <a:noFill/>
+          <a:ln/>
+        </p:spPr>
+        <p:txBody>
+          <a:bodyPr wrap="square" lIns="0" tIns="0" rIns="0" bIns="0" rtlCol="0" anchor="t"/>
+          <a:lstStyle/>
+          <a:p>
+            <a:pPr indent="0" marL="0">
+              <a:buNone/>
+            </a:pPr>
+            <a:r>
+              <a:rPr lang="en-US" sz="1150" dirty="0">
+                <a:solidFill>
+                  <a:srgbClr val="D9954A"/>
+                </a:solidFill>
+                <a:latin typeface="Calibri" pitchFamily="34" charset="0"/>
+                <a:ea typeface="Calibri" pitchFamily="34" charset="-122"/>
+                <a:cs typeface="Calibri" pitchFamily="34" charset="-120"/>
+              </a:rPr>
+              <a:t>Moment is not the bell. It is the sentence the bell hands back to you.</a:t>
+            </a:r>
+            <a:endParaRPr lang="en-US" sz="1150" dirty="0"/>
+          </a:p>
+        </p:txBody>
+      </p:sp>
+      <p:sp>
+        <p:nvSpPr>
+          <p:cNvPr id="16" name="Text 14"/>
+          <p:cNvSpPr/>
+          <p:nvPr/>
+        </p:nvSpPr>
+        <p:spPr>
+          <a:xfrm>
+            <a:off x="548640" y="3849624"/>
+            <a:ext cx="3291840" cy="548640"/>
+          </a:xfrm>
+          <a:prstGeom prst="rect">
+            <a:avLst/>
+          </a:prstGeom>
+          <a:noFill/>
+          <a:ln/>
+        </p:spPr>
+        <p:txBody>
+          <a:bodyPr wrap="square" lIns="0" tIns="0" rIns="0" bIns="0" rtlCol="0" anchor="t"/>
+          <a:lstStyle/>
+          <a:p>
+            <a:pPr indent="0" marL="0">
+              <a:buNone/>
+            </a:pPr>
+            <a:r>
+              <a:rPr lang="en-US" sz="1150" dirty="0">
+                <a:solidFill>
+                  <a:srgbClr val="EDE4D7"/>
+                </a:solidFill>
+                <a:latin typeface="Calibri" pitchFamily="34" charset="0"/>
+                <a:ea typeface="Calibri" pitchFamily="34" charset="-122"/>
+                <a:cs typeface="Calibri" pitchFamily="34" charset="-120"/>
+              </a:rPr>
+              <a:t>The unclaimed job — “how to remember my intention?”</a:t>
+            </a:r>
+            <a:endParaRPr lang="en-US" sz="1150" dirty="0"/>
+          </a:p>
+        </p:txBody>
+      </p:sp>
+      <p:sp>
+        <p:nvSpPr>
+          <p:cNvPr id="17" name="Text 15"/>
+          <p:cNvSpPr/>
+          <p:nvPr/>
+        </p:nvSpPr>
+        <p:spPr>
+          <a:xfrm>
+            <a:off x="3931920" y="3867912"/>
+            <a:ext cx="548640" cy="320040"/>
+          </a:xfrm>
+          <a:prstGeom prst="rect">
+            <a:avLst/>
+          </a:prstGeom>
+          <a:noFill/>
+          <a:ln/>
+        </p:spPr>
+        <p:txBody>
+          <a:bodyPr wrap="square" lIns="0" tIns="0" rIns="0" bIns="0" rtlCol="0" anchor="ctr"/>
+          <a:lstStyle/>
+          <a:p>
+            <a:pPr algn="ctr" indent="0" marL="0">
+              <a:buNone/>
+            </a:pPr>
+            <a:r>
+              <a:rPr lang="en-US" sz="1600" dirty="0">
+                <a:solidFill>
+                  <a:srgbClr val="4A423A"/>
+                </a:solidFill>
+                <a:latin typeface="Calibri" pitchFamily="34" charset="0"/>
+                <a:ea typeface="Calibri" pitchFamily="34" charset="-122"/>
+                <a:cs typeface="Calibri" pitchFamily="34" charset="-120"/>
+              </a:rPr>
+              <a:t>→</a:t>
+            </a:r>
+            <a:endParaRPr lang="en-US" sz="1600" dirty="0"/>
+          </a:p>
+        </p:txBody>
+      </p:sp>
+      <p:sp>
+        <p:nvSpPr>
+          <p:cNvPr id="18" name="Text 16"/>
+          <p:cNvSpPr/>
+          <p:nvPr/>
+        </p:nvSpPr>
+        <p:spPr>
+          <a:xfrm>
+            <a:off x="4846320" y="3849624"/>
+            <a:ext cx="3749040" cy="548640"/>
+          </a:xfrm>
+          <a:prstGeom prst="rect">
+            <a:avLst/>
+          </a:prstGeom>
+          <a:noFill/>
+          <a:ln/>
+        </p:spPr>
+        <p:txBody>
+          <a:bodyPr wrap="square" lIns="0" tIns="0" rIns="0" bIns="0" rtlCol="0" anchor="t"/>
+          <a:lstStyle/>
+          <a:p>
+            <a:pPr indent="0" marL="0">
+              <a:buNone/>
+            </a:pPr>
+            <a:r>
+              <a:rPr lang="en-US" sz="1150" dirty="0">
+                <a:solidFill>
+                  <a:srgbClr val="D9954A"/>
+                </a:solidFill>
+                <a:latin typeface="Calibri" pitchFamily="34" charset="0"/>
+                <a:ea typeface="Calibri" pitchFamily="34" charset="-122"/>
+                <a:cs typeface="Calibri" pitchFamily="34" charset="-120"/>
+              </a:rPr>
+              <a:t>Write it once at 7. Meet it again at 9, 9:30, 10… in the act of deciding.</a:t>
+            </a:r>
+            <a:endParaRPr lang="en-US" sz="1150" dirty="0"/>
+          </a:p>
+        </p:txBody>
+      </p:sp>
+      <p:sp>
+        <p:nvSpPr>
+          <p:cNvPr id="19" name="Text 17"/>
+          <p:cNvSpPr/>
+          <p:nvPr/>
+        </p:nvSpPr>
+        <p:spPr>
+          <a:xfrm>
+            <a:off x="548640" y="4572000"/>
+            <a:ext cx="8046720" cy="365760"/>
+          </a:xfrm>
+          <a:prstGeom prst="rect">
+            <a:avLst/>
+          </a:prstGeom>
+          <a:noFill/>
+          <a:ln/>
+        </p:spPr>
+        <p:txBody>
+          <a:bodyPr wrap="square" lIns="0" tIns="0" rIns="0" bIns="0" rtlCol="0" anchor="ctr"/>
+          <a:lstStyle/>
+          <a:p>
+            <a:pPr indent="0" marL="0">
+              <a:buNone/>
+            </a:pPr>
+            <a:r>
+              <a:rPr lang="en-US" sz="1500" i="1" dirty="0">
                 <a:solidFill>
                   <a:srgbClr val="EDE4D7"/>
                 </a:solidFill>
@@ -4952,631 +5708,7 @@
                 <a:ea typeface="Cambria" pitchFamily="34" charset="-122"/>
                 <a:cs typeface="Cambria" pitchFamily="34" charset="-120"/>
               </a:rPr>
-              <a:t>Paywalls, trials, cancel traps</a:t>
-            </a:r>
-            <a:endParaRPr lang="en-US" sz="1300" dirty="0"/>
-          </a:p>
-        </p:txBody>
-      </p:sp>
-      <p:sp>
-        <p:nvSpPr>
-          <p:cNvPr id="8" name="Text 6"/>
-          <p:cNvSpPr/>
-          <p:nvPr/>
-        </p:nvSpPr>
-        <p:spPr>
-          <a:xfrm>
-            <a:off x="548640" y="2423160"/>
-            <a:ext cx="3108960" cy="228600"/>
-          </a:xfrm>
-          <a:prstGeom prst="rect">
-            <a:avLst/>
-          </a:prstGeom>
-          <a:noFill/>
-          <a:ln/>
-        </p:spPr>
-        <p:txBody>
-          <a:bodyPr wrap="square" lIns="0" tIns="0" rIns="0" bIns="0" rtlCol="0" anchor="ctr"/>
-          <a:lstStyle/>
-          <a:p>
-            <a:pPr indent="0" marL="0">
-              <a:buNone/>
-            </a:pPr>
-            <a:r>
-              <a:rPr lang="en-US" sz="850" dirty="0">
-                <a:solidFill>
-                  <a:srgbClr val="6E9BD1"/>
-                </a:solidFill>
-                <a:latin typeface="Courier New" pitchFamily="34" charset="0"/>
-                <a:ea typeface="Courier New" pitchFamily="34" charset="-122"/>
-                <a:cs typeface="Courier New" pitchFamily="34" charset="-120"/>
-              </a:rPr>
-              <a:t>48% of the anger</a:t>
-            </a:r>
-            <a:endParaRPr lang="en-US" sz="850" dirty="0"/>
-          </a:p>
-        </p:txBody>
-      </p:sp>
-      <p:sp>
-        <p:nvSpPr>
-          <p:cNvPr id="9" name="Text 7"/>
-          <p:cNvSpPr/>
-          <p:nvPr/>
-        </p:nvSpPr>
-        <p:spPr>
-          <a:xfrm>
-            <a:off x="3931920" y="2167128"/>
-            <a:ext cx="548640" cy="320040"/>
-          </a:xfrm>
-          <a:prstGeom prst="rect">
-            <a:avLst/>
-          </a:prstGeom>
-          <a:noFill/>
-          <a:ln/>
-        </p:spPr>
-        <p:txBody>
-          <a:bodyPr wrap="square" lIns="0" tIns="0" rIns="0" bIns="0" rtlCol="0" anchor="ctr"/>
-          <a:lstStyle/>
-          <a:p>
-            <a:pPr algn="ctr" indent="0" marL="0">
-              <a:buNone/>
-            </a:pPr>
-            <a:r>
-              <a:rPr lang="en-US" sz="1600" dirty="0">
-                <a:solidFill>
-                  <a:srgbClr val="4A423A"/>
-                </a:solidFill>
-                <a:latin typeface="Calibri" pitchFamily="34" charset="0"/>
-                <a:ea typeface="Calibri" pitchFamily="34" charset="-122"/>
-                <a:cs typeface="Calibri" pitchFamily="34" charset="-120"/>
-              </a:rPr>
-              <a:t>→</a:t>
-            </a:r>
-            <a:endParaRPr lang="en-US" sz="1600" dirty="0"/>
-          </a:p>
-        </p:txBody>
-      </p:sp>
-      <p:sp>
-        <p:nvSpPr>
-          <p:cNvPr id="10" name="Text 8"/>
-          <p:cNvSpPr/>
-          <p:nvPr/>
-        </p:nvSpPr>
-        <p:spPr>
-          <a:xfrm>
-            <a:off x="4846320" y="2148840"/>
-            <a:ext cx="3749040" cy="502920"/>
-          </a:xfrm>
-          <a:prstGeom prst="rect">
-            <a:avLst/>
-          </a:prstGeom>
-          <a:noFill/>
-          <a:ln/>
-        </p:spPr>
-        <p:txBody>
-          <a:bodyPr wrap="square" lIns="0" tIns="0" rIns="0" bIns="0" rtlCol="0" anchor="t"/>
-          <a:lstStyle/>
-          <a:p>
-            <a:pPr indent="0" marL="0">
-              <a:buNone/>
-            </a:pPr>
-            <a:r>
-              <a:rPr lang="en-US" sz="1200" dirty="0">
-                <a:solidFill>
-                  <a:srgbClr val="D9954A"/>
-                </a:solidFill>
-                <a:latin typeface="Calibri" pitchFamily="34" charset="0"/>
-                <a:ea typeface="Calibri" pitchFamily="34" charset="-122"/>
-                <a:cs typeface="Calibri" pitchFamily="34" charset="-120"/>
-              </a:rPr>
-              <a:t>Free. No account. Nothing to cancel.</a:t>
-            </a:r>
-            <a:endParaRPr lang="en-US" sz="1200" dirty="0"/>
-          </a:p>
-        </p:txBody>
-      </p:sp>
-      <p:sp>
-        <p:nvSpPr>
-          <p:cNvPr id="11" name="Text 9"/>
-          <p:cNvSpPr/>
-          <p:nvPr/>
-        </p:nvSpPr>
-        <p:spPr>
-          <a:xfrm>
-            <a:off x="548640" y="2770632"/>
-            <a:ext cx="3108960" cy="274320"/>
-          </a:xfrm>
-          <a:prstGeom prst="rect">
-            <a:avLst/>
-          </a:prstGeom>
-          <a:noFill/>
-          <a:ln/>
-        </p:spPr>
-        <p:txBody>
-          <a:bodyPr wrap="square" lIns="0" tIns="0" rIns="0" bIns="0" rtlCol="0" anchor="ctr"/>
-          <a:lstStyle/>
-          <a:p>
-            <a:pPr indent="0" marL="0">
-              <a:buNone/>
-            </a:pPr>
-            <a:r>
-              <a:rPr lang="en-US" sz="1300" dirty="0">
-                <a:solidFill>
-                  <a:srgbClr val="EDE4D7"/>
-                </a:solidFill>
-                <a:latin typeface="Cambria" pitchFamily="34" charset="0"/>
-                <a:ea typeface="Cambria" pitchFamily="34" charset="-122"/>
-                <a:cs typeface="Cambria" pitchFamily="34" charset="-120"/>
-              </a:rPr>
-              <a:t>Five hundred sessions to choose from</a:t>
-            </a:r>
-            <a:endParaRPr lang="en-US" sz="1300" dirty="0"/>
-          </a:p>
-        </p:txBody>
-      </p:sp>
-      <p:sp>
-        <p:nvSpPr>
-          <p:cNvPr id="12" name="Text 10"/>
-          <p:cNvSpPr/>
-          <p:nvPr/>
-        </p:nvSpPr>
-        <p:spPr>
-          <a:xfrm>
-            <a:off x="548640" y="3044952"/>
-            <a:ext cx="3108960" cy="228600"/>
-          </a:xfrm>
-          <a:prstGeom prst="rect">
-            <a:avLst/>
-          </a:prstGeom>
-          <a:noFill/>
-          <a:ln/>
-        </p:spPr>
-        <p:txBody>
-          <a:bodyPr wrap="square" lIns="0" tIns="0" rIns="0" bIns="0" rtlCol="0" anchor="ctr"/>
-          <a:lstStyle/>
-          <a:p>
-            <a:pPr indent="0" marL="0">
-              <a:buNone/>
-            </a:pPr>
-            <a:r>
-              <a:rPr lang="en-US" sz="850" dirty="0">
-                <a:solidFill>
-                  <a:srgbClr val="6E9BD1"/>
-                </a:solidFill>
-                <a:latin typeface="Courier New" pitchFamily="34" charset="0"/>
-                <a:ea typeface="Courier New" pitchFamily="34" charset="-122"/>
-                <a:cs typeface="Courier New" pitchFamily="34" charset="-120"/>
-              </a:rPr>
-              <a:t>20% — choice overload</a:t>
-            </a:r>
-            <a:endParaRPr lang="en-US" sz="850" dirty="0"/>
-          </a:p>
-        </p:txBody>
-      </p:sp>
-      <p:sp>
-        <p:nvSpPr>
-          <p:cNvPr id="13" name="Text 11"/>
-          <p:cNvSpPr/>
-          <p:nvPr/>
-        </p:nvSpPr>
-        <p:spPr>
-          <a:xfrm>
-            <a:off x="3931920" y="2788920"/>
-            <a:ext cx="548640" cy="320040"/>
-          </a:xfrm>
-          <a:prstGeom prst="rect">
-            <a:avLst/>
-          </a:prstGeom>
-          <a:noFill/>
-          <a:ln/>
-        </p:spPr>
-        <p:txBody>
-          <a:bodyPr wrap="square" lIns="0" tIns="0" rIns="0" bIns="0" rtlCol="0" anchor="ctr"/>
-          <a:lstStyle/>
-          <a:p>
-            <a:pPr algn="ctr" indent="0" marL="0">
-              <a:buNone/>
-            </a:pPr>
-            <a:r>
-              <a:rPr lang="en-US" sz="1600" dirty="0">
-                <a:solidFill>
-                  <a:srgbClr val="4A423A"/>
-                </a:solidFill>
-                <a:latin typeface="Calibri" pitchFamily="34" charset="0"/>
-                <a:ea typeface="Calibri" pitchFamily="34" charset="-122"/>
-                <a:cs typeface="Calibri" pitchFamily="34" charset="-120"/>
-              </a:rPr>
-              <a:t>→</a:t>
-            </a:r>
-            <a:endParaRPr lang="en-US" sz="1600" dirty="0"/>
-          </a:p>
-        </p:txBody>
-      </p:sp>
-      <p:sp>
-        <p:nvSpPr>
-          <p:cNvPr id="14" name="Text 12"/>
-          <p:cNvSpPr/>
-          <p:nvPr/>
-        </p:nvSpPr>
-        <p:spPr>
-          <a:xfrm>
-            <a:off x="4846320" y="2770632"/>
-            <a:ext cx="3749040" cy="502920"/>
-          </a:xfrm>
-          <a:prstGeom prst="rect">
-            <a:avLst/>
-          </a:prstGeom>
-          <a:noFill/>
-          <a:ln/>
-        </p:spPr>
-        <p:txBody>
-          <a:bodyPr wrap="square" lIns="0" tIns="0" rIns="0" bIns="0" rtlCol="0" anchor="t"/>
-          <a:lstStyle/>
-          <a:p>
-            <a:pPr indent="0" marL="0">
-              <a:buNone/>
-            </a:pPr>
-            <a:r>
-              <a:rPr lang="en-US" sz="1200" dirty="0">
-                <a:solidFill>
-                  <a:srgbClr val="D9954A"/>
-                </a:solidFill>
-                <a:latin typeface="Calibri" pitchFamily="34" charset="0"/>
-                <a:ea typeface="Calibri" pitchFamily="34" charset="-122"/>
-                <a:cs typeface="Calibri" pitchFamily="34" charset="-120"/>
-              </a:rPr>
-              <a:t>One practice. There is nothing to choose.</a:t>
-            </a:r>
-            <a:endParaRPr lang="en-US" sz="1200" dirty="0"/>
-          </a:p>
-        </p:txBody>
-      </p:sp>
-      <p:sp>
-        <p:nvSpPr>
-          <p:cNvPr id="15" name="Text 13"/>
-          <p:cNvSpPr/>
-          <p:nvPr/>
-        </p:nvSpPr>
-        <p:spPr>
-          <a:xfrm>
-            <a:off x="548640" y="3392424"/>
-            <a:ext cx="3108960" cy="274320"/>
-          </a:xfrm>
-          <a:prstGeom prst="rect">
-            <a:avLst/>
-          </a:prstGeom>
-          <a:noFill/>
-          <a:ln/>
-        </p:spPr>
-        <p:txBody>
-          <a:bodyPr wrap="square" lIns="0" tIns="0" rIns="0" bIns="0" rtlCol="0" anchor="ctr"/>
-          <a:lstStyle/>
-          <a:p>
-            <a:pPr indent="0" marL="0">
-              <a:buNone/>
-            </a:pPr>
-            <a:r>
-              <a:rPr lang="en-US" sz="1300" dirty="0">
-                <a:solidFill>
-                  <a:srgbClr val="EDE4D7"/>
-                </a:solidFill>
-                <a:latin typeface="Cambria" pitchFamily="34" charset="0"/>
-                <a:ea typeface="Cambria" pitchFamily="34" charset="-122"/>
-                <a:cs typeface="Cambria" pitchFamily="34" charset="-120"/>
-              </a:rPr>
-              <a:t>Streaks, reminders, chat bots</a:t>
-            </a:r>
-            <a:endParaRPr lang="en-US" sz="1300" dirty="0"/>
-          </a:p>
-        </p:txBody>
-      </p:sp>
-      <p:sp>
-        <p:nvSpPr>
-          <p:cNvPr id="16" name="Text 14"/>
-          <p:cNvSpPr/>
-          <p:nvPr/>
-        </p:nvSpPr>
-        <p:spPr>
-          <a:xfrm>
-            <a:off x="548640" y="3666744"/>
-            <a:ext cx="3108960" cy="228600"/>
-          </a:xfrm>
-          <a:prstGeom prst="rect">
-            <a:avLst/>
-          </a:prstGeom>
-          <a:noFill/>
-          <a:ln/>
-        </p:spPr>
-        <p:txBody>
-          <a:bodyPr wrap="square" lIns="0" tIns="0" rIns="0" bIns="0" rtlCol="0" anchor="ctr"/>
-          <a:lstStyle/>
-          <a:p>
-            <a:pPr indent="0" marL="0">
-              <a:buNone/>
-            </a:pPr>
-            <a:r>
-              <a:rPr lang="en-US" sz="850" dirty="0">
-                <a:solidFill>
-                  <a:srgbClr val="6E9BD1"/>
-                </a:solidFill>
-                <a:latin typeface="Courier New" pitchFamily="34" charset="0"/>
-                <a:ea typeface="Courier New" pitchFamily="34" charset="-122"/>
-                <a:cs typeface="Courier New" pitchFamily="34" charset="-120"/>
-              </a:rPr>
-              <a:t>the retention loop</a:t>
-            </a:r>
-            <a:endParaRPr lang="en-US" sz="850" dirty="0"/>
-          </a:p>
-        </p:txBody>
-      </p:sp>
-      <p:sp>
-        <p:nvSpPr>
-          <p:cNvPr id="17" name="Text 15"/>
-          <p:cNvSpPr/>
-          <p:nvPr/>
-        </p:nvSpPr>
-        <p:spPr>
-          <a:xfrm>
-            <a:off x="3931920" y="3410712"/>
-            <a:ext cx="548640" cy="320040"/>
-          </a:xfrm>
-          <a:prstGeom prst="rect">
-            <a:avLst/>
-          </a:prstGeom>
-          <a:noFill/>
-          <a:ln/>
-        </p:spPr>
-        <p:txBody>
-          <a:bodyPr wrap="square" lIns="0" tIns="0" rIns="0" bIns="0" rtlCol="0" anchor="ctr"/>
-          <a:lstStyle/>
-          <a:p>
-            <a:pPr algn="ctr" indent="0" marL="0">
-              <a:buNone/>
-            </a:pPr>
-            <a:r>
-              <a:rPr lang="en-US" sz="1600" dirty="0">
-                <a:solidFill>
-                  <a:srgbClr val="4A423A"/>
-                </a:solidFill>
-                <a:latin typeface="Calibri" pitchFamily="34" charset="0"/>
-                <a:ea typeface="Calibri" pitchFamily="34" charset="-122"/>
-                <a:cs typeface="Calibri" pitchFamily="34" charset="-120"/>
-              </a:rPr>
-              <a:t>→</a:t>
-            </a:r>
-            <a:endParaRPr lang="en-US" sz="1600" dirty="0"/>
-          </a:p>
-        </p:txBody>
-      </p:sp>
-      <p:sp>
-        <p:nvSpPr>
-          <p:cNvPr id="18" name="Text 16"/>
-          <p:cNvSpPr/>
-          <p:nvPr/>
-        </p:nvSpPr>
-        <p:spPr>
-          <a:xfrm>
-            <a:off x="4846320" y="3392424"/>
-            <a:ext cx="3749040" cy="502920"/>
-          </a:xfrm>
-          <a:prstGeom prst="rect">
-            <a:avLst/>
-          </a:prstGeom>
-          <a:noFill/>
-          <a:ln/>
-        </p:spPr>
-        <p:txBody>
-          <a:bodyPr wrap="square" lIns="0" tIns="0" rIns="0" bIns="0" rtlCol="0" anchor="t"/>
-          <a:lstStyle/>
-          <a:p>
-            <a:pPr indent="0" marL="0">
-              <a:buNone/>
-            </a:pPr>
-            <a:r>
-              <a:rPr lang="en-US" sz="1200" dirty="0">
-                <a:solidFill>
-                  <a:srgbClr val="D9954A"/>
-                </a:solidFill>
-                <a:latin typeface="Calibri" pitchFamily="34" charset="0"/>
-                <a:ea typeface="Calibri" pitchFamily="34" charset="-122"/>
-                <a:cs typeface="Calibri" pitchFamily="34" charset="-120"/>
-              </a:rPr>
-              <a:t>No notifications. It never asks you back.</a:t>
-            </a:r>
-            <a:endParaRPr lang="en-US" sz="1200" dirty="0"/>
-          </a:p>
-        </p:txBody>
-      </p:sp>
-      <p:sp>
-        <p:nvSpPr>
-          <p:cNvPr id="19" name="Text 17"/>
-          <p:cNvSpPr/>
-          <p:nvPr/>
-        </p:nvSpPr>
-        <p:spPr>
-          <a:xfrm>
-            <a:off x="548640" y="4014216"/>
-            <a:ext cx="3108960" cy="274320"/>
-          </a:xfrm>
-          <a:prstGeom prst="rect">
-            <a:avLst/>
-          </a:prstGeom>
-          <a:noFill/>
-          <a:ln/>
-        </p:spPr>
-        <p:txBody>
-          <a:bodyPr wrap="square" lIns="0" tIns="0" rIns="0" bIns="0" rtlCol="0" anchor="ctr"/>
-          <a:lstStyle/>
-          <a:p>
-            <a:pPr indent="0" marL="0">
-              <a:buNone/>
-            </a:pPr>
-            <a:r>
-              <a:rPr lang="en-US" sz="1300" dirty="0">
-                <a:solidFill>
-                  <a:srgbClr val="EDE4D7"/>
-                </a:solidFill>
-                <a:latin typeface="Cambria" pitchFamily="34" charset="0"/>
-                <a:ea typeface="Cambria" pitchFamily="34" charset="-122"/>
-                <a:cs typeface="Cambria" pitchFamily="34" charset="-120"/>
-              </a:rPr>
-              <a:t>A library that forgot the idea</a:t>
-            </a:r>
-            <a:endParaRPr lang="en-US" sz="1300" dirty="0"/>
-          </a:p>
-        </p:txBody>
-      </p:sp>
-      <p:sp>
-        <p:nvSpPr>
-          <p:cNvPr id="20" name="Text 18"/>
-          <p:cNvSpPr/>
-          <p:nvPr/>
-        </p:nvSpPr>
-        <p:spPr>
-          <a:xfrm>
-            <a:off x="548640" y="4288536"/>
-            <a:ext cx="3108960" cy="228600"/>
-          </a:xfrm>
-          <a:prstGeom prst="rect">
-            <a:avLst/>
-          </a:prstGeom>
-          <a:noFill/>
-          <a:ln/>
-        </p:spPr>
-        <p:txBody>
-          <a:bodyPr wrap="square" lIns="0" tIns="0" rIns="0" bIns="0" rtlCol="0" anchor="ctr"/>
-          <a:lstStyle/>
-          <a:p>
-            <a:pPr indent="0" marL="0">
-              <a:buNone/>
-            </a:pPr>
-            <a:r>
-              <a:rPr lang="en-US" sz="850" dirty="0">
-                <a:solidFill>
-                  <a:srgbClr val="6E9BD1"/>
-                </a:solidFill>
-                <a:latin typeface="Courier New" pitchFamily="34" charset="0"/>
-                <a:ea typeface="Courier New" pitchFamily="34" charset="-122"/>
-                <a:cs typeface="Courier New" pitchFamily="34" charset="-120"/>
-              </a:rPr>
-              <a:t>14% — lost simplicity</a:t>
-            </a:r>
-            <a:endParaRPr lang="en-US" sz="850" dirty="0"/>
-          </a:p>
-        </p:txBody>
-      </p:sp>
-      <p:sp>
-        <p:nvSpPr>
-          <p:cNvPr id="21" name="Text 19"/>
-          <p:cNvSpPr/>
-          <p:nvPr/>
-        </p:nvSpPr>
-        <p:spPr>
-          <a:xfrm>
-            <a:off x="3931920" y="4032504"/>
-            <a:ext cx="548640" cy="320040"/>
-          </a:xfrm>
-          <a:prstGeom prst="rect">
-            <a:avLst/>
-          </a:prstGeom>
-          <a:noFill/>
-          <a:ln/>
-        </p:spPr>
-        <p:txBody>
-          <a:bodyPr wrap="square" lIns="0" tIns="0" rIns="0" bIns="0" rtlCol="0" anchor="ctr"/>
-          <a:lstStyle/>
-          <a:p>
-            <a:pPr algn="ctr" indent="0" marL="0">
-              <a:buNone/>
-            </a:pPr>
-            <a:r>
-              <a:rPr lang="en-US" sz="1600" dirty="0">
-                <a:solidFill>
-                  <a:srgbClr val="4A423A"/>
-                </a:solidFill>
-                <a:latin typeface="Calibri" pitchFamily="34" charset="0"/>
-                <a:ea typeface="Calibri" pitchFamily="34" charset="-122"/>
-                <a:cs typeface="Calibri" pitchFamily="34" charset="-120"/>
-              </a:rPr>
-              <a:t>→</a:t>
-            </a:r>
-            <a:endParaRPr lang="en-US" sz="1600" dirty="0"/>
-          </a:p>
-        </p:txBody>
-      </p:sp>
-      <p:sp>
-        <p:nvSpPr>
-          <p:cNvPr id="22" name="Text 20"/>
-          <p:cNvSpPr/>
-          <p:nvPr/>
-        </p:nvSpPr>
-        <p:spPr>
-          <a:xfrm>
-            <a:off x="4846320" y="4014216"/>
-            <a:ext cx="3749040" cy="502920"/>
-          </a:xfrm>
-          <a:prstGeom prst="rect">
-            <a:avLst/>
-          </a:prstGeom>
-          <a:noFill/>
-          <a:ln/>
-        </p:spPr>
-        <p:txBody>
-          <a:bodyPr wrap="square" lIns="0" tIns="0" rIns="0" bIns="0" rtlCol="0" anchor="t"/>
-          <a:lstStyle/>
-          <a:p>
-            <a:pPr indent="0" marL="0">
-              <a:buNone/>
-            </a:pPr>
-            <a:r>
-              <a:rPr lang="en-US" sz="1200" dirty="0">
-                <a:solidFill>
-                  <a:srgbClr val="D9954A"/>
-                </a:solidFill>
-                <a:latin typeface="Calibri" pitchFamily="34" charset="0"/>
-                <a:ea typeface="Calibri" pitchFamily="34" charset="-122"/>
-                <a:cs typeface="Calibri" pitchFamily="34" charset="-120"/>
-              </a:rPr>
-              <a:t>A timer and counted breaths. That's the whole product.</a:t>
-            </a:r>
-            <a:endParaRPr lang="en-US" sz="1200" dirty="0"/>
-          </a:p>
-        </p:txBody>
-      </p:sp>
-      <p:sp>
-        <p:nvSpPr>
-          <p:cNvPr id="23" name="Text 21"/>
-          <p:cNvSpPr/>
-          <p:nvPr/>
-        </p:nvSpPr>
-        <p:spPr>
-          <a:xfrm>
-            <a:off x="548640" y="4572000"/>
-            <a:ext cx="8046720" cy="365760"/>
-          </a:xfrm>
-          <a:prstGeom prst="rect">
-            <a:avLst/>
-          </a:prstGeom>
-          <a:noFill/>
-          <a:ln/>
-        </p:spPr>
-        <p:txBody>
-          <a:bodyPr wrap="square" lIns="0" tIns="0" rIns="0" bIns="0" rtlCol="0" anchor="ctr"/>
-          <a:lstStyle/>
-          <a:p>
-            <a:pPr indent="0" marL="0">
-              <a:buNone/>
-            </a:pPr>
-            <a:r>
-              <a:rPr lang="en-US" sz="1500" i="1" dirty="0">
-                <a:solidFill>
-                  <a:srgbClr val="EDE4D7"/>
-                </a:solidFill>
-                <a:latin typeface="Cambria" pitchFamily="34" charset="0"/>
-                <a:ea typeface="Cambria" pitchFamily="34" charset="-122"/>
-                <a:cs typeface="Cambria" pitchFamily="34" charset="-120"/>
-              </a:rPr>
-              <a:t>One timer. Counted breaths. Nothing else.</a:t>
+              <a:t>One intention. One minute. In the moment it matters.</a:t>
             </a:r>
             <a:endParaRPr lang="en-US" sz="1500" dirty="0"/>
           </a:p>
@@ -5701,7 +5833,7 @@
         <p:spPr>
           <a:xfrm>
             <a:off x="548640" y="777240"/>
-            <a:ext cx="7315200" cy="457200"/>
+            <a:ext cx="8046720" cy="457200"/>
           </a:xfrm>
           <a:prstGeom prst="rect">
             <a:avLst/>
@@ -5717,7 +5849,7 @@
               <a:buNone/>
             </a:pPr>
             <a:r>
-              <a:rPr lang="en-US" sz="2200" dirty="0">
+              <a:rPr lang="en-US" sz="2000" dirty="0">
                 <a:solidFill>
                   <a:srgbClr val="EDE4D7"/>
                 </a:solidFill>
@@ -5725,9 +5857,9 @@
                 <a:ea typeface="Courier New" pitchFamily="34" charset="-122"/>
                 <a:cs typeface="Courier New" pitchFamily="34" charset="-120"/>
               </a:rPr>
-              <a:t>node src/run.js</a:t>
-            </a:r>
-            <a:endParaRPr lang="en-US" sz="2200" dirty="0"/>
+              <a:t>node src/run.js · node src/question.js</a:t>
+            </a:r>
+            <a:endParaRPr lang="en-US" sz="2000" dirty="0"/>
           </a:p>
         </p:txBody>
       </p:sp>
@@ -5781,7 +5913,7 @@
               <a:buNone/>
             </a:pPr>
             <a:r>
-              <a:rPr lang="en-US" sz="1150" b="1" dirty="0">
+              <a:rPr lang="en-US" sz="1050" b="1" dirty="0">
                 <a:solidFill>
                   <a:srgbClr val="6E9BD1"/>
                 </a:solidFill>
@@ -5791,7 +5923,7 @@
               </a:rPr>
               <a:t>SERP API</a:t>
             </a:r>
-            <a:endParaRPr lang="en-US" sz="1150" dirty="0"/>
+            <a:endParaRPr lang="en-US" sz="1050" dirty="0"/>
           </a:p>
         </p:txBody>
       </p:sp>
@@ -5828,7 +5960,7 @@
                 <a:ea typeface="Calibri" pitchFamily="34" charset="-122"/>
                 <a:cs typeface="Calibri" pitchFamily="34" charset="-120"/>
               </a:rPr>
-              <a:t>Google results as JSON (brd_json=1). Also mines reddit via site: searches — the only path that works without KYC.</a:t>
+              <a:t>Google results as JSON (brd_json=1). Mines reddit via site: searches — the only path that works without KYC. Ran the 12 hypothesis queries.</a:t>
             </a:r>
             <a:endParaRPr lang="en-US" sz="950" dirty="0"/>
           </a:p>
@@ -5884,7 +6016,7 @@
               <a:buNone/>
             </a:pPr>
             <a:r>
-              <a:rPr lang="en-US" sz="1150" b="1" dirty="0">
+              <a:rPr lang="en-US" sz="1050" b="1" dirty="0">
                 <a:solidFill>
                   <a:srgbClr val="6E9BD1"/>
                 </a:solidFill>
@@ -5894,7 +6026,7 @@
               </a:rPr>
               <a:t>Web Unlocker</a:t>
             </a:r>
-            <a:endParaRPr lang="en-US" sz="1150" dirty="0"/>
+            <a:endParaRPr lang="en-US" sz="1050" dirty="0"/>
           </a:p>
         </p:txBody>
       </p:sp>
@@ -5987,7 +6119,7 @@
               <a:buNone/>
             </a:pPr>
             <a:r>
-              <a:rPr lang="en-US" sz="1150" b="1" dirty="0">
+              <a:rPr lang="en-US" sz="1050" b="1" dirty="0">
                 <a:solidFill>
                   <a:srgbClr val="6E9BD1"/>
                 </a:solidFill>
@@ -5997,7 +6129,7 @@
               </a:rPr>
               <a:t>Apple review feed</a:t>
             </a:r>
-            <a:endParaRPr lang="en-US" sz="1150" dirty="0"/>
+            <a:endParaRPr lang="en-US" sz="1050" dirty="0"/>
           </a:p>
         </p:txBody>
       </p:sp>
@@ -6090,7 +6222,7 @@
               <a:buNone/>
             </a:pPr>
             <a:r>
-              <a:rPr lang="en-US" sz="1150" b="1" dirty="0">
+              <a:rPr lang="en-US" sz="1050" b="1" dirty="0">
                 <a:solidFill>
                   <a:srgbClr val="6E9BD1"/>
                 </a:solidFill>
@@ -6098,9 +6230,9 @@
                 <a:ea typeface="Courier New" pitchFamily="34" charset="-122"/>
                 <a:cs typeface="Courier New" pitchFamily="34" charset="-120"/>
               </a:rPr>
-              <a:t>corpus.json</a:t>
-            </a:r>
-            <a:endParaRPr lang="en-US" sz="1150" dirty="0"/>
+              <a:t>corpus.json · moment-serp.json</a:t>
+            </a:r>
+            <a:endParaRPr lang="en-US" sz="1050" dirty="0"/>
           </a:p>
         </p:txBody>
       </p:sp>
@@ -6137,7 +6269,7 @@
                 <a:ea typeface="Calibri" pitchFamily="34" charset="-122"/>
                 <a:cs typeface="Calibri" pitchFamily="34" charset="-120"/>
               </a:rPr>
-              <a:t>450 reviews · 30 threads · 42 SERP rows. The raw truth.</a:t>
+              <a:t>450 reviews · 30 threads · 146 SERP rows across 17 queries. The raw truth.</a:t>
             </a:r>
             <a:endParaRPr lang="en-US" sz="950" dirty="0"/>
           </a:p>
@@ -6193,7 +6325,7 @@
               <a:buNone/>
             </a:pPr>
             <a:r>
-              <a:rPr lang="en-US" sz="1150" b="1" dirty="0">
+              <a:rPr lang="en-US" sz="1050" b="1" dirty="0">
                 <a:solidFill>
                   <a:srgbClr val="D9954A"/>
                 </a:solidFill>
@@ -6203,7 +6335,7 @@
               </a:rPr>
               <a:t>Claude</a:t>
             </a:r>
-            <a:endParaRPr lang="en-US" sz="1150" dirty="0"/>
+            <a:endParaRPr lang="en-US" sz="1050" dirty="0"/>
           </a:p>
         </p:txBody>
       </p:sp>
@@ -6240,7 +6372,7 @@
                 <a:ea typeface="Calibri" pitchFamily="34" charset="-122"/>
                 <a:cs typeface="Calibri" pitchFamily="34" charset="-120"/>
               </a:rPr>
-              <a:t>Distills clusters, verbatim quotes, insights → research.json. Degrades to a paste-in prompt without API credits.</a:t>
+              <a:t>Distills clusters, verbatim quotes, verdicts → research.json. Degrades to a paste-in prompt without API credits.</a:t>
             </a:r>
             <a:endParaRPr lang="en-US" sz="950" dirty="0"/>
           </a:p>
@@ -6296,7 +6428,7 @@
               <a:buNone/>
             </a:pPr>
             <a:r>
-              <a:rPr lang="en-US" sz="1150" b="1" dirty="0">
+              <a:rPr lang="en-US" sz="1050" b="1" dirty="0">
                 <a:solidFill>
                   <a:srgbClr val="D9954A"/>
                 </a:solidFill>
@@ -6306,7 +6438,7 @@
               </a:rPr>
               <a:t>page/index.html</a:t>
             </a:r>
-            <a:endParaRPr lang="en-US" sz="1150" dirty="0"/>
+            <a:endParaRPr lang="en-US" sz="1050" dirty="0"/>
           </a:p>
         </p:txBody>
       </p:sp>
@@ -6343,7 +6475,7 @@
                 <a:ea typeface="Calibri" pitchFamily="34" charset="-122"/>
                 <a:cs typeface="Calibri" pitchFamily="34" charset="-120"/>
               </a:rPr>
-              <a:t>research.json injected into one self-contained file. The proof becomes the pitch.</a:t>
+              <a:t>research.json injected into one self-contained file. The proof becomes the pitch — and ends in a live Moment.</a:t>
             </a:r>
             <a:endParaRPr lang="en-US" sz="950" dirty="0"/>
           </a:p>
@@ -6545,7 +6677,7 @@
                 <a:ea typeface="Cambria" pitchFamily="34" charset="-122"/>
                 <a:cs typeface="Cambria" pitchFamily="34" charset="-120"/>
               </a:rPr>
-              <a:t>The landing page tells the same story — and ends with the product itself.</a:t>
+              <a:t>The landing page tells the same story — and ends with one real Moment.</a:t>
             </a:r>
             <a:endParaRPr lang="en-US" sz="2400" dirty="0"/>
           </a:p>
@@ -6758,7 +6890,7 @@
                 <a:ea typeface="Cambria" pitchFamily="34" charset="-122"/>
                 <a:cs typeface="Cambria" pitchFamily="34" charset="-120"/>
               </a:rPr>
-              <a:t>The instinct</a:t>
+              <a:t>The hypothesis</a:t>
             </a:r>
             <a:endParaRPr lang="en-US" sz="1300" dirty="0"/>
           </a:p>
@@ -6797,7 +6929,7 @@
                 <a:ea typeface="Calibri" pitchFamily="34" charset="-122"/>
                 <a:cs typeface="Calibri" pitchFamily="34" charset="-120"/>
               </a:rPr>
-              <a:t>start a timer, count breaths</a:t>
+              <a:t>two things are broken</a:t>
             </a:r>
             <a:endParaRPr lang="en-US" sz="950" dirty="0"/>
           </a:p>
@@ -6923,7 +7055,7 @@
                 <a:ea typeface="Calibri" pitchFamily="34" charset="-122"/>
                 <a:cs typeface="Calibri" pitchFamily="34" charset="-120"/>
               </a:rPr>
-              <a:t>three sources, live counts</a:t>
+              <a:t>three sources, queries built to refute</a:t>
             </a:r>
             <a:endParaRPr lang="en-US" sz="950" dirty="0"/>
           </a:p>
@@ -7049,7 +7181,7 @@
                 <a:ea typeface="Calibri" pitchFamily="34" charset="-122"/>
                 <a:cs typeface="Calibri" pitchFamily="34" charset="-120"/>
               </a:rPr>
-              <a:t>verbatim quotes → 48 / 20 / 14</a:t>
+              <a:t>half held, half pushed back</a:t>
             </a:r>
             <a:endParaRPr lang="en-US" sz="950" dirty="0"/>
           </a:p>
@@ -7175,7 +7307,7 @@
                 <a:ea typeface="Calibri" pitchFamily="34" charset="-122"/>
                 <a:cs typeface="Calibri" pitchFamily="34" charset="-120"/>
               </a:rPr>
-              <a:t>permission to keep it simple</a:t>
+              <a:t>one intention, one minute</a:t>
             </a:r>
             <a:endParaRPr lang="en-US" sz="950" dirty="0"/>
           </a:p>
@@ -7239,7 +7371,7 @@
                 <a:ea typeface="Cambria" pitchFamily="34" charset="-122"/>
                 <a:cs typeface="Cambria" pitchFamily="34" charset="-120"/>
               </a:rPr>
-              <a:t>Breathe</a:t>
+              <a:t>One moment</a:t>
             </a:r>
             <a:endParaRPr lang="en-US" sz="1300" dirty="0"/>
           </a:p>
@@ -7278,7 +7410,7 @@
                 <a:ea typeface="Calibri" pitchFamily="34" charset="-122"/>
                 <a:cs typeface="Calibri" pitchFamily="34" charset="-120"/>
               </a:rPr>
-              <a:t>ten breaths, together, right now</a:t>
+              <a:t>write a sentence, breathe 60 s, meet it again</a:t>
             </a:r>
             <a:endParaRPr lang="en-US" sz="950" dirty="0"/>
           </a:p>
@@ -7317,7 +7449,7 @@
                 <a:ea typeface="Cambria" pitchFamily="34" charset="-122"/>
                 <a:cs typeface="Cambria" pitchFamily="34" charset="-120"/>
               </a:rPr>
-              <a:t>Every quote and number on the page is the same research.json you just saw. When the story ends, the audience does the practice — that is the demo.</a:t>
+              <a:t>Every quote and number on the page is the same research.json you just saw. When the story ends, the room writes one sentence and takes one minute — that is the demo.</a:t>
             </a:r>
             <a:endParaRPr lang="en-US" sz="1400" dirty="0"/>
           </a:p>

</xml_diff>

<commit_message>
Step 4+5: deck rebuilt in the eight-beat arc (10 slides, computed clusters, real request shapes, exact ask.js output), validated and rendered; talk rewritten beat-for-beat, proxy read 3:57; 'thick of it' corrected to the verbatim snippet; stage PNGs + PDF
Co-Authored-By: Claude Fable 5 <noreply@anthropic.com>
</commit_message>
<xml_diff>
--- a/docs/first-breath-how-it-works.pptx
+++ b/docs/first-breath-how-it-works.pptx
@@ -180,10 +180,10 @@
                 <c:ptCount val="3"/>
                 <c:lvl>
                   <c:pt idx="0">
-                    <c:v>Lost simplicity</c:v>
+                    <c:v>Choice overload</c:v>
                   </c:pt>
                   <c:pt idx="1">
-                    <c:v>Choice overload</c:v>
+                    <c:v>Lost simplicity</c:v>
                   </c:pt>
                   <c:pt idx="2">
                     <c:v>Paywall fatigue</c:v>
@@ -199,13 +199,13 @@
                 <c:formatCode>General</c:formatCode>
                 <c:ptCount val="3"/>
                 <c:pt idx="0">
-                  <c:v>14</c:v>
+                  <c:v>16</c:v>
                 </c:pt>
                 <c:pt idx="1">
-                  <c:v>20</c:v>
+                  <c:v>17</c:v>
                 </c:pt>
                 <c:pt idx="2">
-                  <c:v>48</c:v>
+                  <c:v>52</c:v>
                 </c:pt>
               </c:numCache>
             </c:numRef>
@@ -284,7 +284,7 @@
         <c:axId val="2094734552"/>
         <c:scaling>
           <c:orientation val="minMax"/>
-          <c:max val="60"/>
+          <c:max val="65"/>
         </c:scaling>
         <c:delete val="1"/>
         <c:axPos val="b"/>
@@ -739,7 +739,7 @@
           <a:p>
             <a:r>
               <a:rPr lang="en-US" dirty="0"/>
-              <a:t>This is a how-to. Moment is the example, not the subject. Promise: by the end you can run the same loop on your own idea tonight.</a:t>
+              <a:t>Beat 1 — the pain. Meditation apps sell calm and deliver a marketplace; even when it works, the calm stays on the cushion. Then: this is a how-to. Moment is the example, Bright Data is the subject.</a:t>
             </a:r>
             <a:endParaRPr lang="en-US" dirty="0"/>
           </a:p>
@@ -827,7 +827,7 @@
           <a:p>
             <a:r>
               <a:rPr lang="en-US" dirty="0"/>
-              <a:t/>
+              <a:t>Close. Repo is public. Thank you.</a:t>
             </a:r>
             <a:endParaRPr lang="en-US" dirty="0"/>
           </a:p>
@@ -915,7 +915,7 @@
           <a:p>
             <a:r>
               <a:rPr lang="en-US" dirty="0"/>
-              <a:t/>
+              <a:t>Beat 2 — the bet. Two sentences of hypothesis, one product. The question for tonight is not "is Moment good" — it is how you make the web argue with you before you build.</a:t>
             </a:r>
             <a:endParaRPr lang="en-US" dirty="0"/>
           </a:p>
@@ -1003,7 +1003,7 @@
           <a:p>
             <a:r>
               <a:rPr lang="en-US" dirty="0"/>
-              <a:t/>
+              <a:t>Beat 3 + 4 — prove me wrong, the three calls. One Bearer token. SERP with brd_json=1: zero HTML. Web Scraper API: trigger, poll, snapshot — structured rows. Unlocker: the page body, and an honest "no" where the zone is policy-gated.</a:t>
             </a:r>
             <a:endParaRPr lang="en-US" dirty="0"/>
           </a:p>
@@ -1091,7 +1091,7 @@
           <a:p>
             <a:r>
               <a:rPr lang="en-US" dirty="0"/>
-              <a:t/>
+              <a:t>Still beat 3. The pattern is the thing to take home: bucket the queries, a third written to refute, reddit via site: through SERP.</a:t>
             </a:r>
             <a:endParaRPr lang="en-US" dirty="0"/>
           </a:p>
@@ -1179,7 +1179,7 @@
           <a:p>
             <a:r>
               <a:rPr lang="en-US" dirty="0"/>
-              <a:t/>
+              <a:t>Beat 5 — what held. 52 / 17 / 16, computed by a regex file anyone can rerun. Play agrees. H2 from a daily meditator: still reactive. And the community prescribes the bridge themselves.</a:t>
             </a:r>
             <a:endParaRPr lang="en-US" dirty="0"/>
           </a:p>
@@ -1267,7 +1267,7 @@
           <a:p>
             <a:r>
               <a:rPr lang="en-US" dirty="0"/>
-              <a:t/>
+              <a:t>Beat 6 — what pushed back. The slide that paid for the evening. A wrong positioning and a trademark collision caught before launch.</a:t>
             </a:r>
             <a:endParaRPr lang="en-US" dirty="0"/>
           </a:p>
@@ -1355,7 +1355,7 @@
           <a:p>
             <a:r>
               <a:rPr lang="en-US" dirty="0"/>
-              <a:t/>
+              <a:t>Beat 7 — the sharpened product. Every line on the right is a response to a verbatim line on the left.</a:t>
             </a:r>
             <a:endParaRPr lang="en-US" dirty="0"/>
           </a:p>
@@ -1443,7 +1443,7 @@
           <a:p>
             <a:r>
               <a:rPr lang="en-US" dirty="0"/>
-              <a:t>Switch to the terminal. `cd engine &amp;&amp; node src/ask.js "&lt;query from the room&gt;"`. If wifi dies, this slide IS the output.</a:t>
+              <a:t>Switch to the terminal: cd engine &amp;&amp; node src/ask.js "&lt;query from the room&gt;". If Google captcha-s the zone you will see retries; if it fails, `node src/ask.js --cached "how to remember my intention for the day"` prints this exact output, labelled cached. If wifi dies, this slide IS the output (collected Aug 22, 2026).</a:t>
             </a:r>
             <a:endParaRPr lang="en-US" dirty="0"/>
           </a:p>
@@ -1531,7 +1531,7 @@
           <a:p>
             <a:r>
               <a:rPr lang="en-US" dirty="0"/>
-              <a:t>If there is time: open the artifact, scroll to the last scene, run the one-minute Moment with the room. If not, skip — the live API call was the demo.</a:t>
+              <a:t>Beat 8 — the room does it. Open the artifact at the last scene. Ask the room to write one sentence. Press Enter. Silence for a minute. Escape aborts if needed.</a:t>
             </a:r>
             <a:endParaRPr lang="en-US" dirty="0"/>
           </a:p>
@@ -1912,7 +1912,7 @@
         </p:nvSpPr>
         <p:spPr>
           <a:xfrm>
-            <a:off x="3826764" y="534924"/>
+            <a:off x="3826764" y="397764"/>
             <a:ext cx="1399032" cy="1399032"/>
           </a:xfrm>
           <a:prstGeom prst="ellipse">
@@ -1939,7 +1939,7 @@
         </p:nvSpPr>
         <p:spPr>
           <a:xfrm>
-            <a:off x="4114800" y="822960"/>
+            <a:off x="4114800" y="685800"/>
             <a:ext cx="822960" cy="822960"/>
           </a:xfrm>
           <a:prstGeom prst="ellipse">
@@ -1964,7 +1964,7 @@
         </p:nvSpPr>
         <p:spPr>
           <a:xfrm>
-            <a:off x="457200" y="1920240"/>
+            <a:off x="457200" y="1783080"/>
             <a:ext cx="8229600" cy="1280160"/>
           </a:xfrm>
           <a:prstGeom prst="rect">
@@ -2020,8 +2020,8 @@
         </p:nvSpPr>
         <p:spPr>
           <a:xfrm>
-            <a:off x="914400" y="3246120"/>
-            <a:ext cx="7315200" cy="457200"/>
+            <a:off x="914400" y="3154680"/>
+            <a:ext cx="7315200" cy="685800"/>
           </a:xfrm>
           <a:prstGeom prst="rect">
             <a:avLst/>
@@ -2045,7 +2045,7 @@
                 <a:ea typeface="Cambria" pitchFamily="34" charset="-122"/>
                 <a:cs typeface="Cambria" pitchFamily="34" charset="-120"/>
               </a:rPr>
-              <a:t>SERP API · Web Unlocker · a Node script · a product idea I was too attached to</a:t>
+              <a:t>Twenty minutes of calm on the cushion. Then the day happens — and you snap at your kid anyway.</a:t>
             </a:r>
             <a:endParaRPr lang="en-US" sz="1600" dirty="0"/>
           </a:p>
@@ -2059,8 +2059,8 @@
         </p:nvSpPr>
         <p:spPr>
           <a:xfrm>
-            <a:off x="1371600" y="3749040"/>
-            <a:ext cx="6400800" cy="457200"/>
+            <a:off x="914400" y="3840480"/>
+            <a:ext cx="7315200" cy="365760"/>
           </a:xfrm>
           <a:prstGeom prst="rect">
             <a:avLst/>
@@ -2084,7 +2084,7 @@
                 <a:ea typeface="Calibri" pitchFamily="34" charset="-122"/>
                 <a:cs typeface="Calibri" pitchFamily="34" charset="-120"/>
               </a:rPr>
-              <a:t>Worked example: Moment (moment.szlezingier.com) — meditation inside the day, not beside it</a:t>
+              <a:t>SERP API · Web Scraper API · Web Unlocker · a Node script · a coding agent · a product idea I was too attached to</a:t>
             </a:r>
             <a:endParaRPr lang="en-US" sz="1200" dirty="0"/>
           </a:p>
@@ -2123,7 +2123,7 @@
                 <a:ea typeface="Courier New" pitchFamily="34" charset="-122"/>
                 <a:cs typeface="Courier New" pitchFamily="34" charset="-120"/>
               </a:rPr>
-              <a:t>BRIGHT DATA GTM EVENT · AUG 22, 2026 · KEW</a:t>
+              <a:t>BRIGHT DATA GTM EVENT · AUG 22, 2026 · KEW · MOMENT.SZLEZINGIER.COM</a:t>
             </a:r>
             <a:endParaRPr lang="en-US" sz="900" dirty="0"/>
           </a:p>
@@ -2285,7 +2285,7 @@
                 <a:ea typeface="Cambria" pitchFamily="34" charset="-122"/>
                 <a:cs typeface="Cambria" pitchFamily="34" charset="-120"/>
               </a:rPr>
-              <a:t>1 · Write the hypothesis in two sentences</a:t>
+              <a:t>1 · Two sentences of hypothesis</a:t>
             </a:r>
             <a:endParaRPr lang="en-US" sz="1300" dirty="0"/>
           </a:p>
@@ -2300,7 +2300,7 @@
         <p:spPr>
           <a:xfrm>
             <a:off x="548640" y="2834640"/>
-            <a:ext cx="2560320" cy="548640"/>
+            <a:ext cx="2560320" cy="731520"/>
           </a:xfrm>
           <a:prstGeom prst="rect">
             <a:avLst/>
@@ -2363,7 +2363,7 @@
                 <a:ea typeface="Cambria" pitchFamily="34" charset="-122"/>
                 <a:cs typeface="Cambria" pitchFamily="34" charset="-120"/>
               </a:rPr>
-              <a:t>2 · SERP API, brd_json=1</a:t>
+              <a:t>2 · Three APIs, each for its job</a:t>
             </a:r>
             <a:endParaRPr lang="en-US" sz="1300" dirty="0"/>
           </a:p>
@@ -2378,7 +2378,7 @@
         <p:spPr>
           <a:xfrm>
             <a:off x="3291840" y="2834640"/>
-            <a:ext cx="2560320" cy="548640"/>
+            <a:ext cx="2560320" cy="731520"/>
           </a:xfrm>
           <a:prstGeom prst="rect">
             <a:avLst/>
@@ -2402,7 +2402,7 @@
                 <a:ea typeface="Calibri" pitchFamily="34" charset="-122"/>
                 <a:cs typeface="Calibri" pitchFamily="34" charset="-120"/>
               </a:rPr>
-              <a:t>site: your community. Bucket gap / want / competition.</a:t>
+              <a:t>SERP with brd_json=1 · site: your community · Web Scraper for the rows · Unlocker for the page.</a:t>
             </a:r>
             <a:endParaRPr lang="en-US" sz="1050" dirty="0"/>
           </a:p>
@@ -2456,7 +2456,7 @@
         <p:spPr>
           <a:xfrm>
             <a:off x="6035040" y="2834640"/>
-            <a:ext cx="2560320" cy="548640"/>
+            <a:ext cx="2560320" cy="731520"/>
           </a:xfrm>
           <a:prstGeom prst="rect">
             <a:avLst/>
@@ -2494,8 +2494,8 @@
         </p:nvSpPr>
         <p:spPr>
           <a:xfrm>
-            <a:off x="731520" y="3611880"/>
-            <a:ext cx="7680960" cy="548640"/>
+            <a:off x="365760" y="4434840"/>
+            <a:ext cx="8412480" cy="274320"/>
           </a:xfrm>
           <a:prstGeom prst="rect">
             <a:avLst/>
@@ -2511,46 +2511,7 @@
               <a:buNone/>
             </a:pPr>
             <a:r>
-              <a:rPr lang="en-US" sz="1050" dirty="0">
-                <a:solidFill>
-                  <a:srgbClr val="93867A"/>
-                </a:solidFill>
-                <a:latin typeface="Calibri" pitchFamily="34" charset="0"/>
-                <a:ea typeface="Calibri" pitchFamily="34" charset="-122"/>
-                <a:cs typeface="Calibri" pitchFamily="34" charset="-120"/>
-              </a:rPr>
-              <a:t>Next for me: KYC so Unlocker reaches reddit + Apple directly · Web Scraper API for Play-store reviews at scale · Bright Data MCP so Claude runs this loop in conversation.</a:t>
-            </a:r>
-            <a:endParaRPr lang="en-US" sz="1050" dirty="0"/>
-          </a:p>
-        </p:txBody>
-      </p:sp>
-      <p:sp>
-        <p:nvSpPr>
-          <p:cNvPr id="12" name="Text 10"/>
-          <p:cNvSpPr/>
-          <p:nvPr/>
-        </p:nvSpPr>
-        <p:spPr>
-          <a:xfrm>
-            <a:off x="731520" y="4389120"/>
-            <a:ext cx="7680960" cy="274320"/>
-          </a:xfrm>
-          <a:prstGeom prst="rect">
-            <a:avLst/>
-          </a:prstGeom>
-          <a:noFill/>
-          <a:ln/>
-        </p:spPr>
-        <p:txBody>
-          <a:bodyPr wrap="square" lIns="0" tIns="0" rIns="0" bIns="0" rtlCol="0" anchor="ctr"/>
-          <a:lstStyle/>
-          <a:p>
-            <a:pPr algn="ctr" indent="0" marL="0">
-              <a:buNone/>
-            </a:pPr>
-            <a:r>
-              <a:rPr lang="en-US" sz="850" dirty="0">
+              <a:rPr lang="en-US" sz="750" dirty="0">
                 <a:solidFill>
                   <a:srgbClr val="4A423A"/>
                 </a:solidFill>
@@ -2558,9 +2519,9 @@
                 <a:ea typeface="Courier New" pitchFamily="34" charset="-122"/>
                 <a:cs typeface="Courier New" pitchFamily="34" charset="-120"/>
               </a:rPr>
-              <a:t>github.com/kewinzaq1/first-breath  ·  moment.szlezingier.com  ·  built with Bright Data SERP API · Apple's public review feed · Claude</a:t>
-            </a:r>
-            <a:endParaRPr lang="en-US" sz="850" dirty="0"/>
+              <a:t>github.com/kewinzaq1/first-breath · moment.szlezingier.com · Bright Data SERP API · Web Scraper API · Web Unlocker · Apple's public feed · Claude</a:t>
+            </a:r>
+            <a:endParaRPr lang="en-US" sz="750" dirty="0"/>
           </a:p>
         </p:txBody>
       </p:sp>
@@ -2604,8 +2565,8 @@
         </p:nvSpPr>
         <p:spPr>
           <a:xfrm>
-            <a:off x="6766560" y="457200"/>
-            <a:ext cx="1828800" cy="274320"/>
+            <a:off x="5852160" y="457200"/>
+            <a:ext cx="2743200" cy="274320"/>
           </a:xfrm>
           <a:prstGeom prst="rect">
             <a:avLst/>
@@ -2629,7 +2590,7 @@
                 <a:ea typeface="Courier New" pitchFamily="34" charset="-122"/>
                 <a:cs typeface="Courier New" pitchFamily="34" charset="-120"/>
               </a:rPr>
-              <a:t>THE IDEA</a:t>
+              <a:t>THE BET</a:t>
             </a:r>
             <a:endParaRPr lang="en-US" sz="900" dirty="0"/>
           </a:p>
@@ -2732,7 +2693,7 @@
           </a:solidFill>
           <a:ln w="12700">
             <a:solidFill>
-              <a:srgbClr val="6E9BD1"/>
+              <a:srgbClr val="333333"/>
             </a:solidFill>
             <a:prstDash val="solid"/>
           </a:ln>
@@ -2810,7 +2771,7 @@
                 <a:ea typeface="Calibri" pitchFamily="34" charset="-122"/>
                 <a:cs typeface="Calibri" pitchFamily="34" charset="-120"/>
               </a:rPr>
-              <a:t>Meditation apps bury people in content and choice. Ten thousand apps, forty-day challenges, a guru for every mood.</a:t>
+              <a:t>Meditation apps bury people in content and choice. Ten thousand sessions, streaks, paywalls, a guru for every mood.</a:t>
             </a:r>
             <a:endParaRPr lang="en-US" sz="1050" dirty="0"/>
           </a:p>
@@ -2835,7 +2796,7 @@
           </a:solidFill>
           <a:ln w="12700">
             <a:solidFill>
-              <a:srgbClr val="6E9BD1"/>
+              <a:srgbClr val="333333"/>
             </a:solidFill>
             <a:prstDash val="solid"/>
           </a:ln>
@@ -2913,7 +2874,7 @@
                 <a:ea typeface="Calibri" pitchFamily="34" charset="-122"/>
                 <a:cs typeface="Calibri" pitchFamily="34" charset="-120"/>
               </a:rPr>
-              <a:t>The calm stays in the session. Twenty minutes on the cushion — then the same snap, the same second plate, the same midnight scroll.</a:t>
+              <a:t>The calm stays in the session. Twenty minutes on the cushion — then the same snap, the same second plate, the same 2am scroll.</a:t>
             </a:r>
             <a:endParaRPr lang="en-US" sz="1050" dirty="0"/>
           </a:p>
@@ -3016,7 +2977,7 @@
                 <a:ea typeface="Calibri" pitchFamily="34" charset="-122"/>
                 <a:cs typeface="Calibri" pitchFamily="34" charset="-120"/>
               </a:rPr>
-              <a:t>One sentence about how you want to move through today. A pause every 30 minutes. One minute to choose again.</a:t>
+              <a:t>One sentence about how you want to move through today. A pause every 30 minutes. One minute to breathe and choose again.</a:t>
             </a:r>
             <a:endParaRPr lang="en-US" sz="1050" dirty="0"/>
           </a:p>
@@ -3055,7 +3016,7 @@
                 <a:ea typeface="Cambria" pitchFamily="34" charset="-122"/>
                 <a:cs typeface="Cambria" pitchFamily="34" charset="-120"/>
               </a:rPr>
-              <a:t>The question for tonight is not “is Moment good”. It is: how do you make the web argue with you — cheaply, honestly, before you build?</a:t>
+              <a:t>Meditation inside the day, not beside it. That was the bet. But a bet is not a business — so before telling anyone, I asked the web to break it.</a:t>
             </a:r>
             <a:endParaRPr lang="en-US" sz="1500" dirty="0"/>
           </a:p>
@@ -3101,8 +3062,8 @@
         </p:nvSpPr>
         <p:spPr>
           <a:xfrm>
-            <a:off x="6766560" y="457200"/>
-            <a:ext cx="1828800" cy="274320"/>
+            <a:off x="5852160" y="457200"/>
+            <a:ext cx="2743200" cy="274320"/>
           </a:xfrm>
           <a:prstGeom prst="rect">
             <a:avLst/>
@@ -3126,7 +3087,7 @@
                 <a:ea typeface="Courier New" pitchFamily="34" charset="-122"/>
                 <a:cs typeface="Courier New" pitchFamily="34" charset="-120"/>
               </a:rPr>
-              <a:t>THE APIs</a:t>
+              <a:t>THE THREE CALLS</a:t>
             </a:r>
             <a:endParaRPr lang="en-US" sz="900" dirty="0"/>
           </a:p>
@@ -3165,7 +3126,7 @@
                 <a:ea typeface="Courier New" pitchFamily="34" charset="-122"/>
                 <a:cs typeface="Courier New" pitchFamily="34" charset="-120"/>
               </a:rPr>
-              <a:t>BRIGHT DATA · EVERYTHING I NEEDED WAS ONE ENDPOINT</a:t>
+              <a:t>BRIGHT DATA · THREE APIS, EACH FOR WHAT IT IS BEST AT</a:t>
             </a:r>
             <a:endParaRPr lang="en-US" sz="900" dirty="0"/>
           </a:p>
@@ -3196,7 +3157,7 @@
               <a:buNone/>
             </a:pPr>
             <a:r>
-              <a:rPr lang="en-US" sz="2600" dirty="0">
+              <a:rPr lang="en-US" sz="2400" dirty="0">
                 <a:solidFill>
                   <a:srgbClr val="EDE4D7"/>
                 </a:solidFill>
@@ -3204,9 +3165,9 @@
                 <a:ea typeface="Cambria" pitchFamily="34" charset="-122"/>
                 <a:cs typeface="Cambria" pitchFamily="34" charset="-120"/>
               </a:rPr>
-              <a:t>Three ways in. I used two, and wired the third.</a:t>
-            </a:r>
-            <a:endParaRPr lang="en-US" sz="2600" dirty="0"/>
+              <a:t>I asked the web to prove me wrong. Three calls did the asking.</a:t>
+            </a:r>
+            <a:endParaRPr lang="en-US" sz="2400" dirty="0"/>
           </a:p>
         </p:txBody>
       </p:sp>
@@ -3218,8 +3179,8 @@
         </p:nvSpPr>
         <p:spPr>
           <a:xfrm>
-            <a:off x="548640" y="1554480"/>
-            <a:ext cx="3931920" cy="1600200"/>
+            <a:off x="548640" y="1508760"/>
+            <a:ext cx="3931920" cy="1965960"/>
           </a:xfrm>
           <a:prstGeom prst="rect">
             <a:avLst/>
@@ -3243,8 +3204,8 @@
         </p:nvSpPr>
         <p:spPr>
           <a:xfrm>
-            <a:off x="713232" y="1664208"/>
-            <a:ext cx="3602736" cy="1380744"/>
+            <a:off x="713232" y="1618488"/>
+            <a:ext cx="3602736" cy="1746504"/>
           </a:xfrm>
           <a:prstGeom prst="rect">
             <a:avLst/>
@@ -3311,7 +3272,7 @@
                 <a:ea typeface="Courier New" pitchFamily="34" charset="-122"/>
                 <a:cs typeface="Courier New" pitchFamily="34" charset="-120"/>
               </a:rPr>
-              <a:t>{ zone: SERP_ZONE,</a:t>
+              <a:t>{ zone: SERP_ZONE, format: "raw",</a:t>
             </a:r>
             <a:endParaRPr lang="en-US" sz="850" dirty="0"/>
           </a:p>
@@ -3331,7 +3292,7 @@
                 <a:ea typeface="Courier New" pitchFamily="34" charset="-122"/>
                 <a:cs typeface="Courier New" pitchFamily="34" charset="-120"/>
               </a:rPr>
-              <a:t>  url: "google.com/search?q=…&amp;brd_json=1",</a:t>
+              <a:t>  url: "google.com/search?q=…&amp;brd_json=1" }</a:t>
             </a:r>
             <a:endParaRPr lang="en-US" sz="850" dirty="0"/>
           </a:p>
@@ -3351,7 +3312,7 @@
                 <a:ea typeface="Courier New" pitchFamily="34" charset="-122"/>
                 <a:cs typeface="Courier New" pitchFamily="34" charset="-120"/>
               </a:rPr>
-              <a:t>  format: "raw" }</a:t>
+              <a:t>→ { organic:[{rank,title,link,description}],</a:t>
             </a:r>
             <a:endParaRPr lang="en-US" sz="850" dirty="0"/>
           </a:p>
@@ -3371,7 +3332,7 @@
                 <a:ea typeface="Courier New" pitchFamily="34" charset="-122"/>
                 <a:cs typeface="Courier New" pitchFamily="34" charset="-120"/>
               </a:rPr>
-              <a:t>→ { organic:[{rank,title,link,description}],</a:t>
+              <a:t>    people_also_ask:[…], related:[…] }</a:t>
             </a:r>
             <a:endParaRPr lang="en-US" sz="850" dirty="0"/>
           </a:p>
@@ -3382,6 +3343,15 @@
               </a:lnSpc>
               <a:buNone/>
             </a:pPr>
+            <a:endParaRPr lang="en-US" sz="850" dirty="0"/>
+          </a:p>
+          <a:p>
+            <a:pPr indent="0" marL="0">
+              <a:lnSpc>
+                <a:spcPct val="115000"/>
+              </a:lnSpc>
+              <a:buNone/>
+            </a:pPr>
             <a:r>
               <a:rPr lang="en-US" sz="850" dirty="0">
                 <a:solidFill>
@@ -3391,10 +3361,30 @@
                 <a:ea typeface="Courier New" pitchFamily="34" charset="-122"/>
                 <a:cs typeface="Courier New" pitchFamily="34" charset="-120"/>
               </a:rPr>
-              <a:t>    people_also_ask:[…], related:[…] }</a:t>
+              <a:t># served: 146 search rows (17 queries) +</a:t>
             </a:r>
             <a:endParaRPr lang="en-US" sz="850" dirty="0"/>
           </a:p>
+          <a:p>
+            <a:pPr indent="0" marL="0">
+              <a:lnSpc>
+                <a:spcPct val="115000"/>
+              </a:lnSpc>
+              <a:buNone/>
+            </a:pPr>
+            <a:r>
+              <a:rPr lang="en-US" sz="850" dirty="0">
+                <a:solidFill>
+                  <a:srgbClr val="EDE4D7"/>
+                </a:solidFill>
+                <a:latin typeface="Courier New" pitchFamily="34" charset="0"/>
+                <a:ea typeface="Courier New" pitchFamily="34" charset="-122"/>
+                <a:cs typeface="Courier New" pitchFamily="34" charset="-120"/>
+              </a:rPr>
+              <a:t># 30 reddit threads via site:reddit.com/r/…</a:t>
+            </a:r>
+            <a:endParaRPr lang="en-US" sz="850" dirty="0"/>
+          </a:p>
         </p:txBody>
       </p:sp>
       <p:sp>
@@ -3405,8 +3395,8 @@
         </p:nvSpPr>
         <p:spPr>
           <a:xfrm>
-            <a:off x="548640" y="3246120"/>
-            <a:ext cx="3931920" cy="1325880"/>
+            <a:off x="4663440" y="1508760"/>
+            <a:ext cx="3931920" cy="1965960"/>
           </a:xfrm>
           <a:prstGeom prst="rect">
             <a:avLst/>
@@ -3430,8 +3420,8 @@
         </p:nvSpPr>
         <p:spPr>
           <a:xfrm>
-            <a:off x="713232" y="3355848"/>
-            <a:ext cx="3602736" cy="1106424"/>
+            <a:off x="4828032" y="1618488"/>
+            <a:ext cx="3602736" cy="1746504"/>
           </a:xfrm>
           <a:prstGeom prst="rect">
             <a:avLst/>
@@ -3458,7 +3448,7 @@
                 <a:ea typeface="Courier New" pitchFamily="34" charset="-122"/>
                 <a:cs typeface="Courier New" pitchFamily="34" charset="-120"/>
               </a:rPr>
-              <a:t>// 2 · Web Unlocker — any URL, blocks handled</a:t>
+              <a:t>// 2 · Web Scraper API — structured, async</a:t>
             </a:r>
             <a:endParaRPr lang="en-US" sz="850" dirty="0"/>
           </a:p>
@@ -3478,7 +3468,7 @@
                 <a:ea typeface="Courier New" pitchFamily="34" charset="-122"/>
                 <a:cs typeface="Courier New" pitchFamily="34" charset="-120"/>
               </a:rPr>
-              <a:t>POST api.brightdata.com/request</a:t>
+              <a:t>POST /datasets/v3/trigger?dataset_id=gd_m6zagkt…</a:t>
             </a:r>
             <a:endParaRPr lang="en-US" sz="850" dirty="0"/>
           </a:p>
@@ -3498,7 +3488,7 @@
                 <a:ea typeface="Courier New" pitchFamily="34" charset="-122"/>
                 <a:cs typeface="Courier New" pitchFamily="34" charset="-120"/>
               </a:rPr>
-              <a:t>{ zone: UNLOCKER_ZONE, url, format: "raw" }</a:t>
+              <a:t>  [{ url: "…/details?id=com.calm.android" }, ×3]</a:t>
             </a:r>
             <a:endParaRPr lang="en-US" sz="850" dirty="0"/>
           </a:p>
@@ -3518,7 +3508,7 @@
                 <a:ea typeface="Courier New" pitchFamily="34" charset="-122"/>
                 <a:cs typeface="Courier New" pitchFamily="34" charset="-120"/>
               </a:rPr>
-              <a:t>→ the page body. Errors are PLAIN TEXT —</a:t>
+              <a:t>→ { snapshot_id }</a:t>
             </a:r>
             <a:endParaRPr lang="en-US" sz="850" dirty="0"/>
           </a:p>
@@ -3538,10 +3528,79 @@
                 <a:ea typeface="Courier New" pitchFamily="34" charset="-122"/>
                 <a:cs typeface="Courier New" pitchFamily="34" charset="-120"/>
               </a:rPr>
-              <a:t>  always surface a snippet, never JSON.parse blindly.</a:t>
+              <a:t>GET /datasets/v3/progress/{id}           (poll)</a:t>
             </a:r>
             <a:endParaRPr lang="en-US" sz="850" dirty="0"/>
           </a:p>
+          <a:p>
+            <a:pPr indent="0" marL="0">
+              <a:lnSpc>
+                <a:spcPct val="115000"/>
+              </a:lnSpc>
+              <a:buNone/>
+            </a:pPr>
+            <a:r>
+              <a:rPr lang="en-US" sz="850" dirty="0">
+                <a:solidFill>
+                  <a:srgbClr val="EDE4D7"/>
+                </a:solidFill>
+                <a:latin typeface="Courier New" pitchFamily="34" charset="0"/>
+                <a:ea typeface="Courier New" pitchFamily="34" charset="-122"/>
+                <a:cs typeface="Courier New" pitchFamily="34" charset="-120"/>
+              </a:rPr>
+              <a:t>GET /datasets/v3/snapshot/{id}?format=json</a:t>
+            </a:r>
+            <a:endParaRPr lang="en-US" sz="850" dirty="0"/>
+          </a:p>
+          <a:p>
+            <a:pPr indent="0" marL="0">
+              <a:lnSpc>
+                <a:spcPct val="115000"/>
+              </a:lnSpc>
+              <a:buNone/>
+            </a:pPr>
+            <a:r>
+              <a:rPr lang="en-US" sz="850" dirty="0">
+                <a:solidFill>
+                  <a:srgbClr val="EDE4D7"/>
+                </a:solidFill>
+                <a:latin typeface="Courier New" pitchFamily="34" charset="0"/>
+                <a:ea typeface="Courier New" pitchFamily="34" charset="-122"/>
+                <a:cs typeface="Courier New" pitchFamily="34" charset="-120"/>
+              </a:rPr>
+              <a:t>→ [{ review_rating, review, reviewer_name, … }]</a:t>
+            </a:r>
+            <a:endParaRPr lang="en-US" sz="850" dirty="0"/>
+          </a:p>
+          <a:p>
+            <a:pPr indent="0" marL="0">
+              <a:lnSpc>
+                <a:spcPct val="115000"/>
+              </a:lnSpc>
+              <a:buNone/>
+            </a:pPr>
+            <a:endParaRPr lang="en-US" sz="850" dirty="0"/>
+          </a:p>
+          <a:p>
+            <a:pPr indent="0" marL="0">
+              <a:lnSpc>
+                <a:spcPct val="115000"/>
+              </a:lnSpc>
+              <a:buNone/>
+            </a:pPr>
+            <a:r>
+              <a:rPr lang="en-US" sz="850" dirty="0">
+                <a:solidFill>
+                  <a:srgbClr val="EDE4D7"/>
+                </a:solidFill>
+                <a:latin typeface="Courier New" pitchFamily="34" charset="0"/>
+                <a:ea typeface="Courier New" pitchFamily="34" charset="-122"/>
+                <a:cs typeface="Courier New" pitchFamily="34" charset="-120"/>
+              </a:rPr>
+              <a:t># served: 300 reviews · 100 per app · 179 s · 0 errors</a:t>
+            </a:r>
+            <a:endParaRPr lang="en-US" sz="850" dirty="0"/>
+          </a:p>
         </p:txBody>
       </p:sp>
       <p:sp>
@@ -3552,8 +3611,8 @@
         </p:nvSpPr>
         <p:spPr>
           <a:xfrm>
-            <a:off x="4663440" y="1554480"/>
-            <a:ext cx="3931920" cy="1600200"/>
+            <a:off x="548640" y="3611880"/>
+            <a:ext cx="3931920" cy="1234440"/>
           </a:xfrm>
           <a:prstGeom prst="rect">
             <a:avLst/>
@@ -3577,8 +3636,8 @@
         </p:nvSpPr>
         <p:spPr>
           <a:xfrm>
-            <a:off x="4828032" y="1664208"/>
-            <a:ext cx="3602736" cy="1380744"/>
+            <a:off x="713232" y="3721608"/>
+            <a:ext cx="3602736" cy="1014984"/>
           </a:xfrm>
           <a:prstGeom prst="rect">
             <a:avLst/>
@@ -3605,7 +3664,7 @@
                 <a:ea typeface="Courier New" pitchFamily="34" charset="-122"/>
                 <a:cs typeface="Courier New" pitchFamily="34" charset="-120"/>
               </a:rPr>
-              <a:t>// 3 · Web Scraper API — structured, async</a:t>
+              <a:t>// 3 · Web Unlocker — any URL, blocks handled</a:t>
             </a:r>
             <a:endParaRPr lang="en-US" sz="850" dirty="0"/>
           </a:p>
@@ -3625,7 +3684,7 @@
                 <a:ea typeface="Courier New" pitchFamily="34" charset="-122"/>
                 <a:cs typeface="Courier New" pitchFamily="34" charset="-120"/>
               </a:rPr>
-              <a:t>POST /datasets/v3/trigger?dataset_id=…</a:t>
+              <a:t>POST api.brightdata.com/request</a:t>
             </a:r>
             <a:endParaRPr lang="en-US" sz="850" dirty="0"/>
           </a:p>
@@ -3645,7 +3704,7 @@
                 <a:ea typeface="Courier New" pitchFamily="34" charset="-122"/>
                 <a:cs typeface="Courier New" pitchFamily="34" charset="-120"/>
               </a:rPr>
-              <a:t>→ snapshot_id</a:t>
+              <a:t>{ zone: UNLOCKER_ZONE, url, format: "raw" } → body</a:t>
             </a:r>
             <a:endParaRPr lang="en-US" sz="850" dirty="0"/>
           </a:p>
@@ -3665,7 +3724,7 @@
                 <a:ea typeface="Courier New" pitchFamily="34" charset="-122"/>
                 <a:cs typeface="Courier New" pitchFamily="34" charset="-120"/>
               </a:rPr>
-              <a:t>GET  /datasets/v3/progress/{id}  (poll)</a:t>
+              <a:t># served: play.google.com 3/3 · 200 OK · ~1.2 MB</a:t>
             </a:r>
             <a:endParaRPr lang="en-US" sz="850" dirty="0"/>
           </a:p>
@@ -3685,50 +3744,10 @@
                 <a:ea typeface="Courier New" pitchFamily="34" charset="-122"/>
                 <a:cs typeface="Courier New" pitchFamily="34" charset="-120"/>
               </a:rPr>
-              <a:t>GET  /datasets/v3/snapshot/{id}?format=json</a:t>
+              <a:t># refused: apple + reddit hosts (KYC) → fallbacks</a:t>
             </a:r>
             <a:endParaRPr lang="en-US" sz="850" dirty="0"/>
           </a:p>
-          <a:p>
-            <a:pPr indent="0" marL="0">
-              <a:lnSpc>
-                <a:spcPct val="115000"/>
-              </a:lnSpc>
-              <a:buNone/>
-            </a:pPr>
-            <a:r>
-              <a:rPr lang="en-US" sz="850" dirty="0">
-                <a:solidFill>
-                  <a:srgbClr val="EDE4D7"/>
-                </a:solidFill>
-                <a:latin typeface="Courier New" pitchFamily="34" charset="0"/>
-                <a:ea typeface="Courier New" pitchFamily="34" charset="-122"/>
-                <a:cs typeface="Courier New" pitchFamily="34" charset="-120"/>
-              </a:rPr>
-              <a:t>// wired in brightdata.js; the upgrade path for</a:t>
-            </a:r>
-            <a:endParaRPr lang="en-US" sz="850" dirty="0"/>
-          </a:p>
-          <a:p>
-            <a:pPr indent="0" marL="0">
-              <a:lnSpc>
-                <a:spcPct val="115000"/>
-              </a:lnSpc>
-              <a:buNone/>
-            </a:pPr>
-            <a:r>
-              <a:rPr lang="en-US" sz="850" dirty="0">
-                <a:solidFill>
-                  <a:srgbClr val="EDE4D7"/>
-                </a:solidFill>
-                <a:latin typeface="Courier New" pitchFamily="34" charset="0"/>
-                <a:ea typeface="Courier New" pitchFamily="34" charset="-122"/>
-                <a:cs typeface="Courier New" pitchFamily="34" charset="-120"/>
-              </a:rPr>
-              <a:t>// app-store / Play reviews at scale</a:t>
-            </a:r>
-            <a:endParaRPr lang="en-US" sz="850" dirty="0"/>
-          </a:p>
         </p:txBody>
       </p:sp>
       <p:sp>
@@ -3739,8 +3758,8 @@
         </p:nvSpPr>
         <p:spPr>
           <a:xfrm>
-            <a:off x="4663440" y="3246120"/>
-            <a:ext cx="3931920" cy="1325880"/>
+            <a:off x="4663440" y="3611880"/>
+            <a:ext cx="3931920" cy="1234440"/>
           </a:xfrm>
           <a:prstGeom prst="rect">
             <a:avLst/>
@@ -3764,7 +3783,7 @@
                 <a:ea typeface="Cambria" pitchFamily="34" charset="-122"/>
                 <a:cs typeface="Cambria" pitchFamily="34" charset="-120"/>
               </a:rPr>
-              <a:t>Why this matters for a hypothesis test
+              <a:t>The rule that makes it a test
 </a:t>
             </a:r>
             <a:endParaRPr lang="en-US" sz="1300" dirty="0"/>
@@ -3782,7 +3801,7 @@
                 <a:ea typeface="Calibri" pitchFamily="34" charset="-122"/>
                 <a:cs typeface="Calibri" pitchFamily="34" charset="-120"/>
               </a:rPr>
-              <a:t>SERP with brd_json=1 means zero HTML parsing anywhere in the pipeline. One Bearer token, one endpoint, ~1.8 s per query. The whole engine is ~300 lines of Node with a single dependency.</a:t>
+              <a:t>Every output file records which path served it (`via`). Apple's 450 reviews came from Apple's public feed, not Bright Data — and the page says so. Errors arrive as HTTP 200 with the truth in x-brd-error-code; surface it, never JSON.parse blindly.</a:t>
             </a:r>
             <a:endParaRPr lang="en-US" sz="1300" dirty="0"/>
           </a:p>
@@ -3828,8 +3847,8 @@
         </p:nvSpPr>
         <p:spPr>
           <a:xfrm>
-            <a:off x="6766560" y="457200"/>
-            <a:ext cx="1828800" cy="274320"/>
+            <a:off x="5852160" y="457200"/>
+            <a:ext cx="2743200" cy="274320"/>
           </a:xfrm>
           <a:prstGeom prst="rect">
             <a:avLst/>
@@ -3853,7 +3872,7 @@
                 <a:ea typeface="Courier New" pitchFamily="34" charset="-122"/>
                 <a:cs typeface="Courier New" pitchFamily="34" charset="-120"/>
               </a:rPr>
-              <a:t>PATTERN 1</a:t>
+              <a:t>PROVE ME WRONG · THE PATTERN</a:t>
             </a:r>
             <a:endParaRPr lang="en-US" sz="900" dirty="0"/>
           </a:p>
@@ -3931,7 +3950,7 @@
                 <a:ea typeface="Cambria" pitchFamily="34" charset="-122"/>
                 <a:cs typeface="Cambria" pitchFamily="34" charset="-120"/>
               </a:rPr>
-              <a:t>If you only search for people who agree, the web will happily agree.</a:t>
+              <a:t>Search only for people who agree, and the web will agree.</a:t>
             </a:r>
             <a:endParaRPr lang="en-US" sz="2400" dirty="0"/>
           </a:p>
@@ -4138,7 +4157,7 @@
                 <a:ea typeface="Courier New" pitchFamily="34" charset="-122"/>
                 <a:cs typeface="Courier New" pitchFamily="34" charset="-120"/>
               </a:rPr>
-              <a:t>                 "one minute meditation reminder app" ],  // ← meant to hurt</a:t>
+              <a:t>                 "one minute meditation reminder app" ], // ← to hurt</a:t>
             </a:r>
             <a:endParaRPr lang="en-US" sz="850" dirty="0"/>
           </a:p>
@@ -4235,7 +4254,7 @@
                 <a:ea typeface="Calibri" pitchFamily="34" charset="-122"/>
                 <a:cs typeface="Calibri" pitchFamily="34" charset="-120"/>
               </a:rPr>
-              <a:t>Bucket your queries: </a:t>
+              <a:t>Bucket the queries: </a:t>
             </a:r>
             <a:pPr indent="0" marL="0">
               <a:buNone/>
@@ -4281,7 +4300,7 @@
                 <a:ea typeface="Calibri" pitchFamily="34" charset="-122"/>
                 <a:cs typeface="Calibri" pitchFamily="34" charset="-120"/>
               </a:rPr>
-              <a:t>reddit.com is KYC-gated on Web Unlocker. `site:reddit.com/r/Meditation …` through the SERP zone gives you titles + snippets of the exact threads, no KYC, no HTML.</a:t>
+              <a:t>reddit.com is KYC-gated on the Unlocker. `site:reddit.com/r/Meditation …` through the SERP zone gives you titles + snippets of the exact threads — no KYC, no HTML.</a:t>
             </a:r>
             <a:endParaRPr lang="en-US" sz="1300" dirty="0"/>
           </a:p>
@@ -4320,7 +4339,7 @@
                 <a:ea typeface="Courier New" pitchFamily="34" charset="-122"/>
                 <a:cs typeface="Courier New" pitchFamily="34" charset="-120"/>
               </a:rPr>
-              <a:t>12 queries · 104 rows · ~25 seconds · src/question.js</a:t>
+              <a:t>12 queries · 104 rows · ~25 seconds · engine/src/question.js</a:t>
             </a:r>
             <a:endParaRPr lang="en-US" sz="900" dirty="0"/>
           </a:p>
@@ -4366,8 +4385,8 @@
         </p:nvSpPr>
         <p:spPr>
           <a:xfrm>
-            <a:off x="6766560" y="457200"/>
-            <a:ext cx="1828800" cy="274320"/>
+            <a:off x="5852160" y="457200"/>
+            <a:ext cx="2743200" cy="274320"/>
           </a:xfrm>
           <a:prstGeom prst="rect">
             <a:avLst/>
@@ -4391,7 +4410,7 @@
                 <a:ea typeface="Courier New" pitchFamily="34" charset="-122"/>
                 <a:cs typeface="Courier New" pitchFamily="34" charset="-120"/>
               </a:rPr>
-              <a:t>PATTERN 2</a:t>
+              <a:t>WHAT HELD</a:t>
             </a:r>
             <a:endParaRPr lang="en-US" sz="900" dirty="0"/>
           </a:p>
@@ -4406,7 +4425,7 @@
         <p:spPr>
           <a:xfrm>
             <a:off x="548640" y="457200"/>
-            <a:ext cx="7315200" cy="274320"/>
+            <a:ext cx="6400800" cy="274320"/>
           </a:xfrm>
           <a:prstGeom prst="rect">
             <a:avLst/>
@@ -4430,7 +4449,7 @@
                 <a:ea typeface="Courier New" pitchFamily="34" charset="-122"/>
                 <a:cs typeface="Courier New" pitchFamily="34" charset="-120"/>
               </a:rPr>
-              <a:t>PATTERN · EVERY SOURCE GETS A FALLBACK, AND THE PAGE SAYS WHICH PATH SERVED</a:t>
+              <a:t>RESULT · BOTH HALVES HELD — IN THEIR OWN WORDS</a:t>
             </a:r>
             <a:endParaRPr lang="en-US" sz="900" dirty="0"/>
           </a:p>
@@ -4445,7 +4464,7 @@
         <p:spPr>
           <a:xfrm>
             <a:off x="548640" y="777240"/>
-            <a:ext cx="8046720" cy="640080"/>
+            <a:ext cx="8046720" cy="914400"/>
           </a:xfrm>
           <a:prstGeom prst="rect">
             <a:avLst/>
@@ -4469,22 +4488,38 @@
                 <a:ea typeface="Cambria" pitchFamily="34" charset="-122"/>
                 <a:cs typeface="Cambria" pitchFamily="34" charset="-120"/>
               </a:rPr>
-              <a:t>Zones have policies. Design for the “no” before you get it.</a:t>
+              <a:t>H1: people ask for less. H2: the calm really does stay on the cushion.</a:t>
             </a:r>
             <a:endParaRPr lang="en-US" sz="2400" dirty="0"/>
           </a:p>
         </p:txBody>
       </p:sp>
-      <p:sp>
-        <p:nvSpPr>
-          <p:cNvPr id="5" name="Text 3"/>
-          <p:cNvSpPr/>
-          <p:nvPr/>
-        </p:nvSpPr>
-        <p:spPr>
-          <a:xfrm>
-            <a:off x="548640" y="1554480"/>
-            <a:ext cx="1920240" cy="228600"/>
+      <p:graphicFrame>
+        <p:nvGraphicFramePr>
+          <p:cNvPr id="5" name="Chart 0" descr=""/>
+          <p:cNvGraphicFramePr/>
+          <p:nvPr/>
+        </p:nvGraphicFramePr>
+        <p:xfrm>
+          <a:off x="457200" y="1691640"/>
+          <a:ext cx="3840480" cy="2148840"/>
+        </p:xfrm>
+        <a:graphic xmlns:a="http://schemas.openxmlformats.org/drawingml/2006/main">
+          <a:graphicData uri="http://schemas.openxmlformats.org/drawingml/2006/chart">
+            <c:chart xmlns:c="http://schemas.openxmlformats.org/drawingml/2006/chart" r:id="rId1"/>
+          </a:graphicData>
+        </a:graphic>
+      </p:graphicFrame>
+      <p:sp>
+        <p:nvSpPr>
+          <p:cNvPr id="6" name="Text 3"/>
+          <p:cNvSpPr/>
+          <p:nvPr/>
+        </p:nvSpPr>
+        <p:spPr>
+          <a:xfrm>
+            <a:off x="548640" y="3886200"/>
+            <a:ext cx="3840480" cy="228600"/>
           </a:xfrm>
           <a:prstGeom prst="rect">
             <a:avLst/>
@@ -4500,171 +4535,93 @@
               <a:buNone/>
             </a:pPr>
             <a:r>
-              <a:rPr lang="en-US" sz="800" spc="120" kern="0" dirty="0">
+              <a:rPr lang="en-US" sz="750" spc="100" kern="0" dirty="0">
+                <a:solidFill>
+                  <a:srgbClr val="4A423A"/>
+                </a:solidFill>
+                <a:latin typeface="Courier New" pitchFamily="34" charset="0"/>
+                <a:ea typeface="Courier New" pitchFamily="34" charset="-122"/>
+                <a:cs typeface="Courier New" pitchFamily="34" charset="-120"/>
+              </a:rPr>
+              <a:t>210 NEGATIVE APP STORE REVIEWS · SRC/CLUSTERS.JS</a:t>
+            </a:r>
+            <a:endParaRPr lang="en-US" sz="750" dirty="0"/>
+          </a:p>
+        </p:txBody>
+      </p:sp>
+      <p:sp>
+        <p:nvSpPr>
+          <p:cNvPr id="7" name="Text 4"/>
+          <p:cNvSpPr/>
+          <p:nvPr/>
+        </p:nvSpPr>
+        <p:spPr>
+          <a:xfrm>
+            <a:off x="548640" y="4160520"/>
+            <a:ext cx="3840480" cy="548640"/>
+          </a:xfrm>
+          <a:prstGeom prst="rect">
+            <a:avLst/>
+          </a:prstGeom>
+          <a:noFill/>
+          <a:ln/>
+        </p:spPr>
+        <p:txBody>
+          <a:bodyPr wrap="square" lIns="0" tIns="0" rIns="0" bIns="0" rtlCol="0" anchor="t"/>
+          <a:lstStyle/>
+          <a:p>
+            <a:pPr indent="0" marL="0">
+              <a:buNone/>
+            </a:pPr>
+            <a:r>
+              <a:rPr lang="en-US" sz="1000" dirty="0">
+                <a:solidFill>
+                  <a:srgbClr val="93867A"/>
+                </a:solidFill>
+                <a:latin typeface="Calibri" pitchFamily="34" charset="0"/>
+                <a:ea typeface="Calibri" pitchFamily="34" charset="-122"/>
+                <a:cs typeface="Calibri" pitchFamily="34" charset="-120"/>
+              </a:rPr>
+              <a:t>Google Play, second API, same regexes: 54% · 11% · 14% of 153 negatives. Two stores, two APIs, one shape.</a:t>
+            </a:r>
+            <a:endParaRPr lang="en-US" sz="1000" dirty="0"/>
+          </a:p>
+        </p:txBody>
+      </p:sp>
+      <p:sp>
+        <p:nvSpPr>
+          <p:cNvPr id="8" name="Text 5"/>
+          <p:cNvSpPr/>
+          <p:nvPr/>
+        </p:nvSpPr>
+        <p:spPr>
+          <a:xfrm>
+            <a:off x="4754880" y="1737360"/>
+            <a:ext cx="3840480" cy="566928"/>
+          </a:xfrm>
+          <a:prstGeom prst="rect">
+            <a:avLst/>
+          </a:prstGeom>
+          <a:noFill/>
+          <a:ln/>
+        </p:spPr>
+        <p:txBody>
+          <a:bodyPr wrap="square" lIns="0" tIns="0" rIns="0" bIns="0" rtlCol="0" anchor="t"/>
+          <a:lstStyle/>
+          <a:p>
+            <a:pPr indent="0" marL="0">
+              <a:buNone/>
+            </a:pPr>
+            <a:r>
+              <a:rPr lang="en-US" sz="1200" i="1" dirty="0">
                 <a:solidFill>
                   <a:srgbClr val="6E9BD1"/>
-                </a:solidFill>
-                <a:latin typeface="Courier New" pitchFamily="34" charset="0"/>
-                <a:ea typeface="Courier New" pitchFamily="34" charset="-122"/>
-                <a:cs typeface="Courier New" pitchFamily="34" charset="-120"/>
-              </a:rPr>
-              <a:t>SOURCE</a:t>
-            </a:r>
-            <a:endParaRPr lang="en-US" sz="800" dirty="0"/>
-          </a:p>
-        </p:txBody>
-      </p:sp>
-      <p:sp>
-        <p:nvSpPr>
-          <p:cNvPr id="6" name="Text 4"/>
-          <p:cNvSpPr/>
-          <p:nvPr/>
-        </p:nvSpPr>
-        <p:spPr>
-          <a:xfrm>
-            <a:off x="2560320" y="1554480"/>
-            <a:ext cx="1920240" cy="228600"/>
-          </a:xfrm>
-          <a:prstGeom prst="rect">
-            <a:avLst/>
-          </a:prstGeom>
-          <a:noFill/>
-          <a:ln/>
-        </p:spPr>
-        <p:txBody>
-          <a:bodyPr wrap="square" lIns="0" tIns="0" rIns="0" bIns="0" rtlCol="0" anchor="ctr"/>
-          <a:lstStyle/>
-          <a:p>
-            <a:pPr indent="0" marL="0">
-              <a:buNone/>
-            </a:pPr>
-            <a:r>
-              <a:rPr lang="en-US" sz="800" spc="120" kern="0" dirty="0">
-                <a:solidFill>
-                  <a:srgbClr val="6E9BD1"/>
-                </a:solidFill>
-                <a:latin typeface="Courier New" pitchFamily="34" charset="0"/>
-                <a:ea typeface="Courier New" pitchFamily="34" charset="-122"/>
-                <a:cs typeface="Courier New" pitchFamily="34" charset="-120"/>
-              </a:rPr>
-              <a:t>PRIMARY</a:t>
-            </a:r>
-            <a:endParaRPr lang="en-US" sz="800" dirty="0"/>
-          </a:p>
-        </p:txBody>
-      </p:sp>
-      <p:sp>
-        <p:nvSpPr>
-          <p:cNvPr id="7" name="Text 5"/>
-          <p:cNvSpPr/>
-          <p:nvPr/>
-        </p:nvSpPr>
-        <p:spPr>
-          <a:xfrm>
-            <a:off x="4572000" y="1554480"/>
-            <a:ext cx="1920240" cy="228600"/>
-          </a:xfrm>
-          <a:prstGeom prst="rect">
-            <a:avLst/>
-          </a:prstGeom>
-          <a:noFill/>
-          <a:ln/>
-        </p:spPr>
-        <p:txBody>
-          <a:bodyPr wrap="square" lIns="0" tIns="0" rIns="0" bIns="0" rtlCol="0" anchor="ctr"/>
-          <a:lstStyle/>
-          <a:p>
-            <a:pPr indent="0" marL="0">
-              <a:buNone/>
-            </a:pPr>
-            <a:r>
-              <a:rPr lang="en-US" sz="800" spc="120" kern="0" dirty="0">
-                <a:solidFill>
-                  <a:srgbClr val="6E9BD1"/>
-                </a:solidFill>
-                <a:latin typeface="Courier New" pitchFamily="34" charset="0"/>
-                <a:ea typeface="Courier New" pitchFamily="34" charset="-122"/>
-                <a:cs typeface="Courier New" pitchFamily="34" charset="-120"/>
-              </a:rPr>
-              <a:t>FALLBACK</a:t>
-            </a:r>
-            <a:endParaRPr lang="en-US" sz="800" dirty="0"/>
-          </a:p>
-        </p:txBody>
-      </p:sp>
-      <p:sp>
-        <p:nvSpPr>
-          <p:cNvPr id="8" name="Text 6"/>
-          <p:cNvSpPr/>
-          <p:nvPr/>
-        </p:nvSpPr>
-        <p:spPr>
-          <a:xfrm>
-            <a:off x="6583680" y="1554480"/>
-            <a:ext cx="1920240" cy="228600"/>
-          </a:xfrm>
-          <a:prstGeom prst="rect">
-            <a:avLst/>
-          </a:prstGeom>
-          <a:noFill/>
-          <a:ln/>
-        </p:spPr>
-        <p:txBody>
-          <a:bodyPr wrap="square" lIns="0" tIns="0" rIns="0" bIns="0" rtlCol="0" anchor="ctr"/>
-          <a:lstStyle/>
-          <a:p>
-            <a:pPr indent="0" marL="0">
-              <a:buNone/>
-            </a:pPr>
-            <a:r>
-              <a:rPr lang="en-US" sz="800" spc="120" kern="0" dirty="0">
-                <a:solidFill>
-                  <a:srgbClr val="6E9BD1"/>
-                </a:solidFill>
-                <a:latin typeface="Courier New" pitchFamily="34" charset="0"/>
-                <a:ea typeface="Courier New" pitchFamily="34" charset="-122"/>
-                <a:cs typeface="Courier New" pitchFamily="34" charset="-120"/>
-              </a:rPr>
-              <a:t>WHAT ACTUALLY SERVED</a:t>
-            </a:r>
-            <a:endParaRPr lang="en-US" sz="800" dirty="0"/>
-          </a:p>
-        </p:txBody>
-      </p:sp>
-      <p:sp>
-        <p:nvSpPr>
-          <p:cNvPr id="9" name="Text 7"/>
-          <p:cNvSpPr/>
-          <p:nvPr/>
-        </p:nvSpPr>
-        <p:spPr>
-          <a:xfrm>
-            <a:off x="548640" y="1874520"/>
-            <a:ext cx="1920240" cy="457200"/>
-          </a:xfrm>
-          <a:prstGeom prst="rect">
-            <a:avLst/>
-          </a:prstGeom>
-          <a:noFill/>
-          <a:ln/>
-        </p:spPr>
-        <p:txBody>
-          <a:bodyPr wrap="square" lIns="0" tIns="0" rIns="0" bIns="0" rtlCol="0" anchor="t"/>
-          <a:lstStyle/>
-          <a:p>
-            <a:pPr indent="0" marL="0">
-              <a:buNone/>
-            </a:pPr>
-            <a:r>
-              <a:rPr lang="en-US" sz="1200" dirty="0">
-                <a:solidFill>
-                  <a:srgbClr val="EDE4D7"/>
                 </a:solidFill>
                 <a:latin typeface="Cambria" pitchFamily="34" charset="0"/>
                 <a:ea typeface="Cambria" pitchFamily="34" charset="-122"/>
                 <a:cs typeface="Cambria" pitchFamily="34" charset="-120"/>
               </a:rPr>
-              <a:t>Google SERP</a:t>
+              <a:t>“Some days I don't want to discover something new, I just want to return to a old favorite. … I want a calming app to be calming.”</a:t>
             </a:r>
             <a:endParaRPr lang="en-US" sz="1200" dirty="0"/>
           </a:p>
@@ -4672,14 +4629,53 @@
       </p:sp>
       <p:sp>
         <p:nvSpPr>
-          <p:cNvPr id="10" name="Text 8"/>
-          <p:cNvSpPr/>
-          <p:nvPr/>
-        </p:nvSpPr>
-        <p:spPr>
-          <a:xfrm>
-            <a:off x="2560320" y="1874520"/>
-            <a:ext cx="1920240" cy="457200"/>
+          <p:cNvPr id="9" name="Text 6"/>
+          <p:cNvSpPr/>
+          <p:nvPr/>
+        </p:nvSpPr>
+        <p:spPr>
+          <a:xfrm>
+            <a:off x="4754880" y="2350008"/>
+            <a:ext cx="3840480" cy="228600"/>
+          </a:xfrm>
+          <a:prstGeom prst="rect">
+            <a:avLst/>
+          </a:prstGeom>
+          <a:noFill/>
+          <a:ln/>
+        </p:spPr>
+        <p:txBody>
+          <a:bodyPr wrap="square" lIns="0" tIns="0" rIns="0" bIns="0" rtlCol="0" anchor="ctr"/>
+          <a:lstStyle/>
+          <a:p>
+            <a:pPr indent="0" marL="0">
+              <a:buNone/>
+            </a:pPr>
+            <a:r>
+              <a:rPr lang="en-US" sz="750" spc="80" kern="0" dirty="0">
+                <a:solidFill>
+                  <a:srgbClr val="3D5573"/>
+                </a:solidFill>
+                <a:latin typeface="Courier New" pitchFamily="34" charset="0"/>
+                <a:ea typeface="Courier New" pitchFamily="34" charset="-122"/>
+                <a:cs typeface="Courier New" pitchFamily="34" charset="-120"/>
+              </a:rPr>
+              <a:t>HEADSPACE · GOOGLE PLAY · AUG 2026 · VIA WEB SCRAPER API</a:t>
+            </a:r>
+            <a:endParaRPr lang="en-US" sz="750" dirty="0"/>
+          </a:p>
+        </p:txBody>
+      </p:sp>
+      <p:sp>
+        <p:nvSpPr>
+          <p:cNvPr id="10" name="Text 7"/>
+          <p:cNvSpPr/>
+          <p:nvPr/>
+        </p:nvSpPr>
+        <p:spPr>
+          <a:xfrm>
+            <a:off x="4754880" y="2697480"/>
+            <a:ext cx="3840480" cy="566928"/>
           </a:xfrm>
           <a:prstGeom prst="rect">
             <a:avLst/>
@@ -4695,132 +4691,15 @@
               <a:buNone/>
             </a:pPr>
             <a:r>
-              <a:rPr lang="en-US" sz="1000" dirty="0">
-                <a:solidFill>
-                  <a:srgbClr val="93867A"/>
-                </a:solidFill>
-                <a:latin typeface="Calibri" pitchFamily="34" charset="0"/>
-                <a:ea typeface="Calibri" pitchFamily="34" charset="-122"/>
-                <a:cs typeface="Calibri" pitchFamily="34" charset="-120"/>
-              </a:rPr>
-              <a:t>SERP zone, brd_json=1</a:t>
-            </a:r>
-            <a:endParaRPr lang="en-US" sz="1000" dirty="0"/>
-          </a:p>
-        </p:txBody>
-      </p:sp>
-      <p:sp>
-        <p:nvSpPr>
-          <p:cNvPr id="11" name="Text 9"/>
-          <p:cNvSpPr/>
-          <p:nvPr/>
-        </p:nvSpPr>
-        <p:spPr>
-          <a:xfrm>
-            <a:off x="4572000" y="1874520"/>
-            <a:ext cx="1920240" cy="457200"/>
-          </a:xfrm>
-          <a:prstGeom prst="rect">
-            <a:avLst/>
-          </a:prstGeom>
-          <a:noFill/>
-          <a:ln/>
-        </p:spPr>
-        <p:txBody>
-          <a:bodyPr wrap="square" lIns="0" tIns="0" rIns="0" bIns="0" rtlCol="0" anchor="t"/>
-          <a:lstStyle/>
-          <a:p>
-            <a:pPr indent="0" marL="0">
-              <a:buNone/>
-            </a:pPr>
-            <a:r>
-              <a:rPr lang="en-US" sz="1000" dirty="0">
-                <a:solidFill>
-                  <a:srgbClr val="93867A"/>
-                </a:solidFill>
-                <a:latin typeface="Calibri" pitchFamily="34" charset="0"/>
-                <a:ea typeface="Calibri" pitchFamily="34" charset="-122"/>
-                <a:cs typeface="Calibri" pitchFamily="34" charset="-120"/>
-              </a:rPr>
-              <a:t>— (base capability)</a:t>
-            </a:r>
-            <a:endParaRPr lang="en-US" sz="1000" dirty="0"/>
-          </a:p>
-        </p:txBody>
-      </p:sp>
-      <p:sp>
-        <p:nvSpPr>
-          <p:cNvPr id="12" name="Text 10"/>
-          <p:cNvSpPr/>
-          <p:nvPr/>
-        </p:nvSpPr>
-        <p:spPr>
-          <a:xfrm>
-            <a:off x="6583680" y="1874520"/>
-            <a:ext cx="1920240" cy="457200"/>
-          </a:xfrm>
-          <a:prstGeom prst="rect">
-            <a:avLst/>
-          </a:prstGeom>
-          <a:noFill/>
-          <a:ln/>
-        </p:spPr>
-        <p:txBody>
-          <a:bodyPr wrap="square" lIns="0" tIns="0" rIns="0" bIns="0" rtlCol="0" anchor="t"/>
-          <a:lstStyle/>
-          <a:p>
-            <a:pPr indent="0" marL="0">
-              <a:buNone/>
-            </a:pPr>
-            <a:r>
-              <a:rPr lang="en-US" sz="1000" dirty="0">
-                <a:solidFill>
-                  <a:srgbClr val="D9954A"/>
-                </a:solidFill>
-                <a:latin typeface="Calibri" pitchFamily="34" charset="0"/>
-                <a:ea typeface="Calibri" pitchFamily="34" charset="-122"/>
-                <a:cs typeface="Calibri" pitchFamily="34" charset="-120"/>
-              </a:rPr>
-              <a:t>SERP · 146/146 rows</a:t>
-            </a:r>
-            <a:endParaRPr lang="en-US" sz="1000" dirty="0"/>
-          </a:p>
-        </p:txBody>
-      </p:sp>
-      <p:sp>
-        <p:nvSpPr>
-          <p:cNvPr id="13" name="Text 11"/>
-          <p:cNvSpPr/>
-          <p:nvPr/>
-        </p:nvSpPr>
-        <p:spPr>
-          <a:xfrm>
-            <a:off x="548640" y="2377440"/>
-            <a:ext cx="1920240" cy="457200"/>
-          </a:xfrm>
-          <a:prstGeom prst="rect">
-            <a:avLst/>
-          </a:prstGeom>
-          <a:noFill/>
-          <a:ln/>
-        </p:spPr>
-        <p:txBody>
-          <a:bodyPr wrap="square" lIns="0" tIns="0" rIns="0" bIns="0" rtlCol="0" anchor="t"/>
-          <a:lstStyle/>
-          <a:p>
-            <a:pPr indent="0" marL="0">
-              <a:buNone/>
-            </a:pPr>
-            <a:r>
-              <a:rPr lang="en-US" sz="1200" dirty="0">
-                <a:solidFill>
-                  <a:srgbClr val="EDE4D7"/>
+              <a:rPr lang="en-US" sz="1200" i="1" dirty="0">
+                <a:solidFill>
+                  <a:srgbClr val="6E9BD1"/>
                 </a:solidFill>
                 <a:latin typeface="Cambria" pitchFamily="34" charset="0"/>
                 <a:ea typeface="Cambria" pitchFamily="34" charset="-122"/>
                 <a:cs typeface="Cambria" pitchFamily="34" charset="-120"/>
               </a:rPr>
-              <a:t>reddit threads</a:t>
+              <a:t>“meditation helps me identify when I am not being present, However, when another same trigger arose, I was still reactive.”</a:t>
             </a:r>
             <a:endParaRPr lang="en-US" sz="1200" dirty="0"/>
           </a:p>
@@ -4828,14 +4707,53 @@
       </p:sp>
       <p:sp>
         <p:nvSpPr>
-          <p:cNvPr id="14" name="Text 12"/>
-          <p:cNvSpPr/>
-          <p:nvPr/>
-        </p:nvSpPr>
-        <p:spPr>
-          <a:xfrm>
-            <a:off x="2560320" y="2377440"/>
-            <a:ext cx="1920240" cy="457200"/>
+          <p:cNvPr id="11" name="Text 8"/>
+          <p:cNvSpPr/>
+          <p:nvPr/>
+        </p:nvSpPr>
+        <p:spPr>
+          <a:xfrm>
+            <a:off x="4754880" y="3310128"/>
+            <a:ext cx="3840480" cy="228600"/>
+          </a:xfrm>
+          <a:prstGeom prst="rect">
+            <a:avLst/>
+          </a:prstGeom>
+          <a:noFill/>
+          <a:ln/>
+        </p:spPr>
+        <p:txBody>
+          <a:bodyPr wrap="square" lIns="0" tIns="0" rIns="0" bIns="0" rtlCol="0" anchor="ctr"/>
+          <a:lstStyle/>
+          <a:p>
+            <a:pPr indent="0" marL="0">
+              <a:buNone/>
+            </a:pPr>
+            <a:r>
+              <a:rPr lang="en-US" sz="750" spc="80" kern="0" dirty="0">
+                <a:solidFill>
+                  <a:srgbClr val="3D5573"/>
+                </a:solidFill>
+                <a:latin typeface="Courier New" pitchFamily="34" charset="0"/>
+                <a:ea typeface="Courier New" pitchFamily="34" charset="-122"/>
+                <a:cs typeface="Courier New" pitchFamily="34" charset="-120"/>
+              </a:rPr>
+              <a:t>R/MEDITATION · VIA SERP</a:t>
+            </a:r>
+            <a:endParaRPr lang="en-US" sz="750" dirty="0"/>
+          </a:p>
+        </p:txBody>
+      </p:sp>
+      <p:sp>
+        <p:nvSpPr>
+          <p:cNvPr id="12" name="Text 9"/>
+          <p:cNvSpPr/>
+          <p:nvPr/>
+        </p:nvSpPr>
+        <p:spPr>
+          <a:xfrm>
+            <a:off x="4754880" y="3657600"/>
+            <a:ext cx="3840480" cy="566928"/>
           </a:xfrm>
           <a:prstGeom prst="rect">
             <a:avLst/>
@@ -4851,132 +4769,15 @@
               <a:buNone/>
             </a:pPr>
             <a:r>
-              <a:rPr lang="en-US" sz="1000" dirty="0">
-                <a:solidFill>
-                  <a:srgbClr val="93867A"/>
-                </a:solidFill>
-                <a:latin typeface="Calibri" pitchFamily="34" charset="0"/>
-                <a:ea typeface="Calibri" pitchFamily="34" charset="-122"/>
-                <a:cs typeface="Calibri" pitchFamily="34" charset="-120"/>
-              </a:rPr>
-              <a:t>Unlocker → reddit .json</a:t>
-            </a:r>
-            <a:endParaRPr lang="en-US" sz="1000" dirty="0"/>
-          </a:p>
-        </p:txBody>
-      </p:sp>
-      <p:sp>
-        <p:nvSpPr>
-          <p:cNvPr id="15" name="Text 13"/>
-          <p:cNvSpPr/>
-          <p:nvPr/>
-        </p:nvSpPr>
-        <p:spPr>
-          <a:xfrm>
-            <a:off x="4572000" y="2377440"/>
-            <a:ext cx="1920240" cy="457200"/>
-          </a:xfrm>
-          <a:prstGeom prst="rect">
-            <a:avLst/>
-          </a:prstGeom>
-          <a:noFill/>
-          <a:ln/>
-        </p:spPr>
-        <p:txBody>
-          <a:bodyPr wrap="square" lIns="0" tIns="0" rIns="0" bIns="0" rtlCol="0" anchor="t"/>
-          <a:lstStyle/>
-          <a:p>
-            <a:pPr indent="0" marL="0">
-              <a:buNone/>
-            </a:pPr>
-            <a:r>
-              <a:rPr lang="en-US" sz="1000" dirty="0">
-                <a:solidFill>
-                  <a:srgbClr val="93867A"/>
-                </a:solidFill>
-                <a:latin typeface="Calibri" pitchFamily="34" charset="0"/>
-                <a:ea typeface="Calibri" pitchFamily="34" charset="-122"/>
-                <a:cs typeface="Calibri" pitchFamily="34" charset="-120"/>
-              </a:rPr>
-              <a:t>SERP site:reddit.com/r/…</a:t>
-            </a:r>
-            <a:endParaRPr lang="en-US" sz="1000" dirty="0"/>
-          </a:p>
-        </p:txBody>
-      </p:sp>
-      <p:sp>
-        <p:nvSpPr>
-          <p:cNvPr id="16" name="Text 14"/>
-          <p:cNvSpPr/>
-          <p:nvPr/>
-        </p:nvSpPr>
-        <p:spPr>
-          <a:xfrm>
-            <a:off x="6583680" y="2377440"/>
-            <a:ext cx="1920240" cy="457200"/>
-          </a:xfrm>
-          <a:prstGeom prst="rect">
-            <a:avLst/>
-          </a:prstGeom>
-          <a:noFill/>
-          <a:ln/>
-        </p:spPr>
-        <p:txBody>
-          <a:bodyPr wrap="square" lIns="0" tIns="0" rIns="0" bIns="0" rtlCol="0" anchor="t"/>
-          <a:lstStyle/>
-          <a:p>
-            <a:pPr indent="0" marL="0">
-              <a:buNone/>
-            </a:pPr>
-            <a:r>
-              <a:rPr lang="en-US" sz="1000" dirty="0">
-                <a:solidFill>
-                  <a:srgbClr val="D9954A"/>
-                </a:solidFill>
-                <a:latin typeface="Calibri" pitchFamily="34" charset="0"/>
-                <a:ea typeface="Calibri" pitchFamily="34" charset="-122"/>
-                <a:cs typeface="Calibri" pitchFamily="34" charset="-120"/>
-              </a:rPr>
-              <a:t>SERP · KYC-gated on Unlocker</a:t>
-            </a:r>
-            <a:endParaRPr lang="en-US" sz="1000" dirty="0"/>
-          </a:p>
-        </p:txBody>
-      </p:sp>
-      <p:sp>
-        <p:nvSpPr>
-          <p:cNvPr id="17" name="Text 15"/>
-          <p:cNvSpPr/>
-          <p:nvPr/>
-        </p:nvSpPr>
-        <p:spPr>
-          <a:xfrm>
-            <a:off x="548640" y="2880360"/>
-            <a:ext cx="1920240" cy="457200"/>
-          </a:xfrm>
-          <a:prstGeom prst="rect">
-            <a:avLst/>
-          </a:prstGeom>
-          <a:noFill/>
-          <a:ln/>
-        </p:spPr>
-        <p:txBody>
-          <a:bodyPr wrap="square" lIns="0" tIns="0" rIns="0" bIns="0" rtlCol="0" anchor="t"/>
-          <a:lstStyle/>
-          <a:p>
-            <a:pPr indent="0" marL="0">
-              <a:buNone/>
-            </a:pPr>
-            <a:r>
-              <a:rPr lang="en-US" sz="1200" dirty="0">
-                <a:solidFill>
-                  <a:srgbClr val="EDE4D7"/>
+              <a:rPr lang="en-US" sz="1200" i="1" dirty="0">
+                <a:solidFill>
+                  <a:srgbClr val="6E9BD1"/>
                 </a:solidFill>
                 <a:latin typeface="Cambria" pitchFamily="34" charset="0"/>
                 <a:ea typeface="Cambria" pitchFamily="34" charset="-122"/>
                 <a:cs typeface="Cambria" pitchFamily="34" charset="-120"/>
               </a:rPr>
-              <a:t>Apple reviews</a:t>
+              <a:t>“In order to change your behavior, you need to begin to bring your meditative mindset into daily life when you are in the act of making decisions…”</a:t>
             </a:r>
             <a:endParaRPr lang="en-US" sz="1200" dirty="0"/>
           </a:p>
@@ -4984,420 +4785,40 @@
       </p:sp>
       <p:sp>
         <p:nvSpPr>
-          <p:cNvPr id="18" name="Text 16"/>
-          <p:cNvSpPr/>
-          <p:nvPr/>
-        </p:nvSpPr>
-        <p:spPr>
-          <a:xfrm>
-            <a:off x="2560320" y="2880360"/>
-            <a:ext cx="1920240" cy="457200"/>
-          </a:xfrm>
-          <a:prstGeom prst="rect">
-            <a:avLst/>
-          </a:prstGeom>
-          <a:noFill/>
-          <a:ln/>
-        </p:spPr>
-        <p:txBody>
-          <a:bodyPr wrap="square" lIns="0" tIns="0" rIns="0" bIns="0" rtlCol="0" anchor="t"/>
-          <a:lstStyle/>
-          <a:p>
-            <a:pPr indent="0" marL="0">
-              <a:buNone/>
-            </a:pPr>
-            <a:r>
-              <a:rPr lang="en-US" sz="1000" dirty="0">
-                <a:solidFill>
-                  <a:srgbClr val="93867A"/>
-                </a:solidFill>
-                <a:latin typeface="Calibri" pitchFamily="34" charset="0"/>
-                <a:ea typeface="Calibri" pitchFamily="34" charset="-122"/>
-                <a:cs typeface="Calibri" pitchFamily="34" charset="-120"/>
-              </a:rPr>
-              <a:t>Unlocker → itunes RSS</a:t>
-            </a:r>
-            <a:endParaRPr lang="en-US" sz="1000" dirty="0"/>
-          </a:p>
-        </p:txBody>
-      </p:sp>
-      <p:sp>
-        <p:nvSpPr>
-          <p:cNvPr id="19" name="Text 17"/>
-          <p:cNvSpPr/>
-          <p:nvPr/>
-        </p:nvSpPr>
-        <p:spPr>
-          <a:xfrm>
-            <a:off x="4572000" y="2880360"/>
-            <a:ext cx="1920240" cy="457200"/>
-          </a:xfrm>
-          <a:prstGeom prst="rect">
-            <a:avLst/>
-          </a:prstGeom>
-          <a:noFill/>
-          <a:ln/>
-        </p:spPr>
-        <p:txBody>
-          <a:bodyPr wrap="square" lIns="0" tIns="0" rIns="0" bIns="0" rtlCol="0" anchor="t"/>
-          <a:lstStyle/>
-          <a:p>
-            <a:pPr indent="0" marL="0">
-              <a:buNone/>
-            </a:pPr>
-            <a:r>
-              <a:rPr lang="en-US" sz="1000" dirty="0">
-                <a:solidFill>
-                  <a:srgbClr val="93867A"/>
-                </a:solidFill>
-                <a:latin typeface="Calibri" pitchFamily="34" charset="0"/>
-                <a:ea typeface="Calibri" pitchFamily="34" charset="-122"/>
-                <a:cs typeface="Calibri" pitchFamily="34" charset="-120"/>
-              </a:rPr>
-              <a:t>direct fetch (public API)</a:t>
-            </a:r>
-            <a:endParaRPr lang="en-US" sz="1000" dirty="0"/>
-          </a:p>
-        </p:txBody>
-      </p:sp>
-      <p:sp>
-        <p:nvSpPr>
-          <p:cNvPr id="20" name="Text 18"/>
-          <p:cNvSpPr/>
-          <p:nvPr/>
-        </p:nvSpPr>
-        <p:spPr>
-          <a:xfrm>
-            <a:off x="6583680" y="2880360"/>
-            <a:ext cx="1920240" cy="457200"/>
-          </a:xfrm>
-          <a:prstGeom prst="rect">
-            <a:avLst/>
-          </a:prstGeom>
-          <a:noFill/>
-          <a:ln/>
-        </p:spPr>
-        <p:txBody>
-          <a:bodyPr wrap="square" lIns="0" tIns="0" rIns="0" bIns="0" rtlCol="0" anchor="t"/>
-          <a:lstStyle/>
-          <a:p>
-            <a:pPr indent="0" marL="0">
-              <a:buNone/>
-            </a:pPr>
-            <a:r>
-              <a:rPr lang="en-US" sz="1000" dirty="0">
-                <a:solidFill>
-                  <a:srgbClr val="D9954A"/>
-                </a:solidFill>
-                <a:latin typeface="Calibri" pitchFamily="34" charset="0"/>
-                <a:ea typeface="Calibri" pitchFamily="34" charset="-122"/>
-                <a:cs typeface="Calibri" pitchFamily="34" charset="-120"/>
-              </a:rPr>
-              <a:t>direct · 0 via unlocker, 9 direct</a:t>
-            </a:r>
-            <a:endParaRPr lang="en-US" sz="1000" dirty="0"/>
-          </a:p>
-        </p:txBody>
-      </p:sp>
-      <p:sp>
-        <p:nvSpPr>
-          <p:cNvPr id="21" name="Text 19"/>
-          <p:cNvSpPr/>
-          <p:nvPr/>
-        </p:nvSpPr>
-        <p:spPr>
-          <a:xfrm>
-            <a:off x="548640" y="3383280"/>
-            <a:ext cx="1920240" cy="457200"/>
-          </a:xfrm>
-          <a:prstGeom prst="rect">
-            <a:avLst/>
-          </a:prstGeom>
-          <a:noFill/>
-          <a:ln/>
-        </p:spPr>
-        <p:txBody>
-          <a:bodyPr wrap="square" lIns="0" tIns="0" rIns="0" bIns="0" rtlCol="0" anchor="t"/>
-          <a:lstStyle/>
-          <a:p>
-            <a:pPr indent="0" marL="0">
-              <a:buNone/>
-            </a:pPr>
-            <a:r>
-              <a:rPr lang="en-US" sz="1200" dirty="0">
-                <a:solidFill>
-                  <a:srgbClr val="EDE4D7"/>
-                </a:solidFill>
-                <a:latin typeface="Cambria" pitchFamily="34" charset="0"/>
-                <a:ea typeface="Cambria" pitchFamily="34" charset="-122"/>
-                <a:cs typeface="Cambria" pitchFamily="34" charset="-120"/>
-              </a:rPr>
-              <a:t>Google Play page</a:t>
-            </a:r>
-            <a:endParaRPr lang="en-US" sz="1200" dirty="0"/>
-          </a:p>
-        </p:txBody>
-      </p:sp>
-      <p:sp>
-        <p:nvSpPr>
-          <p:cNvPr id="22" name="Text 20"/>
-          <p:cNvSpPr/>
-          <p:nvPr/>
-        </p:nvSpPr>
-        <p:spPr>
-          <a:xfrm>
-            <a:off x="2560320" y="3383280"/>
-            <a:ext cx="1920240" cy="457200"/>
-          </a:xfrm>
-          <a:prstGeom prst="rect">
-            <a:avLst/>
-          </a:prstGeom>
-          <a:noFill/>
-          <a:ln/>
-        </p:spPr>
-        <p:txBody>
-          <a:bodyPr wrap="square" lIns="0" tIns="0" rIns="0" bIns="0" rtlCol="0" anchor="t"/>
-          <a:lstStyle/>
-          <a:p>
-            <a:pPr indent="0" marL="0">
-              <a:buNone/>
-            </a:pPr>
-            <a:r>
-              <a:rPr lang="en-US" sz="1000" dirty="0">
-                <a:solidFill>
-                  <a:srgbClr val="93867A"/>
-                </a:solidFill>
-                <a:latin typeface="Calibri" pitchFamily="34" charset="0"/>
-                <a:ea typeface="Calibri" pitchFamily="34" charset="-122"/>
-                <a:cs typeface="Calibri" pitchFamily="34" charset="-120"/>
-              </a:rPr>
-              <a:t>Unlocker</a:t>
-            </a:r>
-            <a:endParaRPr lang="en-US" sz="1000" dirty="0"/>
-          </a:p>
-        </p:txBody>
-      </p:sp>
-      <p:sp>
-        <p:nvSpPr>
-          <p:cNvPr id="23" name="Text 21"/>
-          <p:cNvSpPr/>
-          <p:nvPr/>
-        </p:nvSpPr>
-        <p:spPr>
-          <a:xfrm>
-            <a:off x="4572000" y="3383280"/>
-            <a:ext cx="1920240" cy="457200"/>
-          </a:xfrm>
-          <a:prstGeom prst="rect">
-            <a:avLst/>
-          </a:prstGeom>
-          <a:noFill/>
-          <a:ln/>
-        </p:spPr>
-        <p:txBody>
-          <a:bodyPr wrap="square" lIns="0" tIns="0" rIns="0" bIns="0" rtlCol="0" anchor="t"/>
-          <a:lstStyle/>
-          <a:p>
-            <a:pPr indent="0" marL="0">
-              <a:buNone/>
-            </a:pPr>
-            <a:r>
-              <a:rPr lang="en-US" sz="1000" dirty="0">
-                <a:solidFill>
-                  <a:srgbClr val="93867A"/>
-                </a:solidFill>
-                <a:latin typeface="Calibri" pitchFamily="34" charset="0"/>
-                <a:ea typeface="Calibri" pitchFamily="34" charset="-122"/>
-                <a:cs typeface="Calibri" pitchFamily="34" charset="-120"/>
-              </a:rPr>
-              <a:t>—</a:t>
-            </a:r>
-            <a:endParaRPr lang="en-US" sz="1000" dirty="0"/>
-          </a:p>
-        </p:txBody>
-      </p:sp>
-      <p:sp>
-        <p:nvSpPr>
-          <p:cNvPr id="24" name="Text 22"/>
-          <p:cNvSpPr/>
-          <p:nvPr/>
-        </p:nvSpPr>
-        <p:spPr>
-          <a:xfrm>
-            <a:off x="6583680" y="3383280"/>
-            <a:ext cx="1920240" cy="457200"/>
-          </a:xfrm>
-          <a:prstGeom prst="rect">
-            <a:avLst/>
-          </a:prstGeom>
-          <a:noFill/>
-          <a:ln/>
-        </p:spPr>
-        <p:txBody>
-          <a:bodyPr wrap="square" lIns="0" tIns="0" rIns="0" bIns="0" rtlCol="0" anchor="t"/>
-          <a:lstStyle/>
-          <a:p>
-            <a:pPr indent="0" marL="0">
-              <a:buNone/>
-            </a:pPr>
-            <a:r>
-              <a:rPr lang="en-US" sz="1000" dirty="0">
-                <a:solidFill>
-                  <a:srgbClr val="D9954A"/>
-                </a:solidFill>
-                <a:latin typeface="Calibri" pitchFamily="34" charset="0"/>
-                <a:ea typeface="Calibri" pitchFamily="34" charset="-122"/>
-                <a:cs typeface="Calibri" pitchFamily="34" charset="-120"/>
-              </a:rPr>
-              <a:t>Unlocker · 200 OK, 1.2 MB (untapped)</a:t>
-            </a:r>
-            <a:endParaRPr lang="en-US" sz="1000" dirty="0"/>
-          </a:p>
-        </p:txBody>
-      </p:sp>
-      <p:sp>
-        <p:nvSpPr>
-          <p:cNvPr id="25" name="Shape 23"/>
-          <p:cNvSpPr/>
-          <p:nvPr/>
-        </p:nvSpPr>
-        <p:spPr>
-          <a:xfrm>
-            <a:off x="548640" y="3931920"/>
-            <a:ext cx="4937760" cy="868680"/>
-          </a:xfrm>
-          <a:prstGeom prst="rect">
-            <a:avLst/>
-          </a:prstGeom>
-          <a:solidFill>
-            <a:srgbClr val="161210"/>
-          </a:solidFill>
-          <a:ln w="9525">
-            <a:solidFill>
-              <a:srgbClr val="3D5573"/>
-            </a:solidFill>
-            <a:prstDash val="solid"/>
-          </a:ln>
-        </p:spPr>
-      </p:sp>
-      <p:sp>
-        <p:nvSpPr>
-          <p:cNvPr id="26" name="Text 24"/>
-          <p:cNvSpPr/>
-          <p:nvPr/>
-        </p:nvSpPr>
-        <p:spPr>
-          <a:xfrm>
-            <a:off x="713232" y="4041648"/>
-            <a:ext cx="4608576" cy="649224"/>
-          </a:xfrm>
-          <a:prstGeom prst="rect">
-            <a:avLst/>
-          </a:prstGeom>
-          <a:noFill/>
-          <a:ln/>
-        </p:spPr>
-        <p:txBody>
-          <a:bodyPr wrap="square" lIns="0" tIns="0" rIns="0" bIns="0" rtlCol="0" anchor="t"/>
-          <a:lstStyle/>
-          <a:p>
-            <a:pPr indent="0" marL="0">
-              <a:lnSpc>
-                <a:spcPct val="115000"/>
-              </a:lnSpc>
-              <a:buNone/>
-            </a:pPr>
-            <a:r>
-              <a:rPr lang="en-US" sz="850" dirty="0">
-                <a:solidFill>
-                  <a:srgbClr val="EDE4D7"/>
-                </a:solidFill>
-                <a:latin typeface="Courier New" pitchFamily="34" charset="0"/>
-                <a:ea typeface="Courier New" pitchFamily="34" charset="-122"/>
-                <a:cs typeface="Courier New" pitchFamily="34" charset="-120"/>
-              </a:rPr>
-              <a:t>export const pathStats = { unlocker: 0, direct: 0 };</a:t>
-            </a:r>
-            <a:endParaRPr lang="en-US" sz="850" dirty="0"/>
-          </a:p>
-          <a:p>
-            <a:pPr indent="0" marL="0">
-              <a:lnSpc>
-                <a:spcPct val="115000"/>
-              </a:lnSpc>
-              <a:buNone/>
-            </a:pPr>
-            <a:r>
-              <a:rPr lang="en-US" sz="850" dirty="0">
-                <a:solidFill>
-                  <a:srgbClr val="EDE4D7"/>
-                </a:solidFill>
-                <a:latin typeface="Courier New" pitchFamily="34" charset="0"/>
-                <a:ea typeface="Courier New" pitchFamily="34" charset="-122"/>
-                <a:cs typeface="Courier New" pitchFamily="34" charset="-120"/>
-              </a:rPr>
-              <a:t>// … every fetch increments the path that served …</a:t>
-            </a:r>
-            <a:endParaRPr lang="en-US" sz="850" dirty="0"/>
-          </a:p>
-          <a:p>
-            <a:pPr indent="0" marL="0">
-              <a:lnSpc>
-                <a:spcPct val="115000"/>
-              </a:lnSpc>
-              <a:buNone/>
-            </a:pPr>
-            <a:r>
-              <a:rPr lang="en-US" sz="850" dirty="0">
-                <a:solidFill>
-                  <a:srgbClr val="EDE4D7"/>
-                </a:solidFill>
-                <a:latin typeface="Courier New" pitchFamily="34" charset="0"/>
-                <a:ea typeface="Courier New" pitchFamily="34" charset="-122"/>
-                <a:cs typeface="Courier New" pitchFamily="34" charset="-120"/>
-              </a:rPr>
-              <a:t>log(`${pathStats.unlocker} via unlocker, ${pathStats.direct} via direct`)</a:t>
-            </a:r>
-            <a:endParaRPr lang="en-US" sz="850" dirty="0"/>
-          </a:p>
-        </p:txBody>
-      </p:sp>
-      <p:sp>
-        <p:nvSpPr>
-          <p:cNvPr id="27" name="Text 25"/>
-          <p:cNvSpPr/>
-          <p:nvPr/>
-        </p:nvSpPr>
-        <p:spPr>
-          <a:xfrm>
-            <a:off x="5669280" y="3931920"/>
-            <a:ext cx="2926080" cy="868680"/>
-          </a:xfrm>
-          <a:prstGeom prst="rect">
-            <a:avLst/>
-          </a:prstGeom>
-          <a:noFill/>
-          <a:ln/>
-        </p:spPr>
-        <p:txBody>
-          <a:bodyPr wrap="square" lIns="0" tIns="0" rIns="0" bIns="0" rtlCol="0" anchor="t"/>
-          <a:lstStyle/>
-          <a:p>
-            <a:pPr indent="0" marL="0">
-              <a:buNone/>
-            </a:pPr>
-            <a:r>
-              <a:rPr lang="en-US" sz="1200" i="1" dirty="0">
-                <a:solidFill>
-                  <a:srgbClr val="EDE4D7"/>
-                </a:solidFill>
-                <a:latin typeface="Cambria" pitchFamily="34" charset="0"/>
-                <a:ea typeface="Cambria" pitchFamily="34" charset="-122"/>
-                <a:cs typeface="Cambria" pitchFamily="34" charset="-120"/>
-              </a:rPr>
-              <a:t>The page credits whichever path served. At a data event, that honesty is the product.</a:t>
-            </a:r>
-            <a:endParaRPr lang="en-US" sz="1200" dirty="0"/>
+          <p:cNvPr id="13" name="Text 10"/>
+          <p:cNvSpPr/>
+          <p:nvPr/>
+        </p:nvSpPr>
+        <p:spPr>
+          <a:xfrm>
+            <a:off x="4754880" y="4270248"/>
+            <a:ext cx="3840480" cy="228600"/>
+          </a:xfrm>
+          <a:prstGeom prst="rect">
+            <a:avLst/>
+          </a:prstGeom>
+          <a:noFill/>
+          <a:ln/>
+        </p:spPr>
+        <p:txBody>
+          <a:bodyPr wrap="square" lIns="0" tIns="0" rIns="0" bIns="0" rtlCol="0" anchor="ctr"/>
+          <a:lstStyle/>
+          <a:p>
+            <a:pPr indent="0" marL="0">
+              <a:buNone/>
+            </a:pPr>
+            <a:r>
+              <a:rPr lang="en-US" sz="750" spc="80" kern="0" dirty="0">
+                <a:solidFill>
+                  <a:srgbClr val="3D5573"/>
+                </a:solidFill>
+                <a:latin typeface="Courier New" pitchFamily="34" charset="0"/>
+                <a:ea typeface="Courier New" pitchFamily="34" charset="-122"/>
+                <a:cs typeface="Courier New" pitchFamily="34" charset="-120"/>
+              </a:rPr>
+              <a:t>R/MEDITATION · VIA SERP</a:t>
+            </a:r>
+            <a:endParaRPr lang="en-US" sz="750" dirty="0"/>
           </a:p>
         </p:txBody>
       </p:sp>
@@ -5441,8 +4862,8 @@
         </p:nvSpPr>
         <p:spPr>
           <a:xfrm>
-            <a:off x="6766560" y="457200"/>
-            <a:ext cx="1828800" cy="274320"/>
+            <a:off x="5852160" y="457200"/>
+            <a:ext cx="2743200" cy="274320"/>
           </a:xfrm>
           <a:prstGeom prst="rect">
             <a:avLst/>
@@ -5466,7 +4887,7 @@
                 <a:ea typeface="Courier New" pitchFamily="34" charset="-122"/>
                 <a:cs typeface="Courier New" pitchFamily="34" charset="-120"/>
               </a:rPr>
-              <a:t>RESULT · HELD</a:t>
+              <a:t>WHAT PUSHED BACK</a:t>
             </a:r>
             <a:endParaRPr lang="en-US" sz="900" dirty="0"/>
           </a:p>
@@ -5505,7 +4926,7 @@
                 <a:ea typeface="Courier New" pitchFamily="34" charset="-122"/>
                 <a:cs typeface="Courier New" pitchFamily="34" charset="-120"/>
               </a:rPr>
-              <a:t>RESULT · BOTH HALVES HELD — IN THEIR OWN WORDS</a:t>
+              <a:t>RESULT · THE COMPETITION QUERIES DID THEIR JOB</a:t>
             </a:r>
             <a:endParaRPr lang="en-US" sz="900" dirty="0"/>
           </a:p>
@@ -5544,38 +4965,47 @@
                 <a:ea typeface="Cambria" pitchFamily="34" charset="-122"/>
                 <a:cs typeface="Cambria" pitchFamily="34" charset="-120"/>
               </a:rPr>
-              <a:t>H1: people ask for less. H2: the calm really does stay on the cushion.</a:t>
+              <a:t>The web refuted my positioning. The interrupt and the minute both already exist.</a:t>
             </a:r>
             <a:endParaRPr lang="en-US" sz="2400" dirty="0"/>
           </a:p>
         </p:txBody>
       </p:sp>
-      <p:graphicFrame>
-        <p:nvGraphicFramePr>
-          <p:cNvPr id="5" name="Chart 0" descr=""/>
-          <p:cNvGraphicFramePr/>
-          <p:nvPr/>
-        </p:nvGraphicFramePr>
-        <p:xfrm>
-          <a:off x="457200" y="1737360"/>
-          <a:ext cx="3840480" cy="2377440"/>
-        </p:xfrm>
-        <a:graphic xmlns:a="http://schemas.openxmlformats.org/drawingml/2006/main">
-          <a:graphicData uri="http://schemas.openxmlformats.org/drawingml/2006/chart">
-            <c:chart xmlns:c="http://schemas.openxmlformats.org/drawingml/2006/chart" r:id="rId1"/>
-          </a:graphicData>
-        </a:graphic>
-      </p:graphicFrame>
-      <p:sp>
-        <p:nvSpPr>
-          <p:cNvPr id="6" name="Text 3"/>
-          <p:cNvSpPr/>
-          <p:nvPr/>
-        </p:nvSpPr>
-        <p:spPr>
-          <a:xfrm>
-            <a:off x="548640" y="4160520"/>
-            <a:ext cx="3840480" cy="274320"/>
+      <p:sp>
+        <p:nvSpPr>
+          <p:cNvPr id="5" name="Shape 3"/>
+          <p:cNvSpPr/>
+          <p:nvPr/>
+        </p:nvSpPr>
+        <p:spPr>
+          <a:xfrm>
+            <a:off x="548640" y="1947672"/>
+            <a:ext cx="118872" cy="118872"/>
+          </a:xfrm>
+          <a:prstGeom prst="ellipse">
+            <a:avLst/>
+          </a:prstGeom>
+          <a:solidFill>
+            <a:srgbClr val="6E9BD1"/>
+          </a:solidFill>
+          <a:ln w="12700">
+            <a:solidFill>
+              <a:srgbClr val="333333"/>
+            </a:solidFill>
+            <a:prstDash val="solid"/>
+          </a:ln>
+        </p:spPr>
+      </p:sp>
+      <p:sp>
+        <p:nvSpPr>
+          <p:cNvPr id="6" name="Text 4"/>
+          <p:cNvSpPr/>
+          <p:nvPr/>
+        </p:nvSpPr>
+        <p:spPr>
+          <a:xfrm>
+            <a:off x="822960" y="1874520"/>
+            <a:ext cx="3017520" cy="274320"/>
           </a:xfrm>
           <a:prstGeom prst="rect">
             <a:avLst/>
@@ -5591,30 +5021,30 @@
               <a:buNone/>
             </a:pPr>
             <a:r>
-              <a:rPr lang="en-US" sz="800" spc="120" kern="0" dirty="0">
-                <a:solidFill>
-                  <a:srgbClr val="4A423A"/>
-                </a:solidFill>
-                <a:latin typeface="Courier New" pitchFamily="34" charset="0"/>
-                <a:ea typeface="Courier New" pitchFamily="34" charset="-122"/>
-                <a:cs typeface="Courier New" pitchFamily="34" charset="-120"/>
-              </a:rPr>
-              <a:t>210 NEGATIVE APP-STORE REVIEWS, CLASSIFIED</a:t>
-            </a:r>
-            <a:endParaRPr lang="en-US" sz="800" dirty="0"/>
-          </a:p>
-        </p:txBody>
-      </p:sp>
-      <p:sp>
-        <p:nvSpPr>
-          <p:cNvPr id="7" name="Text 4"/>
-          <p:cNvSpPr/>
-          <p:nvPr/>
-        </p:nvSpPr>
-        <p:spPr>
-          <a:xfrm>
-            <a:off x="4754880" y="1737360"/>
-            <a:ext cx="3840480" cy="777240"/>
+              <a:rPr lang="en-US" sz="950" b="1" dirty="0">
+                <a:solidFill>
+                  <a:srgbClr val="EDE4D7"/>
+                </a:solidFill>
+                <a:latin typeface="Courier New" pitchFamily="34" charset="0"/>
+                <a:ea typeface="Courier New" pitchFamily="34" charset="-122"/>
+                <a:cs typeface="Courier New" pitchFamily="34" charset="-120"/>
+              </a:rPr>
+              <a:t>Mindfulness Bell · MindBell · Chill</a:t>
+            </a:r>
+            <a:endParaRPr lang="en-US" sz="950" dirty="0"/>
+          </a:p>
+        </p:txBody>
+      </p:sp>
+      <p:sp>
+        <p:nvSpPr>
+          <p:cNvPr id="7" name="Text 5"/>
+          <p:cNvSpPr/>
+          <p:nvPr/>
+        </p:nvSpPr>
+        <p:spPr>
+          <a:xfrm>
+            <a:off x="822960" y="2148840"/>
+            <a:ext cx="2743200" cy="365760"/>
           </a:xfrm>
           <a:prstGeom prst="rect">
             <a:avLst/>
@@ -5630,7 +5060,316 @@
               <a:buNone/>
             </a:pPr>
             <a:r>
-              <a:rPr lang="en-US" sz="1200" i="1" dirty="0">
+              <a:rPr lang="en-US" sz="1000" dirty="0">
+                <a:solidFill>
+                  <a:srgbClr val="93867A"/>
+                </a:solidFill>
+                <a:latin typeface="Calibri" pitchFamily="34" charset="0"/>
+                <a:ea typeface="Calibri" pitchFamily="34" charset="-122"/>
+                <a:cs typeface="Calibri" pitchFamily="34" charset="-120"/>
+              </a:rPr>
+              <a:t>interval or random bells, all day</a:t>
+            </a:r>
+            <a:endParaRPr lang="en-US" sz="1000" dirty="0"/>
+          </a:p>
+        </p:txBody>
+      </p:sp>
+      <p:sp>
+        <p:nvSpPr>
+          <p:cNvPr id="8" name="Shape 6"/>
+          <p:cNvSpPr/>
+          <p:nvPr/>
+        </p:nvSpPr>
+        <p:spPr>
+          <a:xfrm>
+            <a:off x="548640" y="2587752"/>
+            <a:ext cx="118872" cy="118872"/>
+          </a:xfrm>
+          <a:prstGeom prst="ellipse">
+            <a:avLst/>
+          </a:prstGeom>
+          <a:solidFill>
+            <a:srgbClr val="6E9BD1"/>
+          </a:solidFill>
+          <a:ln w="12700">
+            <a:solidFill>
+              <a:srgbClr val="333333"/>
+            </a:solidFill>
+            <a:prstDash val="solid"/>
+          </a:ln>
+        </p:spPr>
+      </p:sp>
+      <p:sp>
+        <p:nvSpPr>
+          <p:cNvPr id="9" name="Text 7"/>
+          <p:cNvSpPr/>
+          <p:nvPr/>
+        </p:nvSpPr>
+        <p:spPr>
+          <a:xfrm>
+            <a:off x="822960" y="2514600"/>
+            <a:ext cx="3017520" cy="274320"/>
+          </a:xfrm>
+          <a:prstGeom prst="rect">
+            <a:avLst/>
+          </a:prstGeom>
+          <a:noFill/>
+          <a:ln/>
+        </p:spPr>
+        <p:txBody>
+          <a:bodyPr wrap="square" lIns="0" tIns="0" rIns="0" bIns="0" rtlCol="0" anchor="ctr"/>
+          <a:lstStyle/>
+          <a:p>
+            <a:pPr indent="0" marL="0">
+              <a:buNone/>
+            </a:pPr>
+            <a:r>
+              <a:rPr lang="en-US" sz="950" b="1" dirty="0">
+                <a:solidFill>
+                  <a:srgbClr val="EDE4D7"/>
+                </a:solidFill>
+                <a:latin typeface="Courier New" pitchFamily="34" charset="0"/>
+                <a:ea typeface="Courier New" pitchFamily="34" charset="-122"/>
+                <a:cs typeface="Courier New" pitchFamily="34" charset="-120"/>
+              </a:rPr>
+              <a:t>One-Moment Meditation®</a:t>
+            </a:r>
+            <a:endParaRPr lang="en-US" sz="950" dirty="0"/>
+          </a:p>
+        </p:txBody>
+      </p:sp>
+      <p:sp>
+        <p:nvSpPr>
+          <p:cNvPr id="10" name="Text 8"/>
+          <p:cNvSpPr/>
+          <p:nvPr/>
+        </p:nvSpPr>
+        <p:spPr>
+          <a:xfrm>
+            <a:off x="822960" y="2788920"/>
+            <a:ext cx="2743200" cy="365760"/>
+          </a:xfrm>
+          <a:prstGeom prst="rect">
+            <a:avLst/>
+          </a:prstGeom>
+          <a:noFill/>
+          <a:ln/>
+        </p:spPr>
+        <p:txBody>
+          <a:bodyPr wrap="square" lIns="0" tIns="0" rIns="0" bIns="0" rtlCol="0" anchor="t"/>
+          <a:lstStyle/>
+          <a:p>
+            <a:pPr indent="0" marL="0">
+              <a:buNone/>
+            </a:pPr>
+            <a:r>
+              <a:rPr lang="en-US" sz="1000" dirty="0">
+                <a:solidFill>
+                  <a:srgbClr val="93867A"/>
+                </a:solidFill>
+                <a:latin typeface="Calibri" pitchFamily="34" charset="0"/>
+                <a:ea typeface="Calibri" pitchFamily="34" charset="-122"/>
+                <a:cs typeface="Calibri" pitchFamily="34" charset="-120"/>
+              </a:rPr>
+              <a:t>one-minute exercise + reminders — and a registered mark</a:t>
+            </a:r>
+            <a:endParaRPr lang="en-US" sz="1000" dirty="0"/>
+          </a:p>
+        </p:txBody>
+      </p:sp>
+      <p:sp>
+        <p:nvSpPr>
+          <p:cNvPr id="11" name="Shape 9"/>
+          <p:cNvSpPr/>
+          <p:nvPr/>
+        </p:nvSpPr>
+        <p:spPr>
+          <a:xfrm>
+            <a:off x="548640" y="3227832"/>
+            <a:ext cx="118872" cy="118872"/>
+          </a:xfrm>
+          <a:prstGeom prst="ellipse">
+            <a:avLst/>
+          </a:prstGeom>
+          <a:solidFill>
+            <a:srgbClr val="6E9BD1"/>
+          </a:solidFill>
+          <a:ln w="12700">
+            <a:solidFill>
+              <a:srgbClr val="333333"/>
+            </a:solidFill>
+            <a:prstDash val="solid"/>
+          </a:ln>
+        </p:spPr>
+      </p:sp>
+      <p:sp>
+        <p:nvSpPr>
+          <p:cNvPr id="12" name="Text 10"/>
+          <p:cNvSpPr/>
+          <p:nvPr/>
+        </p:nvSpPr>
+        <p:spPr>
+          <a:xfrm>
+            <a:off x="822960" y="3154680"/>
+            <a:ext cx="3017520" cy="274320"/>
+          </a:xfrm>
+          <a:prstGeom prst="rect">
+            <a:avLst/>
+          </a:prstGeom>
+          <a:noFill/>
+          <a:ln/>
+        </p:spPr>
+        <p:txBody>
+          <a:bodyPr wrap="square" lIns="0" tIns="0" rIns="0" bIns="0" rtlCol="0" anchor="ctr"/>
+          <a:lstStyle/>
+          <a:p>
+            <a:pPr indent="0" marL="0">
+              <a:buNone/>
+            </a:pPr>
+            <a:r>
+              <a:rPr lang="en-US" sz="950" b="1" dirty="0">
+                <a:solidFill>
+                  <a:srgbClr val="EDE4D7"/>
+                </a:solidFill>
+                <a:latin typeface="Courier New" pitchFamily="34" charset="0"/>
+                <a:ea typeface="Courier New" pitchFamily="34" charset="-122"/>
+                <a:cs typeface="Courier New" pitchFamily="34" charset="-120"/>
+              </a:rPr>
+              <a:t>Insight Timer</a:t>
+            </a:r>
+            <a:endParaRPr lang="en-US" sz="950" dirty="0"/>
+          </a:p>
+        </p:txBody>
+      </p:sp>
+      <p:sp>
+        <p:nvSpPr>
+          <p:cNvPr id="13" name="Text 11"/>
+          <p:cNvSpPr/>
+          <p:nvPr/>
+        </p:nvSpPr>
+        <p:spPr>
+          <a:xfrm>
+            <a:off x="822960" y="3429000"/>
+            <a:ext cx="2743200" cy="365760"/>
+          </a:xfrm>
+          <a:prstGeom prst="rect">
+            <a:avLst/>
+          </a:prstGeom>
+          <a:noFill/>
+          <a:ln/>
+        </p:spPr>
+        <p:txBody>
+          <a:bodyPr wrap="square" lIns="0" tIns="0" rIns="0" bIns="0" rtlCol="0" anchor="t"/>
+          <a:lstStyle/>
+          <a:p>
+            <a:pPr indent="0" marL="0">
+              <a:buNone/>
+            </a:pPr>
+            <a:r>
+              <a:rPr lang="en-US" sz="1000" dirty="0">
+                <a:solidFill>
+                  <a:srgbClr val="93867A"/>
+                </a:solidFill>
+                <a:latin typeface="Calibri" pitchFamily="34" charset="0"/>
+                <a:ea typeface="Calibri" pitchFamily="34" charset="-122"/>
+                <a:cs typeface="Calibri" pitchFamily="34" charset="-120"/>
+              </a:rPr>
+              <a:t>owns the SERP for “one minute meditation reminder app”</a:t>
+            </a:r>
+            <a:endParaRPr lang="en-US" sz="1000" dirty="0"/>
+          </a:p>
+        </p:txBody>
+      </p:sp>
+      <p:sp>
+        <p:nvSpPr>
+          <p:cNvPr id="14" name="Shape 12"/>
+          <p:cNvSpPr/>
+          <p:nvPr/>
+        </p:nvSpPr>
+        <p:spPr>
+          <a:xfrm>
+            <a:off x="3931920" y="1783080"/>
+            <a:ext cx="4663440" cy="2514600"/>
+          </a:xfrm>
+          <a:prstGeom prst="rect">
+            <a:avLst/>
+          </a:prstGeom>
+          <a:solidFill>
+            <a:srgbClr val="161210"/>
+          </a:solidFill>
+          <a:ln w="12700">
+            <a:solidFill>
+              <a:srgbClr val="333333"/>
+            </a:solidFill>
+            <a:prstDash val="solid"/>
+          </a:ln>
+        </p:spPr>
+      </p:sp>
+      <p:sp>
+        <p:nvSpPr>
+          <p:cNvPr id="15" name="Text 13"/>
+          <p:cNvSpPr/>
+          <p:nvPr/>
+        </p:nvSpPr>
+        <p:spPr>
+          <a:xfrm>
+            <a:off x="4114800" y="1920240"/>
+            <a:ext cx="4297680" cy="274320"/>
+          </a:xfrm>
+          <a:prstGeom prst="rect">
+            <a:avLst/>
+          </a:prstGeom>
+          <a:noFill/>
+          <a:ln/>
+        </p:spPr>
+        <p:txBody>
+          <a:bodyPr wrap="square" lIns="0" tIns="0" rIns="0" bIns="0" rtlCol="0" anchor="ctr"/>
+          <a:lstStyle/>
+          <a:p>
+            <a:pPr indent="0" marL="0">
+              <a:buNone/>
+            </a:pPr>
+            <a:r>
+              <a:rPr lang="en-US" sz="850" spc="120" kern="0" dirty="0">
+                <a:solidFill>
+                  <a:srgbClr val="D9954A"/>
+                </a:solidFill>
+                <a:latin typeface="Courier New" pitchFamily="34" charset="0"/>
+                <a:ea typeface="Courier New" pitchFamily="34" charset="-122"/>
+                <a:cs typeface="Courier New" pitchFamily="34" charset="-120"/>
+              </a:rPr>
+              <a:t>WHAT NO RESULT OFFERS — FOUND BY A “WANT” QUERY</a:t>
+            </a:r>
+            <a:endParaRPr lang="en-US" sz="850" dirty="0"/>
+          </a:p>
+        </p:txBody>
+      </p:sp>
+      <p:sp>
+        <p:nvSpPr>
+          <p:cNvPr id="16" name="Text 14"/>
+          <p:cNvSpPr/>
+          <p:nvPr/>
+        </p:nvSpPr>
+        <p:spPr>
+          <a:xfrm>
+            <a:off x="4114800" y="2240280"/>
+            <a:ext cx="4297680" cy="777240"/>
+          </a:xfrm>
+          <a:prstGeom prst="rect">
+            <a:avLst/>
+          </a:prstGeom>
+          <a:noFill/>
+          <a:ln/>
+        </p:spPr>
+        <p:txBody>
+          <a:bodyPr wrap="square" lIns="0" tIns="0" rIns="0" bIns="0" rtlCol="0" anchor="t"/>
+          <a:lstStyle/>
+          <a:p>
+            <a:pPr indent="0" marL="0">
+              <a:buNone/>
+            </a:pPr>
+            <a:r>
+              <a:rPr lang="en-US" sz="1300" i="1" dirty="0">
                 <a:solidFill>
                   <a:srgbClr val="6E9BD1"/>
                 </a:solidFill>
@@ -5638,22 +5377,22 @@
                 <a:ea typeface="Cambria" pitchFamily="34" charset="-122"/>
                 <a:cs typeface="Cambria" pitchFamily="34" charset="-120"/>
               </a:rPr>
-              <a:t>“meditation helps me identify when I am not being present, However, when another same trigger arose, I was still reactive.”</a:t>
-            </a:r>
-            <a:endParaRPr lang="en-US" sz="1200" dirty="0"/>
-          </a:p>
-        </p:txBody>
-      </p:sp>
-      <p:sp>
-        <p:nvSpPr>
-          <p:cNvPr id="8" name="Text 5"/>
-          <p:cNvSpPr/>
-          <p:nvPr/>
-        </p:nvSpPr>
-        <p:spPr>
-          <a:xfrm>
-            <a:off x="4754880" y="2560320"/>
-            <a:ext cx="3840480" cy="228600"/>
+              <a:t>“My morning yoga includes setting an intention for the day… 23 minutes later I'm in the thick of…”</a:t>
+            </a:r>
+            <a:endParaRPr lang="en-US" sz="1300" dirty="0"/>
+          </a:p>
+        </p:txBody>
+      </p:sp>
+      <p:sp>
+        <p:nvSpPr>
+          <p:cNvPr id="17" name="Text 15"/>
+          <p:cNvSpPr/>
+          <p:nvPr/>
+        </p:nvSpPr>
+        <p:spPr>
+          <a:xfrm>
+            <a:off x="4114800" y="3063240"/>
+            <a:ext cx="4297680" cy="228600"/>
           </a:xfrm>
           <a:prstGeom prst="rect">
             <a:avLst/>
@@ -5677,7 +5416,7 @@
                 <a:ea typeface="Courier New" pitchFamily="34" charset="-122"/>
                 <a:cs typeface="Courier New" pitchFamily="34" charset="-120"/>
               </a:rPr>
-              <a:t>R/MEDITATION · VIA SERP</a:t>
+              <a:t>R/SELFIMPROVEMENT · #1 ORGANIC RESULT · VIA SERP</a:t>
             </a:r>
             <a:endParaRPr lang="en-US" sz="750" dirty="0"/>
           </a:p>
@@ -5685,14 +5424,14 @@
       </p:sp>
       <p:sp>
         <p:nvSpPr>
-          <p:cNvPr id="9" name="Text 6"/>
-          <p:cNvSpPr/>
-          <p:nvPr/>
-        </p:nvSpPr>
-        <p:spPr>
-          <a:xfrm>
-            <a:off x="4754880" y="2788920"/>
-            <a:ext cx="3840480" cy="548640"/>
+          <p:cNvPr id="18" name="Text 16"/>
+          <p:cNvSpPr/>
+          <p:nvPr/>
+        </p:nvSpPr>
+        <p:spPr>
+          <a:xfrm>
+            <a:off x="4114800" y="3383280"/>
+            <a:ext cx="4297680" cy="822960"/>
           </a:xfrm>
           <a:prstGeom prst="rect">
             <a:avLst/>
@@ -5708,30 +5447,30 @@
               <a:buNone/>
             </a:pPr>
             <a:r>
-              <a:rPr lang="en-US" sz="1200" i="1" dirty="0">
-                <a:solidFill>
-                  <a:srgbClr val="6E9BD1"/>
+              <a:rPr lang="en-US" sz="1300" dirty="0">
+                <a:solidFill>
+                  <a:srgbClr val="D9954A"/>
                 </a:solidFill>
                 <a:latin typeface="Cambria" pitchFamily="34" charset="0"/>
                 <a:ea typeface="Cambria" pitchFamily="34" charset="-122"/>
                 <a:cs typeface="Cambria" pitchFamily="34" charset="-120"/>
               </a:rPr>
-              <a:t>“It's been 2years already into meditation. I am still dealing with intrusive thoughts, anxiety.”</a:t>
-            </a:r>
-            <a:endParaRPr lang="en-US" sz="1200" dirty="0"/>
-          </a:p>
-        </p:txBody>
-      </p:sp>
-      <p:sp>
-        <p:nvSpPr>
-          <p:cNvPr id="10" name="Text 7"/>
-          <p:cNvSpPr/>
-          <p:nvPr/>
-        </p:nvSpPr>
-        <p:spPr>
-          <a:xfrm>
-            <a:off x="4754880" y="3383280"/>
-            <a:ext cx="3840480" cy="228600"/>
+              <a:t>Remembering your own sentence at the moment it matters. The bell is taken. The minute is taken. The intention is not.</a:t>
+            </a:r>
+            <a:endParaRPr lang="en-US" sz="1300" dirty="0"/>
+          </a:p>
+        </p:txBody>
+      </p:sp>
+      <p:sp>
+        <p:nvSpPr>
+          <p:cNvPr id="19" name="Text 17"/>
+          <p:cNvSpPr/>
+          <p:nvPr/>
+        </p:nvSpPr>
+        <p:spPr>
+          <a:xfrm>
+            <a:off x="548640" y="4434840"/>
+            <a:ext cx="8046720" cy="457200"/>
           </a:xfrm>
           <a:prstGeom prst="rect">
             <a:avLst/>
@@ -5747,95 +5486,17 @@
               <a:buNone/>
             </a:pPr>
             <a:r>
-              <a:rPr lang="en-US" sz="750" spc="80" kern="0" dirty="0">
-                <a:solidFill>
-                  <a:srgbClr val="3D5573"/>
-                </a:solidFill>
-                <a:latin typeface="Courier New" pitchFamily="34" charset="0"/>
-                <a:ea typeface="Courier New" pitchFamily="34" charset="-122"/>
-                <a:cs typeface="Courier New" pitchFamily="34" charset="-120"/>
-              </a:rPr>
-              <a:t>R/MEDITATION · 151 VOTES · VIA SERP</a:t>
-            </a:r>
-            <a:endParaRPr lang="en-US" sz="750" dirty="0"/>
-          </a:p>
-        </p:txBody>
-      </p:sp>
-      <p:sp>
-        <p:nvSpPr>
-          <p:cNvPr id="11" name="Text 8"/>
-          <p:cNvSpPr/>
-          <p:nvPr/>
-        </p:nvSpPr>
-        <p:spPr>
-          <a:xfrm>
-            <a:off x="4754880" y="3611880"/>
-            <a:ext cx="3840480" cy="777240"/>
-          </a:xfrm>
-          <a:prstGeom prst="rect">
-            <a:avLst/>
-          </a:prstGeom>
-          <a:noFill/>
-          <a:ln/>
-        </p:spPr>
-        <p:txBody>
-          <a:bodyPr wrap="square" lIns="0" tIns="0" rIns="0" bIns="0" rtlCol="0" anchor="t"/>
-          <a:lstStyle/>
-          <a:p>
-            <a:pPr indent="0" marL="0">
-              <a:buNone/>
-            </a:pPr>
-            <a:r>
               <a:rPr lang="en-US" sz="1200" i="1" dirty="0">
                 <a:solidFill>
-                  <a:srgbClr val="6E9BD1"/>
+                  <a:srgbClr val="EDE4D7"/>
                 </a:solidFill>
                 <a:latin typeface="Cambria" pitchFamily="34" charset="0"/>
                 <a:ea typeface="Cambria" pitchFamily="34" charset="-122"/>
                 <a:cs typeface="Cambria" pitchFamily="34" charset="-120"/>
               </a:rPr>
-              <a:t>“In order to change your behavior, you need to begin to bring your meditative mindset into daily life when you are in the act of making decisions…”</a:t>
+              <a:t>This slide is the ROI of the research: a positioning I would have shipped wrong, and a trademark collision, both caught for a few dollars of API calls.</a:t>
             </a:r>
             <a:endParaRPr lang="en-US" sz="1200" dirty="0"/>
-          </a:p>
-        </p:txBody>
-      </p:sp>
-      <p:sp>
-        <p:nvSpPr>
-          <p:cNvPr id="12" name="Text 9"/>
-          <p:cNvSpPr/>
-          <p:nvPr/>
-        </p:nvSpPr>
-        <p:spPr>
-          <a:xfrm>
-            <a:off x="4754880" y="4434840"/>
-            <a:ext cx="3840480" cy="228600"/>
-          </a:xfrm>
-          <a:prstGeom prst="rect">
-            <a:avLst/>
-          </a:prstGeom>
-          <a:noFill/>
-          <a:ln/>
-        </p:spPr>
-        <p:txBody>
-          <a:bodyPr wrap="square" lIns="0" tIns="0" rIns="0" bIns="0" rtlCol="0" anchor="ctr"/>
-          <a:lstStyle/>
-          <a:p>
-            <a:pPr indent="0" marL="0">
-              <a:buNone/>
-            </a:pPr>
-            <a:r>
-              <a:rPr lang="en-US" sz="750" spc="80" kern="0" dirty="0">
-                <a:solidFill>
-                  <a:srgbClr val="3D5573"/>
-                </a:solidFill>
-                <a:latin typeface="Courier New" pitchFamily="34" charset="0"/>
-                <a:ea typeface="Courier New" pitchFamily="34" charset="-122"/>
-                <a:cs typeface="Courier New" pitchFamily="34" charset="-120"/>
-              </a:rPr>
-              <a:t>R/MEDITATION · VIA SERP</a:t>
-            </a:r>
-            <a:endParaRPr lang="en-US" sz="750" dirty="0"/>
           </a:p>
         </p:txBody>
       </p:sp>
@@ -5879,8 +5540,8 @@
         </p:nvSpPr>
         <p:spPr>
           <a:xfrm>
-            <a:off x="6766560" y="457200"/>
-            <a:ext cx="1828800" cy="274320"/>
+            <a:off x="5852160" y="457200"/>
+            <a:ext cx="2743200" cy="274320"/>
           </a:xfrm>
           <a:prstGeom prst="rect">
             <a:avLst/>
@@ -5904,7 +5565,7 @@
                 <a:ea typeface="Courier New" pitchFamily="34" charset="-122"/>
                 <a:cs typeface="Courier New" pitchFamily="34" charset="-120"/>
               </a:rPr>
-              <a:t>RESULT · REFUTED</a:t>
+              <a:t>THE SHARPENED PRODUCT</a:t>
             </a:r>
             <a:endParaRPr lang="en-US" sz="900" dirty="0"/>
           </a:p>
@@ -5919,7 +5580,7 @@
         <p:spPr>
           <a:xfrm>
             <a:off x="548640" y="457200"/>
-            <a:ext cx="6400800" cy="274320"/>
+            <a:ext cx="5486400" cy="274320"/>
           </a:xfrm>
           <a:prstGeom prst="rect">
             <a:avLst/>
@@ -5937,13 +5598,13 @@
             <a:r>
               <a:rPr lang="en-US" sz="900" spc="150" kern="0" dirty="0">
                 <a:solidFill>
-                  <a:srgbClr val="6E9BD1"/>
-                </a:solidFill>
-                <a:latin typeface="Courier New" pitchFamily="34" charset="0"/>
-                <a:ea typeface="Courier New" pitchFamily="34" charset="-122"/>
-                <a:cs typeface="Courier New" pitchFamily="34" charset="-120"/>
-              </a:rPr>
-              <a:t>RESULT · THE COMPETITION QUERIES DID THEIR JOB</a:t>
+                  <a:srgbClr val="93867A"/>
+                </a:solidFill>
+                <a:latin typeface="Courier New" pitchFamily="34" charset="0"/>
+                <a:ea typeface="Courier New" pitchFamily="34" charset="-122"/>
+                <a:cs typeface="Courier New" pitchFamily="34" charset="-120"/>
+              </a:rPr>
+              <a:t>THE WAY · THE DATA SHARPENED THE PRODUCT</a:t>
             </a:r>
             <a:endParaRPr lang="en-US" sz="900" dirty="0"/>
           </a:p>
@@ -5958,7 +5619,7 @@
         <p:spPr>
           <a:xfrm>
             <a:off x="548640" y="777240"/>
-            <a:ext cx="8046720" cy="914400"/>
+            <a:ext cx="8046720" cy="640080"/>
           </a:xfrm>
           <a:prstGeom prst="rect">
             <a:avLst/>
@@ -5974,7 +5635,7 @@
               <a:buNone/>
             </a:pPr>
             <a:r>
-              <a:rPr lang="en-US" sz="2400" dirty="0">
+              <a:rPr lang="en-US" sz="2600" dirty="0">
                 <a:solidFill>
                   <a:srgbClr val="EDE4D7"/>
                 </a:solidFill>
@@ -5982,36 +5643,50 @@
                 <a:ea typeface="Cambria" pitchFamily="34" charset="-122"/>
                 <a:cs typeface="Cambria" pitchFamily="34" charset="-120"/>
               </a:rPr>
-              <a:t>The web refuted my positioning. The interrupt and the minute both already exist.</a:t>
-            </a:r>
-            <a:endParaRPr lang="en-US" sz="2400" dirty="0"/>
-          </a:p>
-        </p:txBody>
-      </p:sp>
-      <p:sp>
-        <p:nvSpPr>
-          <p:cNvPr id="5" name="Shape 3"/>
-          <p:cNvSpPr/>
-          <p:nvPr/>
-        </p:nvSpPr>
-        <p:spPr>
-          <a:xfrm>
-            <a:off x="548640" y="1947672"/>
-            <a:ext cx="118872" cy="118872"/>
-          </a:xfrm>
-          <a:prstGeom prst="ellipse">
-            <a:avLst/>
-          </a:prstGeom>
-          <a:solidFill>
-            <a:srgbClr val="6E9BD1"/>
-          </a:solidFill>
-          <a:ln w="12700">
-            <a:solidFill>
-              <a:srgbClr val="333333"/>
-            </a:solidFill>
-            <a:prstDash val="solid"/>
-          </a:ln>
-        </p:spPr>
+              <a:t>Not a reminder app. Not a meditation library.</a:t>
+            </a:r>
+            <a:endParaRPr lang="en-US" sz="2600" dirty="0"/>
+          </a:p>
+        </p:txBody>
+      </p:sp>
+      <p:sp>
+        <p:nvSpPr>
+          <p:cNvPr id="5" name="Text 3"/>
+          <p:cNvSpPr/>
+          <p:nvPr/>
+        </p:nvSpPr>
+        <p:spPr>
+          <a:xfrm>
+            <a:off x="548640" y="1645920"/>
+            <a:ext cx="3657600" cy="228600"/>
+          </a:xfrm>
+          <a:prstGeom prst="rect">
+            <a:avLst/>
+          </a:prstGeom>
+          <a:noFill/>
+          <a:ln/>
+        </p:spPr>
+        <p:txBody>
+          <a:bodyPr wrap="square" lIns="0" tIns="0" rIns="0" bIns="0" rtlCol="0" anchor="ctr"/>
+          <a:lstStyle/>
+          <a:p>
+            <a:pPr indent="0" marL="0">
+              <a:buNone/>
+            </a:pPr>
+            <a:r>
+              <a:rPr lang="en-US" sz="850" spc="150" kern="0" dirty="0">
+                <a:solidFill>
+                  <a:srgbClr val="6E9BD1"/>
+                </a:solidFill>
+                <a:latin typeface="Courier New" pitchFamily="34" charset="0"/>
+                <a:ea typeface="Courier New" pitchFamily="34" charset="-122"/>
+                <a:cs typeface="Courier New" pitchFamily="34" charset="-120"/>
+              </a:rPr>
+              <a:t>WHAT THE WEB SAID</a:t>
+            </a:r>
+            <a:endParaRPr lang="en-US" sz="850" dirty="0"/>
+          </a:p>
+        </p:txBody>
       </p:sp>
       <p:sp>
         <p:nvSpPr>
@@ -6021,8 +5696,8 @@
         </p:nvSpPr>
         <p:spPr>
           <a:xfrm>
-            <a:off x="822960" y="1874520"/>
-            <a:ext cx="2468880" cy="274320"/>
+            <a:off x="4846320" y="1645920"/>
+            <a:ext cx="3657600" cy="228600"/>
           </a:xfrm>
           <a:prstGeom prst="rect">
             <a:avLst/>
@@ -6038,17 +5713,17 @@
               <a:buNone/>
             </a:pPr>
             <a:r>
-              <a:rPr lang="en-US" sz="1050" b="1" dirty="0">
-                <a:solidFill>
-                  <a:srgbClr val="EDE4D7"/>
-                </a:solidFill>
-                <a:latin typeface="Courier New" pitchFamily="34" charset="0"/>
-                <a:ea typeface="Courier New" pitchFamily="34" charset="-122"/>
-                <a:cs typeface="Courier New" pitchFamily="34" charset="-120"/>
-              </a:rPr>
-              <a:t>Mindfulness Bell · MindBell · Chill</a:t>
-            </a:r>
-            <a:endParaRPr lang="en-US" sz="1050" dirty="0"/>
+              <a:rPr lang="en-US" sz="850" spc="150" kern="0" dirty="0">
+                <a:solidFill>
+                  <a:srgbClr val="D9954A"/>
+                </a:solidFill>
+                <a:latin typeface="Courier New" pitchFamily="34" charset="0"/>
+                <a:ea typeface="Courier New" pitchFamily="34" charset="-122"/>
+                <a:cs typeface="Courier New" pitchFamily="34" charset="-120"/>
+              </a:rPr>
+              <a:t>WHAT MOMENT BECAME</a:t>
+            </a:r>
+            <a:endParaRPr lang="en-US" sz="850" dirty="0"/>
           </a:p>
         </p:txBody>
       </p:sp>
@@ -6060,8 +5735,8 @@
         </p:nvSpPr>
         <p:spPr>
           <a:xfrm>
-            <a:off x="822960" y="2148840"/>
-            <a:ext cx="2651760" cy="365760"/>
+            <a:off x="548640" y="2011680"/>
+            <a:ext cx="3657600" cy="502920"/>
           </a:xfrm>
           <a:prstGeom prst="rect">
             <a:avLst/>
@@ -6077,44 +5752,58 @@
               <a:buNone/>
             </a:pPr>
             <a:r>
-              <a:rPr lang="en-US" sz="1000" dirty="0">
-                <a:solidFill>
-                  <a:srgbClr val="93867A"/>
+              <a:rPr lang="en-US" sz="1150" i="1" dirty="0">
+                <a:solidFill>
+                  <a:srgbClr val="6E9BD1"/>
+                </a:solidFill>
+                <a:latin typeface="Cambria" pitchFamily="34" charset="0"/>
+                <a:ea typeface="Cambria" pitchFamily="34" charset="-122"/>
+                <a:cs typeface="Cambria" pitchFamily="34" charset="-120"/>
+              </a:rPr>
+              <a:t>52% paywall fatigue · 17% lost simplicity · 16% choice overload</a:t>
+            </a:r>
+            <a:endParaRPr lang="en-US" sz="1150" dirty="0"/>
+          </a:p>
+        </p:txBody>
+      </p:sp>
+      <p:sp>
+        <p:nvSpPr>
+          <p:cNvPr id="8" name="Text 6"/>
+          <p:cNvSpPr/>
+          <p:nvPr/>
+        </p:nvSpPr>
+        <p:spPr>
+          <a:xfrm>
+            <a:off x="4206240" y="2029968"/>
+            <a:ext cx="548640" cy="320040"/>
+          </a:xfrm>
+          <a:prstGeom prst="rect">
+            <a:avLst/>
+          </a:prstGeom>
+          <a:noFill/>
+          <a:ln/>
+        </p:spPr>
+        <p:txBody>
+          <a:bodyPr wrap="square" lIns="0" tIns="0" rIns="0" bIns="0" rtlCol="0" anchor="ctr"/>
+          <a:lstStyle/>
+          <a:p>
+            <a:pPr algn="ctr" indent="0" marL="0">
+              <a:buNone/>
+            </a:pPr>
+            <a:r>
+              <a:rPr lang="en-US" sz="1600" dirty="0">
+                <a:solidFill>
+                  <a:srgbClr val="4A423A"/>
                 </a:solidFill>
                 <a:latin typeface="Calibri" pitchFamily="34" charset="0"/>
                 <a:ea typeface="Calibri" pitchFamily="34" charset="-122"/>
                 <a:cs typeface="Calibri" pitchFamily="34" charset="-120"/>
               </a:rPr>
-              <a:t>interval or random bells, all day</a:t>
-            </a:r>
-            <a:endParaRPr lang="en-US" sz="1000" dirty="0"/>
-          </a:p>
-        </p:txBody>
-      </p:sp>
-      <p:sp>
-        <p:nvSpPr>
-          <p:cNvPr id="8" name="Shape 6"/>
-          <p:cNvSpPr/>
-          <p:nvPr/>
-        </p:nvSpPr>
-        <p:spPr>
-          <a:xfrm>
-            <a:off x="548640" y="2587752"/>
-            <a:ext cx="118872" cy="118872"/>
-          </a:xfrm>
-          <a:prstGeom prst="ellipse">
-            <a:avLst/>
-          </a:prstGeom>
-          <a:solidFill>
-            <a:srgbClr val="6E9BD1"/>
-          </a:solidFill>
-          <a:ln w="12700">
-            <a:solidFill>
-              <a:srgbClr val="333333"/>
-            </a:solidFill>
-            <a:prstDash val="solid"/>
-          </a:ln>
-        </p:spPr>
+              <a:t>→</a:t>
+            </a:r>
+            <a:endParaRPr lang="en-US" sz="1600" dirty="0"/>
+          </a:p>
+        </p:txBody>
       </p:sp>
       <p:sp>
         <p:nvSpPr>
@@ -6124,47 +5813,8 @@
         </p:nvSpPr>
         <p:spPr>
           <a:xfrm>
-            <a:off x="822960" y="2514600"/>
-            <a:ext cx="2468880" cy="274320"/>
-          </a:xfrm>
-          <a:prstGeom prst="rect">
-            <a:avLst/>
-          </a:prstGeom>
-          <a:noFill/>
-          <a:ln/>
-        </p:spPr>
-        <p:txBody>
-          <a:bodyPr wrap="square" lIns="0" tIns="0" rIns="0" bIns="0" rtlCol="0" anchor="ctr"/>
-          <a:lstStyle/>
-          <a:p>
-            <a:pPr indent="0" marL="0">
-              <a:buNone/>
-            </a:pPr>
-            <a:r>
-              <a:rPr lang="en-US" sz="1050" b="1" dirty="0">
-                <a:solidFill>
-                  <a:srgbClr val="EDE4D7"/>
-                </a:solidFill>
-                <a:latin typeface="Courier New" pitchFamily="34" charset="0"/>
-                <a:ea typeface="Courier New" pitchFamily="34" charset="-122"/>
-                <a:cs typeface="Courier New" pitchFamily="34" charset="-120"/>
-              </a:rPr>
-              <a:t>One-Moment Meditation®</a:t>
-            </a:r>
-            <a:endParaRPr lang="en-US" sz="1050" dirty="0"/>
-          </a:p>
-        </p:txBody>
-      </p:sp>
-      <p:sp>
-        <p:nvSpPr>
-          <p:cNvPr id="10" name="Text 8"/>
-          <p:cNvSpPr/>
-          <p:nvPr/>
-        </p:nvSpPr>
-        <p:spPr>
-          <a:xfrm>
-            <a:off x="822960" y="2788920"/>
-            <a:ext cx="2651760" cy="365760"/>
+            <a:off x="4846320" y="2011680"/>
+            <a:ext cx="3749040" cy="502920"/>
           </a:xfrm>
           <a:prstGeom prst="rect">
             <a:avLst/>
@@ -6180,55 +5830,69 @@
               <a:buNone/>
             </a:pPr>
             <a:r>
-              <a:rPr lang="en-US" sz="1000" dirty="0">
-                <a:solidFill>
-                  <a:srgbClr val="93867A"/>
+              <a:rPr lang="en-US" sz="1200" dirty="0">
+                <a:solidFill>
+                  <a:srgbClr val="D9954A"/>
                 </a:solidFill>
                 <a:latin typeface="Calibri" pitchFamily="34" charset="0"/>
                 <a:ea typeface="Calibri" pitchFamily="34" charset="-122"/>
                 <a:cs typeface="Calibri" pitchFamily="34" charset="-120"/>
               </a:rPr>
-              <a:t>one-minute exercise + reminders — and a registered mark</a:t>
-            </a:r>
-            <a:endParaRPr lang="en-US" sz="1000" dirty="0"/>
-          </a:p>
-        </p:txBody>
-      </p:sp>
-      <p:sp>
-        <p:nvSpPr>
-          <p:cNvPr id="11" name="Shape 9"/>
-          <p:cNvSpPr/>
-          <p:nvPr/>
-        </p:nvSpPr>
-        <p:spPr>
-          <a:xfrm>
-            <a:off x="548640" y="3227832"/>
-            <a:ext cx="118872" cy="118872"/>
-          </a:xfrm>
-          <a:prstGeom prst="ellipse">
-            <a:avLst/>
-          </a:prstGeom>
-          <a:solidFill>
-            <a:srgbClr val="6E9BD1"/>
-          </a:solidFill>
-          <a:ln w="12700">
-            <a:solidFill>
-              <a:srgbClr val="333333"/>
-            </a:solidFill>
-            <a:prstDash val="solid"/>
-          </a:ln>
-        </p:spPr>
-      </p:sp>
-      <p:sp>
-        <p:nvSpPr>
-          <p:cNvPr id="12" name="Text 10"/>
-          <p:cNvSpPr/>
-          <p:nvPr/>
-        </p:nvSpPr>
-        <p:spPr>
-          <a:xfrm>
-            <a:off x="822960" y="3154680"/>
-            <a:ext cx="2468880" cy="274320"/>
+              <a:t>One sentence. Nothing to choose, nothing to unlock.</a:t>
+            </a:r>
+            <a:endParaRPr lang="en-US" sz="1200" dirty="0"/>
+          </a:p>
+        </p:txBody>
+      </p:sp>
+      <p:sp>
+        <p:nvSpPr>
+          <p:cNvPr id="10" name="Text 8"/>
+          <p:cNvSpPr/>
+          <p:nvPr/>
+        </p:nvSpPr>
+        <p:spPr>
+          <a:xfrm>
+            <a:off x="548640" y="2578608"/>
+            <a:ext cx="3657600" cy="502920"/>
+          </a:xfrm>
+          <a:prstGeom prst="rect">
+            <a:avLst/>
+          </a:prstGeom>
+          <a:noFill/>
+          <a:ln/>
+        </p:spPr>
+        <p:txBody>
+          <a:bodyPr wrap="square" lIns="0" tIns="0" rIns="0" bIns="0" rtlCol="0" anchor="t"/>
+          <a:lstStyle/>
+          <a:p>
+            <a:pPr indent="0" marL="0">
+              <a:buNone/>
+            </a:pPr>
+            <a:r>
+              <a:rPr lang="en-US" sz="1150" i="1" dirty="0">
+                <a:solidFill>
+                  <a:srgbClr val="6E9BD1"/>
+                </a:solidFill>
+                <a:latin typeface="Cambria" pitchFamily="34" charset="0"/>
+                <a:ea typeface="Cambria" pitchFamily="34" charset="-122"/>
+                <a:cs typeface="Cambria" pitchFamily="34" charset="-120"/>
+              </a:rPr>
+              <a:t>“when another same trigger arose, I was still reactive”</a:t>
+            </a:r>
+            <a:endParaRPr lang="en-US" sz="1150" dirty="0"/>
+          </a:p>
+        </p:txBody>
+      </p:sp>
+      <p:sp>
+        <p:nvSpPr>
+          <p:cNvPr id="11" name="Text 9"/>
+          <p:cNvSpPr/>
+          <p:nvPr/>
+        </p:nvSpPr>
+        <p:spPr>
+          <a:xfrm>
+            <a:off x="4206240" y="2596896"/>
+            <a:ext cx="548640" cy="320040"/>
           </a:xfrm>
           <a:prstGeom prst="rect">
             <a:avLst/>
@@ -6240,137 +5904,73 @@
           <a:bodyPr wrap="square" lIns="0" tIns="0" rIns="0" bIns="0" rtlCol="0" anchor="ctr"/>
           <a:lstStyle/>
           <a:p>
-            <a:pPr indent="0" marL="0">
-              <a:buNone/>
-            </a:pPr>
-            <a:r>
-              <a:rPr lang="en-US" sz="1050" b="1" dirty="0">
-                <a:solidFill>
-                  <a:srgbClr val="EDE4D7"/>
-                </a:solidFill>
-                <a:latin typeface="Courier New" pitchFamily="34" charset="0"/>
-                <a:ea typeface="Courier New" pitchFamily="34" charset="-122"/>
-                <a:cs typeface="Courier New" pitchFamily="34" charset="-120"/>
-              </a:rPr>
-              <a:t>Insight Timer</a:t>
-            </a:r>
-            <a:endParaRPr lang="en-US" sz="1050" dirty="0"/>
-          </a:p>
-        </p:txBody>
-      </p:sp>
-      <p:sp>
-        <p:nvSpPr>
-          <p:cNvPr id="13" name="Text 11"/>
-          <p:cNvSpPr/>
-          <p:nvPr/>
-        </p:nvSpPr>
-        <p:spPr>
-          <a:xfrm>
-            <a:off x="822960" y="3429000"/>
-            <a:ext cx="2651760" cy="365760"/>
-          </a:xfrm>
-          <a:prstGeom prst="rect">
-            <a:avLst/>
-          </a:prstGeom>
-          <a:noFill/>
-          <a:ln/>
-        </p:spPr>
-        <p:txBody>
-          <a:bodyPr wrap="square" lIns="0" tIns="0" rIns="0" bIns="0" rtlCol="0" anchor="t"/>
-          <a:lstStyle/>
-          <a:p>
-            <a:pPr indent="0" marL="0">
-              <a:buNone/>
-            </a:pPr>
-            <a:r>
-              <a:rPr lang="en-US" sz="1000" dirty="0">
-                <a:solidFill>
-                  <a:srgbClr val="93867A"/>
+            <a:pPr algn="ctr" indent="0" marL="0">
+              <a:buNone/>
+            </a:pPr>
+            <a:r>
+              <a:rPr lang="en-US" sz="1600" dirty="0">
+                <a:solidFill>
+                  <a:srgbClr val="4A423A"/>
                 </a:solidFill>
                 <a:latin typeface="Calibri" pitchFamily="34" charset="0"/>
                 <a:ea typeface="Calibri" pitchFamily="34" charset="-122"/>
                 <a:cs typeface="Calibri" pitchFamily="34" charset="-120"/>
               </a:rPr>
-              <a:t>owns the SERP for “one minute meditation reminder app”</a:t>
-            </a:r>
-            <a:endParaRPr lang="en-US" sz="1000" dirty="0"/>
-          </a:p>
-        </p:txBody>
-      </p:sp>
-      <p:sp>
-        <p:nvSpPr>
-          <p:cNvPr id="14" name="Shape 12"/>
-          <p:cNvSpPr/>
-          <p:nvPr/>
-        </p:nvSpPr>
-        <p:spPr>
-          <a:xfrm>
-            <a:off x="3931920" y="1783080"/>
-            <a:ext cx="4663440" cy="2514600"/>
-          </a:xfrm>
-          <a:prstGeom prst="rect">
-            <a:avLst/>
-          </a:prstGeom>
-          <a:solidFill>
-            <a:srgbClr val="161210"/>
-          </a:solidFill>
-          <a:ln w="12700">
-            <a:solidFill>
-              <a:srgbClr val="333333"/>
-            </a:solidFill>
-            <a:prstDash val="solid"/>
-          </a:ln>
-        </p:spPr>
-      </p:sp>
-      <p:sp>
-        <p:nvSpPr>
-          <p:cNvPr id="15" name="Text 13"/>
-          <p:cNvSpPr/>
-          <p:nvPr/>
-        </p:nvSpPr>
-        <p:spPr>
-          <a:xfrm>
-            <a:off x="4114800" y="1920240"/>
-            <a:ext cx="4297680" cy="274320"/>
-          </a:xfrm>
-          <a:prstGeom prst="rect">
-            <a:avLst/>
-          </a:prstGeom>
-          <a:noFill/>
-          <a:ln/>
-        </p:spPr>
-        <p:txBody>
-          <a:bodyPr wrap="square" lIns="0" tIns="0" rIns="0" bIns="0" rtlCol="0" anchor="ctr"/>
-          <a:lstStyle/>
-          <a:p>
-            <a:pPr indent="0" marL="0">
-              <a:buNone/>
-            </a:pPr>
-            <a:r>
-              <a:rPr lang="en-US" sz="850" spc="120" kern="0" dirty="0">
+              <a:t>→</a:t>
+            </a:r>
+            <a:endParaRPr lang="en-US" sz="1600" dirty="0"/>
+          </a:p>
+        </p:txBody>
+      </p:sp>
+      <p:sp>
+        <p:nvSpPr>
+          <p:cNvPr id="12" name="Text 10"/>
+          <p:cNvSpPr/>
+          <p:nvPr/>
+        </p:nvSpPr>
+        <p:spPr>
+          <a:xfrm>
+            <a:off x="4846320" y="2578608"/>
+            <a:ext cx="3749040" cy="502920"/>
+          </a:xfrm>
+          <a:prstGeom prst="rect">
+            <a:avLst/>
+          </a:prstGeom>
+          <a:noFill/>
+          <a:ln/>
+        </p:spPr>
+        <p:txBody>
+          <a:bodyPr wrap="square" lIns="0" tIns="0" rIns="0" bIns="0" rtlCol="0" anchor="t"/>
+          <a:lstStyle/>
+          <a:p>
+            <a:pPr indent="0" marL="0">
+              <a:buNone/>
+            </a:pPr>
+            <a:r>
+              <a:rPr lang="en-US" sz="1200" dirty="0">
                 <a:solidFill>
                   <a:srgbClr val="D9954A"/>
                 </a:solidFill>
-                <a:latin typeface="Courier New" pitchFamily="34" charset="0"/>
-                <a:ea typeface="Courier New" pitchFamily="34" charset="-122"/>
-                <a:cs typeface="Courier New" pitchFamily="34" charset="-120"/>
-              </a:rPr>
-              <a:t>WHAT NO RESULT OFFERS — FOUND BY A “WANT” QUERY</a:t>
-            </a:r>
-            <a:endParaRPr lang="en-US" sz="850" dirty="0"/>
-          </a:p>
-        </p:txBody>
-      </p:sp>
-      <p:sp>
-        <p:nvSpPr>
-          <p:cNvPr id="16" name="Text 14"/>
-          <p:cNvSpPr/>
-          <p:nvPr/>
-        </p:nvSpPr>
-        <p:spPr>
-          <a:xfrm>
-            <a:off x="4114800" y="2240280"/>
-            <a:ext cx="4297680" cy="777240"/>
+                <a:latin typeface="Calibri" pitchFamily="34" charset="0"/>
+                <a:ea typeface="Calibri" pitchFamily="34" charset="-122"/>
+                <a:cs typeface="Calibri" pitchFamily="34" charset="-120"/>
+              </a:rPr>
+              <a:t>A pause every thirty minutes — inside the day, not beside it.</a:t>
+            </a:r>
+            <a:endParaRPr lang="en-US" sz="1200" dirty="0"/>
+          </a:p>
+        </p:txBody>
+      </p:sp>
+      <p:sp>
+        <p:nvSpPr>
+          <p:cNvPr id="13" name="Text 11"/>
+          <p:cNvSpPr/>
+          <p:nvPr/>
+        </p:nvSpPr>
+        <p:spPr>
+          <a:xfrm>
+            <a:off x="548640" y="3145536"/>
+            <a:ext cx="3657600" cy="502920"/>
           </a:xfrm>
           <a:prstGeom prst="rect">
             <a:avLst/>
@@ -6386,7 +5986,7 @@
               <a:buNone/>
             </a:pPr>
             <a:r>
-              <a:rPr lang="en-US" sz="1300" i="1" dirty="0">
+              <a:rPr lang="en-US" sz="1150" i="1" dirty="0">
                 <a:solidFill>
                   <a:srgbClr val="6E9BD1"/>
                 </a:solidFill>
@@ -6394,22 +5994,22 @@
                 <a:ea typeface="Cambria" pitchFamily="34" charset="-122"/>
                 <a:cs typeface="Cambria" pitchFamily="34" charset="-120"/>
               </a:rPr>
-              <a:t>“My morning yoga includes setting an intention for the day… 23 minutes later I'm in the thick of…”</a:t>
-            </a:r>
-            <a:endParaRPr lang="en-US" sz="1300" dirty="0"/>
-          </a:p>
-        </p:txBody>
-      </p:sp>
-      <p:sp>
-        <p:nvSpPr>
-          <p:cNvPr id="17" name="Text 15"/>
-          <p:cNvSpPr/>
-          <p:nvPr/>
-        </p:nvSpPr>
-        <p:spPr>
-          <a:xfrm>
-            <a:off x="4114800" y="3063240"/>
-            <a:ext cx="4297680" cy="228600"/>
+              <a:t>the bell is taken · the minute is taken (One-Moment Meditation®)</a:t>
+            </a:r>
+            <a:endParaRPr lang="en-US" sz="1150" dirty="0"/>
+          </a:p>
+        </p:txBody>
+      </p:sp>
+      <p:sp>
+        <p:nvSpPr>
+          <p:cNvPr id="14" name="Text 12"/>
+          <p:cNvSpPr/>
+          <p:nvPr/>
+        </p:nvSpPr>
+        <p:spPr>
+          <a:xfrm>
+            <a:off x="4206240" y="3163824"/>
+            <a:ext cx="548640" cy="320040"/>
           </a:xfrm>
           <a:prstGeom prst="rect">
             <a:avLst/>
@@ -6421,34 +6021,34 @@
           <a:bodyPr wrap="square" lIns="0" tIns="0" rIns="0" bIns="0" rtlCol="0" anchor="ctr"/>
           <a:lstStyle/>
           <a:p>
-            <a:pPr indent="0" marL="0">
-              <a:buNone/>
-            </a:pPr>
-            <a:r>
-              <a:rPr lang="en-US" sz="750" spc="80" kern="0" dirty="0">
-                <a:solidFill>
-                  <a:srgbClr val="3D5573"/>
-                </a:solidFill>
-                <a:latin typeface="Courier New" pitchFamily="34" charset="0"/>
-                <a:ea typeface="Courier New" pitchFamily="34" charset="-122"/>
-                <a:cs typeface="Courier New" pitchFamily="34" charset="-120"/>
-              </a:rPr>
-              <a:t>R/SELFIMPROVEMENT · #1 ORGANIC RESULT · VIA SERP</a:t>
-            </a:r>
-            <a:endParaRPr lang="en-US" sz="750" dirty="0"/>
-          </a:p>
-        </p:txBody>
-      </p:sp>
-      <p:sp>
-        <p:nvSpPr>
-          <p:cNvPr id="18" name="Text 16"/>
-          <p:cNvSpPr/>
-          <p:nvPr/>
-        </p:nvSpPr>
-        <p:spPr>
-          <a:xfrm>
-            <a:off x="4114800" y="3383280"/>
-            <a:ext cx="4297680" cy="822960"/>
+            <a:pPr algn="ctr" indent="0" marL="0">
+              <a:buNone/>
+            </a:pPr>
+            <a:r>
+              <a:rPr lang="en-US" sz="1600" dirty="0">
+                <a:solidFill>
+                  <a:srgbClr val="4A423A"/>
+                </a:solidFill>
+                <a:latin typeface="Calibri" pitchFamily="34" charset="0"/>
+                <a:ea typeface="Calibri" pitchFamily="34" charset="-122"/>
+                <a:cs typeface="Calibri" pitchFamily="34" charset="-120"/>
+              </a:rPr>
+              <a:t>→</a:t>
+            </a:r>
+            <a:endParaRPr lang="en-US" sz="1600" dirty="0"/>
+          </a:p>
+        </p:txBody>
+      </p:sp>
+      <p:sp>
+        <p:nvSpPr>
+          <p:cNvPr id="15" name="Text 13"/>
+          <p:cNvSpPr/>
+          <p:nvPr/>
+        </p:nvSpPr>
+        <p:spPr>
+          <a:xfrm>
+            <a:off x="4846320" y="3145536"/>
+            <a:ext cx="3749040" cy="502920"/>
           </a:xfrm>
           <a:prstGeom prst="rect">
             <a:avLst/>
@@ -6464,17 +6064,134 @@
               <a:buNone/>
             </a:pPr>
             <a:r>
-              <a:rPr lang="en-US" sz="1300" dirty="0">
+              <a:rPr lang="en-US" sz="1200" dirty="0">
                 <a:solidFill>
                   <a:srgbClr val="D9954A"/>
+                </a:solidFill>
+                <a:latin typeface="Calibri" pitchFamily="34" charset="0"/>
+                <a:ea typeface="Calibri" pitchFamily="34" charset="-122"/>
+                <a:cs typeface="Calibri" pitchFamily="34" charset="-120"/>
+              </a:rPr>
+              <a:t>Not a bell. It hands you back your own sentence.</a:t>
+            </a:r>
+            <a:endParaRPr lang="en-US" sz="1200" dirty="0"/>
+          </a:p>
+        </p:txBody>
+      </p:sp>
+      <p:sp>
+        <p:nvSpPr>
+          <p:cNvPr id="16" name="Text 14"/>
+          <p:cNvSpPr/>
+          <p:nvPr/>
+        </p:nvSpPr>
+        <p:spPr>
+          <a:xfrm>
+            <a:off x="548640" y="3712464"/>
+            <a:ext cx="3657600" cy="502920"/>
+          </a:xfrm>
+          <a:prstGeom prst="rect">
+            <a:avLst/>
+          </a:prstGeom>
+          <a:noFill/>
+          <a:ln/>
+        </p:spPr>
+        <p:txBody>
+          <a:bodyPr wrap="square" lIns="0" tIns="0" rIns="0" bIns="0" rtlCol="0" anchor="t"/>
+          <a:lstStyle/>
+          <a:p>
+            <a:pPr indent="0" marL="0">
+              <a:buNone/>
+            </a:pPr>
+            <a:r>
+              <a:rPr lang="en-US" sz="1150" i="1" dirty="0">
+                <a:solidFill>
+                  <a:srgbClr val="6E9BD1"/>
                 </a:solidFill>
                 <a:latin typeface="Cambria" pitchFamily="34" charset="0"/>
                 <a:ea typeface="Cambria" pitchFamily="34" charset="-122"/>
                 <a:cs typeface="Cambria" pitchFamily="34" charset="-120"/>
               </a:rPr>
-              <a:t>Remembering your own sentence at the moment it matters. The bell is taken. The minute is taken. The intention is not.</a:t>
-            </a:r>
-            <a:endParaRPr lang="en-US" sz="1300" dirty="0"/>
+              <a:t>“23 minutes later I'm in the thick of…”</a:t>
+            </a:r>
+            <a:endParaRPr lang="en-US" sz="1150" dirty="0"/>
+          </a:p>
+        </p:txBody>
+      </p:sp>
+      <p:sp>
+        <p:nvSpPr>
+          <p:cNvPr id="17" name="Text 15"/>
+          <p:cNvSpPr/>
+          <p:nvPr/>
+        </p:nvSpPr>
+        <p:spPr>
+          <a:xfrm>
+            <a:off x="4206240" y="3730752"/>
+            <a:ext cx="548640" cy="320040"/>
+          </a:xfrm>
+          <a:prstGeom prst="rect">
+            <a:avLst/>
+          </a:prstGeom>
+          <a:noFill/>
+          <a:ln/>
+        </p:spPr>
+        <p:txBody>
+          <a:bodyPr wrap="square" lIns="0" tIns="0" rIns="0" bIns="0" rtlCol="0" anchor="ctr"/>
+          <a:lstStyle/>
+          <a:p>
+            <a:pPr algn="ctr" indent="0" marL="0">
+              <a:buNone/>
+            </a:pPr>
+            <a:r>
+              <a:rPr lang="en-US" sz="1600" dirty="0">
+                <a:solidFill>
+                  <a:srgbClr val="4A423A"/>
+                </a:solidFill>
+                <a:latin typeface="Calibri" pitchFamily="34" charset="0"/>
+                <a:ea typeface="Calibri" pitchFamily="34" charset="-122"/>
+                <a:cs typeface="Calibri" pitchFamily="34" charset="-120"/>
+              </a:rPr>
+              <a:t>→</a:t>
+            </a:r>
+            <a:endParaRPr lang="en-US" sz="1600" dirty="0"/>
+          </a:p>
+        </p:txBody>
+      </p:sp>
+      <p:sp>
+        <p:nvSpPr>
+          <p:cNvPr id="18" name="Text 16"/>
+          <p:cNvSpPr/>
+          <p:nvPr/>
+        </p:nvSpPr>
+        <p:spPr>
+          <a:xfrm>
+            <a:off x="4846320" y="3712464"/>
+            <a:ext cx="3749040" cy="502920"/>
+          </a:xfrm>
+          <a:prstGeom prst="rect">
+            <a:avLst/>
+          </a:prstGeom>
+          <a:noFill/>
+          <a:ln/>
+        </p:spPr>
+        <p:txBody>
+          <a:bodyPr wrap="square" lIns="0" tIns="0" rIns="0" bIns="0" rtlCol="0" anchor="t"/>
+          <a:lstStyle/>
+          <a:p>
+            <a:pPr indent="0" marL="0">
+              <a:buNone/>
+            </a:pPr>
+            <a:r>
+              <a:rPr lang="en-US" sz="1200" dirty="0">
+                <a:solidFill>
+                  <a:srgbClr val="D9954A"/>
+                </a:solidFill>
+                <a:latin typeface="Calibri" pitchFamily="34" charset="0"/>
+                <a:ea typeface="Calibri" pitchFamily="34" charset="-122"/>
+                <a:cs typeface="Calibri" pitchFamily="34" charset="-120"/>
+              </a:rPr>
+              <a:t>One minute to breathe — and choose again.</a:t>
+            </a:r>
+            <a:endParaRPr lang="en-US" sz="1200" dirty="0"/>
           </a:p>
         </p:txBody>
       </p:sp>
@@ -6486,8 +6203,8 @@
         </p:nvSpPr>
         <p:spPr>
           <a:xfrm>
-            <a:off x="548640" y="4434840"/>
-            <a:ext cx="8046720" cy="457200"/>
+            <a:off x="548640" y="4389120"/>
+            <a:ext cx="8046720" cy="411480"/>
           </a:xfrm>
           <a:prstGeom prst="rect">
             <a:avLst/>
@@ -6503,7 +6220,7 @@
               <a:buNone/>
             </a:pPr>
             <a:r>
-              <a:rPr lang="en-US" sz="1200" i="1" dirty="0">
+              <a:rPr lang="en-US" sz="1500" i="1" dirty="0">
                 <a:solidFill>
                   <a:srgbClr val="EDE4D7"/>
                 </a:solidFill>
@@ -6511,9 +6228,9 @@
                 <a:ea typeface="Cambria" pitchFamily="34" charset="-122"/>
                 <a:cs typeface="Cambria" pitchFamily="34" charset="-120"/>
               </a:rPr>
-              <a:t>This slide is the ROI of the research: a positioning I would have shipped wrong, and a trademark collision, both caught for a few dollars of API calls.</a:t>
-            </a:r>
-            <a:endParaRPr lang="en-US" sz="1200" dirty="0"/>
+              <a:t>One intention. One minute. In the moment it matters.</a:t>
+            </a:r>
+            <a:endParaRPr lang="en-US" sz="1500" dirty="0"/>
           </a:p>
         </p:txBody>
       </p:sp>
@@ -6557,8 +6274,8 @@
         </p:nvSpPr>
         <p:spPr>
           <a:xfrm>
-            <a:off x="6766560" y="457200"/>
-            <a:ext cx="1828800" cy="274320"/>
+            <a:off x="5852160" y="457200"/>
+            <a:ext cx="2743200" cy="274320"/>
           </a:xfrm>
           <a:prstGeom prst="rect">
             <a:avLst/>
@@ -6660,7 +6377,7 @@
                 <a:ea typeface="Cambria" pitchFamily="34" charset="-122"/>
                 <a:cs typeface="Cambria" pitchFamily="34" charset="-120"/>
               </a:rPr>
-              <a:t>Let's ask the web something I haven't asked yet.</a:t>
+              <a:t>Let's ask the web something from this room.</a:t>
             </a:r>
             <a:endParaRPr lang="en-US" sz="2600" dirty="0"/>
           </a:p>
@@ -6675,7 +6392,7 @@
         <p:spPr>
           <a:xfrm>
             <a:off x="548640" y="1554480"/>
-            <a:ext cx="8046720" cy="2377440"/>
+            <a:ext cx="8046720" cy="2514600"/>
           </a:xfrm>
           <a:prstGeom prst="rect">
             <a:avLst/>
@@ -6700,7 +6417,7 @@
         <p:spPr>
           <a:xfrm>
             <a:off x="713232" y="1664208"/>
-            <a:ext cx="7717536" cy="2157984"/>
+            <a:ext cx="7717536" cy="2295144"/>
           </a:xfrm>
           <a:prstGeom prst="rect">
             <a:avLst/>
@@ -6719,7 +6436,7 @@
               <a:buNone/>
             </a:pPr>
             <a:r>
-              <a:rPr lang="en-US" sz="900" dirty="0">
+              <a:rPr lang="en-US" sz="850" dirty="0">
                 <a:solidFill>
                   <a:srgbClr val="EDE4D7"/>
                 </a:solidFill>
@@ -6729,7 +6446,7 @@
               </a:rPr>
               <a:t>$ node src/ask.js "how to remember my intention for the day"</a:t>
             </a:r>
-            <a:endParaRPr lang="en-US" sz="900" dirty="0"/>
+            <a:endParaRPr lang="en-US" sz="850" dirty="0"/>
           </a:p>
           <a:p>
             <a:pPr indent="0" marL="0">
@@ -6738,7 +6455,7 @@
               </a:lnSpc>
               <a:buNone/>
             </a:pPr>
-            <a:endParaRPr lang="en-US" sz="900" dirty="0"/>
+            <a:endParaRPr lang="en-US" sz="850" dirty="0"/>
           </a:p>
           <a:p>
             <a:pPr indent="0" marL="0">
@@ -6748,7 +6465,7 @@
               <a:buNone/>
             </a:pPr>
             <a:r>
-              <a:rPr lang="en-US" sz="900" dirty="0">
+              <a:rPr lang="en-US" sz="850" dirty="0">
                 <a:solidFill>
                   <a:srgbClr val="EDE4D7"/>
                 </a:solidFill>
@@ -6758,7 +6475,7 @@
               </a:rPr>
               <a:t>▸ POST https://api.brightdata.com/request</a:t>
             </a:r>
-            <a:endParaRPr lang="en-US" sz="900" dirty="0"/>
+            <a:endParaRPr lang="en-US" sz="850" dirty="0"/>
           </a:p>
           <a:p>
             <a:pPr indent="0" marL="0">
@@ -6768,7 +6485,7 @@
               <a:buNone/>
             </a:pPr>
             <a:r>
-              <a:rPr lang="en-US" sz="900" dirty="0">
+              <a:rPr lang="en-US" sz="850" dirty="0">
                 <a:solidFill>
                   <a:srgbClr val="EDE4D7"/>
                 </a:solidFill>
@@ -6776,9 +6493,9 @@
                 <a:ea typeface="Courier New" pitchFamily="34" charset="-122"/>
                 <a:cs typeface="Courier New" pitchFamily="34" charset="-120"/>
               </a:rPr>
-              <a:t>  { zone: SERP, url: google.com/search?q=…&amp;brd_json=1 }</a:t>
-            </a:r>
-            <a:endParaRPr lang="en-US" sz="900" dirty="0"/>
+              <a:t>  { zone: SERP, url: google.com/search?q="how to remember my intention for the day"&amp;brd_json=1 }</a:t>
+            </a:r>
+            <a:endParaRPr lang="en-US" sz="850" dirty="0"/>
           </a:p>
           <a:p>
             <a:pPr indent="0" marL="0">
@@ -6787,7 +6504,7 @@
               </a:lnSpc>
               <a:buNone/>
             </a:pPr>
-            <a:endParaRPr lang="en-US" sz="900" dirty="0"/>
+            <a:endParaRPr lang="en-US" sz="850" dirty="0"/>
           </a:p>
           <a:p>
             <a:pPr indent="0" marL="0">
@@ -6797,7 +6514,7 @@
               <a:buNone/>
             </a:pPr>
             <a:r>
-              <a:rPr lang="en-US" sz="900" dirty="0">
+              <a:rPr lang="en-US" sz="850" dirty="0">
                 <a:solidFill>
                   <a:srgbClr val="EDE4D7"/>
                 </a:solidFill>
@@ -6805,9 +6522,9 @@
                 <a:ea typeface="Courier New" pitchFamily="34" charset="-122"/>
                 <a:cs typeface="Courier New" pitchFamily="34" charset="-120"/>
               </a:rPr>
-              <a:t>  8 organic results · 1813 ms · parsed by Bright Data, zero HTML touched</a:t>
-            </a:r>
-            <a:endParaRPr lang="en-US" sz="900" dirty="0"/>
+              <a:t>  8 organic results · 1445 ms · parsed by Bright Data, zero HTML touched</a:t>
+            </a:r>
+            <a:endParaRPr lang="en-US" sz="850" dirty="0"/>
           </a:p>
           <a:p>
             <a:pPr indent="0" marL="0">
@@ -6816,7 +6533,7 @@
               </a:lnSpc>
               <a:buNone/>
             </a:pPr>
-            <a:endParaRPr lang="en-US" sz="900" dirty="0"/>
+            <a:endParaRPr lang="en-US" sz="850" dirty="0"/>
           </a:p>
           <a:p>
             <a:pPr indent="0" marL="0">
@@ -6826,7 +6543,7 @@
               <a:buNone/>
             </a:pPr>
             <a:r>
-              <a:rPr lang="en-US" sz="900" dirty="0">
+              <a:rPr lang="en-US" sz="850" dirty="0">
                 <a:solidFill>
                   <a:srgbClr val="EDE4D7"/>
                 </a:solidFill>
@@ -6836,7 +6553,7 @@
               </a:rPr>
               <a:t>  #1  How to remember my set intention for the day?</a:t>
             </a:r>
-            <a:endParaRPr lang="en-US" sz="900" dirty="0"/>
+            <a:endParaRPr lang="en-US" sz="850" dirty="0"/>
           </a:p>
           <a:p>
             <a:pPr indent="0" marL="0">
@@ -6846,7 +6563,7 @@
               <a:buNone/>
             </a:pPr>
             <a:r>
-              <a:rPr lang="en-US" sz="900" dirty="0">
+              <a:rPr lang="en-US" sz="850" dirty="0">
                 <a:solidFill>
                   <a:srgbClr val="EDE4D7"/>
                 </a:solidFill>
@@ -6854,9 +6571,9 @@
                 <a:ea typeface="Courier New" pitchFamily="34" charset="-122"/>
                 <a:cs typeface="Courier New" pitchFamily="34" charset="-120"/>
               </a:rPr>
-              <a:t>      https://www.reddit.com/r/selfimprovement/comments/1llqrl4/…</a:t>
-            </a:r>
-            <a:endParaRPr lang="en-US" sz="900" dirty="0"/>
+              <a:t>      https://www.reddit.com/r/selfimprovement/comments/1llqrl4/how_to_remember_my_set_intention_for_the_day/</a:t>
+            </a:r>
+            <a:endParaRPr lang="en-US" sz="850" dirty="0"/>
           </a:p>
           <a:p>
             <a:pPr indent="0" marL="0">
@@ -6866,7 +6583,7 @@
               <a:buNone/>
             </a:pPr>
             <a:r>
-              <a:rPr lang="en-US" sz="900" dirty="0">
+              <a:rPr lang="en-US" sz="850" dirty="0">
                 <a:solidFill>
                   <a:srgbClr val="EDE4D7"/>
                 </a:solidFill>
@@ -6874,9 +6591,9 @@
                 <a:ea typeface="Courier New" pitchFamily="34" charset="-122"/>
                 <a:cs typeface="Courier New" pitchFamily="34" charset="-120"/>
               </a:rPr>
-              <a:t>      “My morning yoga includes setting an intention for the day … 23 minutes later I'm in the thick of …”</a:t>
-            </a:r>
-            <a:endParaRPr lang="en-US" sz="900" dirty="0"/>
+              <a:t>      “My morning yoga includes setting an intention for the day (a one-word mantra, or guiding</a:t>
+            </a:r>
+            <a:endParaRPr lang="en-US" sz="850" dirty="0"/>
           </a:p>
           <a:p>
             <a:pPr indent="0" marL="0">
@@ -6886,7 +6603,7 @@
               <a:buNone/>
             </a:pPr>
             <a:r>
-              <a:rPr lang="en-US" sz="900" dirty="0">
+              <a:rPr lang="en-US" sz="850" dirty="0">
                 <a:solidFill>
                   <a:srgbClr val="EDE4D7"/>
                 </a:solidFill>
@@ -6894,9 +6611,9 @@
                 <a:ea typeface="Courier New" pitchFamily="34" charset="-122"/>
                 <a:cs typeface="Courier New" pitchFamily="34" charset="-120"/>
               </a:rPr>
-              <a:t>  #2  The power of setting intentions &amp; how to set mindful ones — calm.com</a:t>
-            </a:r>
-            <a:endParaRPr lang="en-US" sz="900" dirty="0"/>
+              <a:t>       principle, if you will). 23 minutes later I'm in the thick of ...…”</a:t>
+            </a:r>
+            <a:endParaRPr lang="en-US" sz="850" dirty="0"/>
           </a:p>
           <a:p>
             <a:pPr indent="0" marL="0">
@@ -6906,7 +6623,7 @@
               <a:buNone/>
             </a:pPr>
             <a:r>
-              <a:rPr lang="en-US" sz="900" dirty="0">
+              <a:rPr lang="en-US" sz="850" dirty="0">
                 <a:solidFill>
                   <a:srgbClr val="EDE4D7"/>
                 </a:solidFill>
@@ -6914,9 +6631,58 @@
                 <a:ea typeface="Courier New" pitchFamily="34" charset="-122"/>
                 <a:cs typeface="Courier New" pitchFamily="34" charset="-120"/>
               </a:rPr>
-              <a:t>  #3  How do I remember my intention throughout the day? — getstillmind.com</a:t>
-            </a:r>
-            <a:endParaRPr lang="en-US" sz="900" dirty="0"/>
+              <a:t>  #2  How do I remember my intention throughout the day? - StillMind</a:t>
+            </a:r>
+            <a:endParaRPr lang="en-US" sz="850" dirty="0"/>
+          </a:p>
+          <a:p>
+            <a:pPr indent="0" marL="0">
+              <a:lnSpc>
+                <a:spcPct val="115000"/>
+              </a:lnSpc>
+              <a:buNone/>
+            </a:pPr>
+            <a:r>
+              <a:rPr lang="en-US" sz="850" dirty="0">
+                <a:solidFill>
+                  <a:srgbClr val="EDE4D7"/>
+                </a:solidFill>
+                <a:latin typeface="Courier New" pitchFamily="34" charset="0"/>
+                <a:ea typeface="Courier New" pitchFamily="34" charset="-122"/>
+                <a:cs typeface="Courier New" pitchFamily="34" charset="-120"/>
+              </a:rPr>
+              <a:t>  #3  The power of setting intentions &amp; how to set mindful ones — calm.com</a:t>
+            </a:r>
+            <a:endParaRPr lang="en-US" sz="850" dirty="0"/>
+          </a:p>
+          <a:p>
+            <a:pPr indent="0" marL="0">
+              <a:lnSpc>
+                <a:spcPct val="115000"/>
+              </a:lnSpc>
+              <a:buNone/>
+            </a:pPr>
+            <a:endParaRPr lang="en-US" sz="850" dirty="0"/>
+          </a:p>
+          <a:p>
+            <a:pPr indent="0" marL="0">
+              <a:lnSpc>
+                <a:spcPct val="115000"/>
+              </a:lnSpc>
+              <a:buNone/>
+            </a:pPr>
+            <a:r>
+              <a:rPr lang="en-US" sz="850" dirty="0">
+                <a:solidFill>
+                  <a:srgbClr val="EDE4D7"/>
+                </a:solidFill>
+                <a:latin typeface="Courier New" pitchFamily="34" charset="0"/>
+                <a:ea typeface="Courier New" pitchFamily="34" charset="-122"/>
+                <a:cs typeface="Courier New" pitchFamily="34" charset="-120"/>
+              </a:rPr>
+              <a:t>  people also ask → How do I set my intention for the day? · What are my intentions for the day?</a:t>
+            </a:r>
+            <a:endParaRPr lang="en-US" sz="850" dirty="0"/>
           </a:p>
         </p:txBody>
       </p:sp>
@@ -6928,8 +6694,8 @@
         </p:nvSpPr>
         <p:spPr>
           <a:xfrm>
-            <a:off x="548640" y="4114800"/>
-            <a:ext cx="8046720" cy="548640"/>
+            <a:off x="548640" y="4206240"/>
+            <a:ext cx="8046720" cy="502920"/>
           </a:xfrm>
           <a:prstGeom prst="rect">
             <a:avLst/>
@@ -6999,8 +6765,8 @@
         </p:nvSpPr>
         <p:spPr>
           <a:xfrm>
-            <a:off x="6766560" y="457200"/>
-            <a:ext cx="1828800" cy="274320"/>
+            <a:off x="5852160" y="457200"/>
+            <a:ext cx="2743200" cy="274320"/>
           </a:xfrm>
           <a:prstGeom prst="rect">
             <a:avLst/>
@@ -7024,7 +6790,7 @@
                 <a:ea typeface="Courier New" pitchFamily="34" charset="-122"/>
                 <a:cs typeface="Courier New" pitchFamily="34" charset="-120"/>
               </a:rPr>
-              <a:t>OUTPUT</a:t>
+              <a:t>THE ROOM DOES IT</a:t>
             </a:r>
             <a:endParaRPr lang="en-US" sz="900" dirty="0"/>
           </a:p>
@@ -7063,7 +6829,7 @@
                 <a:ea typeface="Courier New" pitchFamily="34" charset="-122"/>
                 <a:cs typeface="Courier New" pitchFamily="34" charset="-120"/>
               </a:rPr>
-              <a:t>OUTPUT · RESEARCH.JSON → ONE SELF-CONTAINED PAGE</a:t>
+              <a:t>OUTPUT · RESEARCH.JSON → ONE SELF-CONTAINED PAGE → ONE REAL MOMENT</a:t>
             </a:r>
             <a:endParaRPr lang="en-US" sz="900" dirty="0"/>
           </a:p>
@@ -7102,7 +6868,7 @@
                 <a:ea typeface="Cambria" pitchFamily="34" charset="-122"/>
                 <a:cs typeface="Cambria" pitchFamily="34" charset="-120"/>
               </a:rPr>
-              <a:t>The research object is injected straight into the landing page. The proof is the pitch.</a:t>
+              <a:t>The research object is injected straight into the page. Then the page asks you for one sentence.</a:t>
             </a:r>
             <a:endParaRPr lang="en-US" sz="2400" dirty="0"/>
           </a:p>
@@ -7189,7 +6955,7 @@
                 <a:ea typeface="Courier New" pitchFamily="34" charset="-122"/>
                 <a:cs typeface="Courier New" pitchFamily="34" charset="-120"/>
               </a:rPr>
-              <a:t>  "quotes":  [ { text, src } ×5 ],        // verbatim from corpus</a:t>
+              <a:t>  "quotes":  [ { text, src } ×5 ],     // verbatim</a:t>
             </a:r>
             <a:endParaRPr lang="en-US" sz="850" dirty="0"/>
           </a:p>
@@ -7209,7 +6975,7 @@
                 <a:ea typeface="Courier New" pitchFamily="34" charset="-122"/>
                 <a:cs typeface="Courier New" pitchFamily="34" charset="-120"/>
               </a:rPr>
-              <a:t>  "clusters":[ { pct, label, of } ×3 ],    // computed, never typed</a:t>
+              <a:t>  "clusters":[ { pct, label, of } ×3 ], // computed</a:t>
             </a:r>
             <a:endParaRPr lang="en-US" sz="850" dirty="0"/>
           </a:p>
@@ -7229,7 +6995,7 @@
                 <a:ea typeface="Courier New" pitchFamily="34" charset="-122"/>
                 <a:cs typeface="Courier New" pitchFamily="34" charset="-120"/>
               </a:rPr>
-              <a:t>  "hypothesis": { H1, H2, verdict: { H1, H2, pushback } },</a:t>
+              <a:t>  "hypothesis": { H1, H2,</a:t>
             </a:r>
             <a:endParaRPr lang="en-US" sz="850" dirty="0"/>
           </a:p>
@@ -7249,7 +7015,7 @@
                 <a:ea typeface="Courier New" pitchFamily="34" charset="-122"/>
                 <a:cs typeface="Courier New" pitchFamily="34" charset="-120"/>
               </a:rPr>
-              <a:t>  "counter_evidence": [ … ],</a:t>
+              <a:t>                  verdict: { H1, H2, pushback } },</a:t>
             </a:r>
             <a:endParaRPr lang="en-US" sz="850" dirty="0"/>
           </a:p>
@@ -7269,7 +7035,47 @@
                 <a:ea typeface="Courier New" pitchFamily="34" charset="-122"/>
                 <a:cs typeface="Courier New" pitchFamily="34" charset="-120"/>
               </a:rPr>
+              <a:t>  "counter_evidence": [ … ],</a:t>
+            </a:r>
+            <a:endParaRPr lang="en-US" sz="850" dirty="0"/>
+          </a:p>
+          <a:p>
+            <a:pPr indent="0" marL="0">
+              <a:lnSpc>
+                <a:spcPct val="115000"/>
+              </a:lnSpc>
+              <a:buNone/>
+            </a:pPr>
+            <a:r>
+              <a:rPr lang="en-US" sz="850" dirty="0">
+                <a:solidFill>
+                  <a:srgbClr val="EDE4D7"/>
+                </a:solidFill>
+                <a:latin typeface="Courier New" pitchFamily="34" charset="0"/>
+                <a:ea typeface="Courier New" pitchFamily="34" charset="-122"/>
+                <a:cs typeface="Courier New" pitchFamily="34" charset="-120"/>
+              </a:rPr>
               <a:t>  "meta": { corpus, method, attribution } }</a:t>
+            </a:r>
+            <a:endParaRPr lang="en-US" sz="850" dirty="0"/>
+          </a:p>
+          <a:p>
+            <a:pPr indent="0" marL="0">
+              <a:lnSpc>
+                <a:spcPct val="115000"/>
+              </a:lnSpc>
+              <a:buNone/>
+            </a:pPr>
+            <a:r>
+              <a:rPr lang="en-US" sz="850" dirty="0">
+                <a:solidFill>
+                  <a:srgbClr val="EDE4D7"/>
+                </a:solidFill>
+                <a:latin typeface="Courier New" pitchFamily="34" charset="0"/>
+                <a:ea typeface="Courier New" pitchFamily="34" charset="-122"/>
+                <a:cs typeface="Courier New" pitchFamily="34" charset="-120"/>
+              </a:rPr>
+              <a:t>// verify.js checks all of it before a republish</a:t>
             </a:r>
             <a:endParaRPr lang="en-US" sz="850" dirty="0"/>
           </a:p>
@@ -7397,7 +7203,7 @@
                 <a:ea typeface="Cambria" pitchFamily="34" charset="-122"/>
                 <a:cs typeface="Cambria" pitchFamily="34" charset="-120"/>
               </a:rPr>
-              <a:t>The hypothesis</a:t>
+              <a:t>The bet</a:t>
             </a:r>
             <a:endParaRPr lang="en-US" sz="1200" dirty="0"/>
           </a:p>
@@ -7461,7 +7267,7 @@
                 <a:ea typeface="Cambria" pitchFamily="34" charset="-122"/>
                 <a:cs typeface="Cambria" pitchFamily="34" charset="-120"/>
               </a:rPr>
-              <a:t>The ask</a:t>
+              <a:t>Prove me wrong · three calls</a:t>
             </a:r>
             <a:endParaRPr lang="en-US" sz="1200" dirty="0"/>
           </a:p>
@@ -7589,7 +7395,7 @@
                 <a:ea typeface="Cambria" pitchFamily="34" charset="-122"/>
                 <a:cs typeface="Cambria" pitchFamily="34" charset="-120"/>
               </a:rPr>
-              <a:t>The way</a:t>
+              <a:t>The sharpened product</a:t>
             </a:r>
             <a:endParaRPr lang="en-US" sz="1200" dirty="0"/>
           </a:p>
@@ -7653,7 +7459,7 @@
                 <a:ea typeface="Cambria" pitchFamily="34" charset="-122"/>
                 <a:cs typeface="Cambria" pitchFamily="34" charset="-120"/>
               </a:rPr>
-              <a:t>One real Moment</a:t>
+              <a:t>One sentence · six breaths · choose again</a:t>
             </a:r>
             <a:endParaRPr lang="en-US" sz="1200" dirty="0"/>
           </a:p>
@@ -7684,17 +7490,17 @@
               <a:buNone/>
             </a:pPr>
             <a:r>
-              <a:rPr lang="en-US" sz="1150" dirty="0">
-                <a:solidFill>
-                  <a:srgbClr val="93867A"/>
-                </a:solidFill>
-                <a:latin typeface="Calibri" pitchFamily="34" charset="0"/>
-                <a:ea typeface="Calibri" pitchFamily="34" charset="-122"/>
-                <a:cs typeface="Calibri" pitchFamily="34" charset="-120"/>
-              </a:rPr>
-              <a:t>Every quote and number on the page is this JSON. `node src/run.js --inject-only` swaps the blob; nothing else changes. When the story ends, the room writes one sentence and takes one minute.</a:t>
-            </a:r>
-            <a:endParaRPr lang="en-US" sz="1150" dirty="0"/>
+              <a:rPr lang="en-US" sz="1300" i="1" dirty="0">
+                <a:solidFill>
+                  <a:srgbClr val="D9954A"/>
+                </a:solidFill>
+                <a:latin typeface="Cambria" pitchFamily="34" charset="0"/>
+                <a:ea typeface="Cambria" pitchFamily="34" charset="-122"/>
+                <a:cs typeface="Cambria" pitchFamily="34" charset="-120"/>
+              </a:rPr>
+              <a:t>Write one sentence about how you want to move through tonight. Sixty seconds. Six breaths. Halfway through, the sentence comes back. Then: now choose again.</a:t>
+            </a:r>
+            <a:endParaRPr lang="en-US" sz="1300" dirty="0"/>
           </a:p>
         </p:txBody>
       </p:sp>

</xml_diff>